<commit_message>
Pitch script: cut the notes to fit 5:00 at speaking pace
Co-Authored-By: Claude Opus 5.5 (1M context) <noreply@anthropic.com>
</commit_message>
<xml_diff>
--- a/docs/pitch/overwatering.pptx
+++ b/docs/pitch/overwatering.pptx
@@ -527,17 +527,12 @@
           <a:lstStyle/>
           <a:p>
             <a:r>
-              <a:t>[0:00–0:10]</a:t>
-            </a:r>
-          </a:p>
-          <a:p>
-            <a:r>
-              <a:t>Hi, I'm Adam Fortuna. This is Overwater.ing, with a question mark, because that's the question</a:t>
-            </a:r>
-          </a:p>
-          <a:p>
-            <a:r>
-              <a:t>every Utah yard should be asking.</a:t>
+              <a:t>[0:00–0:05]</a:t>
+            </a:r>
+          </a:p>
+          <a:p>
+            <a:r>
+              <a:t>Hi, I'm Adam Fortuna. This is Overwater.ing. Question mark.</a:t>
             </a:r>
           </a:p>
         </p:txBody>
@@ -607,42 +602,27 @@
           <a:lstStyle/>
           <a:p>
             <a:r>
-              <a:t>[3:55–4:20]</a:t>
-            </a:r>
-          </a:p>
-          <a:p>
-            <a:r>
-              <a:t>Who pays. First, water districts: they already spend money on rebate outreach. We hand them a</a:t>
-            </a:r>
-          </a:p>
-          <a:p>
-            <a:r>
-              <a:t>ranked list of the lots with the most lawn to replace and the biggest savings, and we prove it</a:t>
-            </a:r>
-          </a:p>
-          <a:p>
-            <a:r>
-              <a:t>with a metered before-and-after pilot.</a:t>
-            </a:r>
-          </a:p>
-          <a:p>
-            <a:r>
-              <a:t>Second, data centers. Under the executive order they need offsets, and hyperscalers already fund</a:t>
-            </a:r>
-          </a:p>
-          <a:p>
-            <a:r>
-              <a:t>"water positive" projects. We're the measurement and verification layer that turns that money</a:t>
-            </a:r>
-          </a:p>
-          <a:p>
-            <a:r>
-              <a:t>into verified acre-feet.</a:t>
-            </a:r>
-          </a:p>
-          <a:p>
-            <a:r>
-              <a:t>Third, homeowners: they're the distribution and the ground truth.</a:t>
+              <a:t>[3:52–4:15]</a:t>
+            </a:r>
+          </a:p>
+          <a:p>
+            <a:r>
+              <a:t>Who pays? Water districts first: they already spend on rebate outreach, and we hand them the</a:t>
+            </a:r>
+          </a:p>
+          <a:p>
+            <a:r>
+              <a:t>lots with the most to save, proven with a metered pilot. Then data centers, which now need</a:t>
+            </a:r>
+          </a:p>
+          <a:p>
+            <a:r>
+              <a:t>offsets: we're the verification layer that turns their money into real acre-feet. Homeowners are</a:t>
+            </a:r>
+          </a:p>
+          <a:p>
+            <a:r>
+              <a:t>the distribution and the ground truth.</a:t>
             </a:r>
           </a:p>
         </p:txBody>
@@ -712,32 +692,22 @@
           <a:lstStyle/>
           <a:p>
             <a:r>
-              <a:t>[4:20–4:42]</a:t>
-            </a:r>
-          </a:p>
-          <a:p>
-            <a:r>
-              <a:t>Ten thousand dollars gets us statewide: every Utah lot precomputed and hosted, a trained lawn</a:t>
-            </a:r>
-          </a:p>
-          <a:p>
-            <a:r>
-              <a:t>model built on our users' corrections and the state's own Greenspace data, a district pilot</a:t>
-            </a:r>
-          </a:p>
-          <a:p>
-            <a:r>
-              <a:t>with real meter data, and partner access to the big smart-controller platforms.</a:t>
-            </a:r>
-          </a:p>
-          <a:p>
-            <a:r>
-              <a:t>What's already moving: it's live, and the state's GIS team shared their Greenspace model with</a:t>
-            </a:r>
-          </a:p>
-          <a:p>
-            <a:r>
-              <a:t>us, which is how we validated it.</a:t>
+              <a:t>[4:15–4:40]</a:t>
+            </a:r>
+          </a:p>
+          <a:p>
+            <a:r>
+              <a:t>Ten thousand dollars takes it statewide: every Utah lot precomputed, a trained lawn model, a</a:t>
+            </a:r>
+          </a:p>
+          <a:p>
+            <a:r>
+              <a:t>district pilot with real meter data, and integrations with the big smart controllers. It's</a:t>
+            </a:r>
+          </a:p>
+          <a:p>
+            <a:r>
+              <a:t>already live, and the state's GIS team shared their data with us to validate it.</a:t>
             </a:r>
           </a:p>
           <a:p>
@@ -812,22 +782,22 @@
           <a:lstStyle/>
           <a:p>
             <a:r>
-              <a:t>[4:42–5:00]</a:t>
-            </a:r>
-          </a:p>
-          <a:p>
-            <a:r>
-              <a:t>So here's the ask: ten thousand dollars to go statewide and run the first district pilot, and</a:t>
-            </a:r>
-          </a:p>
-          <a:p>
-            <a:r>
-              <a:t>introductions to a water district's conservation team and a data-center sustainability lead.</a:t>
-            </a:r>
-          </a:p>
-          <a:p>
-            <a:r>
-              <a:t>And one more thing: take out your phone and type your address at overwater.ing. Thank you.</a:t>
+              <a:t>[4:40–5:00]</a:t>
+            </a:r>
+          </a:p>
+          <a:p>
+            <a:r>
+              <a:t>So: ten thousand dollars to go statewide and run a district pilot, and introductions to a water</a:t>
+            </a:r>
+          </a:p>
+          <a:p>
+            <a:r>
+              <a:t>district and a data-center sustainability team. And right now, take out your phone and type</a:t>
+            </a:r>
+          </a:p>
+          <a:p>
+            <a:r>
+              <a:t>your address at overwater.ing. Thank you.</a:t>
             </a:r>
           </a:p>
         </p:txBody>
@@ -1422,37 +1392,27 @@
           <a:lstStyle/>
           <a:p>
             <a:r>
-              <a:t>[0:10–0:30]</a:t>
-            </a:r>
-          </a:p>
-          <a:p>
-            <a:r>
-              <a:t>Back in July I went to Perspectives Over Pints at Fisher Brewing. The Yard Farmer gave the talk,</a:t>
-            </a:r>
-          </a:p>
-          <a:p>
-            <a:r>
-              <a:t>about where Utah's water goes. Most of it goes on grass, and the state will actually pay you to</a:t>
-            </a:r>
-          </a:p>
-          <a:p>
-            <a:r>
-              <a:t>rip the grass out and put in native plants.</a:t>
-            </a:r>
-          </a:p>
-          <a:p>
-            <a:r>
-              <a:t>I was hooked enough that we booked our own yard consult with them for November.</a:t>
-            </a:r>
-          </a:p>
-          <a:p>
-            <a:r>
-              <a:t>But my first question was simple: how much lawn do I have, and how much water does it really</a:t>
-            </a:r>
-          </a:p>
-          <a:p>
-            <a:r>
-              <a:t>need? Nobody could tell me. Not for my lot, and not for any lot in Utah.</a:t>
+              <a:t>[0:05–0:30]</a:t>
+            </a:r>
+          </a:p>
+          <a:p>
+            <a:r>
+              <a:t>In July I went to Perspectives Over Pints at Fisher Brewing, and The Yard Farmer gave the talk.</a:t>
+            </a:r>
+          </a:p>
+          <a:p>
+            <a:r>
+              <a:t>Most of Utah's water goes on grass, and the state will pay you to replace it. We booked our own</a:t>
+            </a:r>
+          </a:p>
+          <a:p>
+            <a:r>
+              <a:t>yard consult for November. But my first question was: how much lawn do I have, and what does it</a:t>
+            </a:r>
+          </a:p>
+          <a:p>
+            <a:r>
+              <a:t>really need? Nobody could tell me.</a:t>
             </a:r>
           </a:p>
         </p:txBody>
@@ -2047,27 +2007,17 @@
           <a:lstStyle/>
           <a:p>
             <a:r>
-              <a:t>[0:30–0:45]</a:t>
-            </a:r>
-          </a:p>
-          <a:p>
-            <a:r>
-              <a:t>Here's the problem in two numbers. About 60 percent of Utah's city water goes outdoors, mostly on</a:t>
-            </a:r>
-          </a:p>
-          <a:p>
-            <a:r>
-              <a:t>grass. And because indoor water goes back to the treatment plant and the river, outdoor watering</a:t>
-            </a:r>
-          </a:p>
-          <a:p>
-            <a:r>
-              <a:t>is 96 percent of what our cities actually use up. That's half a million acre-feet a year on</a:t>
-            </a:r>
-          </a:p>
-          <a:p>
-            <a:r>
-              <a:t>residential yards alone.</a:t>
+              <a:t>[0:30–0:42]</a:t>
+            </a:r>
+          </a:p>
+          <a:p>
+            <a:r>
+              <a:t>About 60 percent of Utah's city water goes outdoors. And since indoor water flows back to the</a:t>
+            </a:r>
+          </a:p>
+          <a:p>
+            <a:r>
+              <a:t>river, outdoor watering is 96 percent of what our cities use up.</a:t>
             </a:r>
           </a:p>
         </p:txBody>
@@ -2137,37 +2087,22 @@
           <a:lstStyle/>
           <a:p>
             <a:r>
-              <a:t>[0:45–1:00]</a:t>
-            </a:r>
-          </a:p>
-          <a:p>
-            <a:r>
-              <a:t>Meanwhile Great Salt Lake sits at 4,190 feet, eight feet below where the healthy range starts,</a:t>
-            </a:r>
-          </a:p>
-          <a:p>
-            <a:r>
-              <a:t>and the state's plan says it needs up to a million more acre-feet a year.</a:t>
-            </a:r>
-          </a:p>
-          <a:p>
-            <a:r>
-              <a:t>And now the AI build-out: 48 data centers already, and since May the Governor's executive order</a:t>
-            </a:r>
-          </a:p>
-          <a:p>
-            <a:r>
-              <a:t>says new ones can't add to the lake's depletion. One proposed campus in Box Elder County alone is</a:t>
-            </a:r>
-          </a:p>
-          <a:p>
-            <a:r>
-              <a:t>about a thousand acre-feet a year. That water has to come from somewhere, and the biggest place</a:t>
-            </a:r>
-          </a:p>
-          <a:p>
-            <a:r>
-              <a:t>to find it is the yard.</a:t>
+              <a:t>[0:42–1:00]</a:t>
+            </a:r>
+          </a:p>
+          <a:p>
+            <a:r>
+              <a:t>Great Salt Lake is eight feet below healthy. Meanwhile Utah has 48 data centers, and since May,</a:t>
+            </a:r>
+          </a:p>
+          <a:p>
+            <a:r>
+              <a:t>new ones can't add to the lake's depletion. One proposed campus is about a thousand acre-feet a</a:t>
+            </a:r>
+          </a:p>
+          <a:p>
+            <a:r>
+              <a:t>year. That water has to come from somewhere. The biggest place to find it is the yard.</a:t>
             </a:r>
           </a:p>
         </p:txBody>
@@ -2242,17 +2177,12 @@
           </a:p>
           <a:p>
             <a:r>
-              <a:t>The state already pays people to fix this: up to three dollars a square foot, seven million</a:t>
-            </a:r>
-          </a:p>
-          <a:p>
-            <a:r>
-              <a:t>dollars last year. About half of us overwater. But nobody knows, lot by lot, how much lawn</a:t>
-            </a:r>
-          </a:p>
-          <a:p>
-            <a:r>
-              <a:t>there is or what it actually needs. So I built it.</a:t>
+              <a:t>The state already pays up to three dollars a square foot to replace grass. But nobody knows, lot</a:t>
+            </a:r>
+          </a:p>
+          <a:p>
+            <a:r>
+              <a:t>by lot, how much lawn there is. So I built it.</a:t>
             </a:r>
           </a:p>
         </p:txBody>
@@ -2477,17 +2407,12 @@
           </a:p>
           <a:p>
             <a:r>
-              <a:t>This is live today. Twelve thousand eight hundred lots precomputed, any address in all 29</a:t>
-            </a:r>
-          </a:p>
-          <a:p>
-            <a:r>
-              <a:t>counties measured on demand, and when we checked against the state's own Greenspace model, lot</a:t>
-            </a:r>
-          </a:p>
-          <a:p>
-            <a:r>
-              <a:t>by lot, we track it with a correlation of 0.77.</a:t>
+              <a:t>It's live: twelve thousand eight hundred lots precomputed, any address in all 29 counties</a:t>
+            </a:r>
+          </a:p>
+          <a:p>
+            <a:r>
+              <a:t>measured on demand, and it tracks the state's own Greenspace model lot by lot.</a:t>
             </a:r>
           </a:p>
         </p:txBody>
@@ -2562,47 +2487,27 @@
           </a:p>
           <a:p>
             <a:r>
-              <a:t>Under the hood: USDA's 60-centimeter, four-band aerial imagery, haze-corrected NDVI to find what's</a:t>
-            </a:r>
-          </a:p>
-          <a:p>
-            <a:r>
-              <a:t>growing, Meta's LiDAR-derived tree heights read straight out of cloud-optimized GeoTIFFs to pull</a:t>
-            </a:r>
-          </a:p>
-          <a:p>
-            <a:r>
-              <a:t>out trees, and building footprints. That gives turf polygons for each lot, computed in the</a:t>
-            </a:r>
-          </a:p>
-          <a:p>
-            <a:r>
-              <a:t>browser and on Cloudflare's edge.</a:t>
-            </a:r>
-          </a:p>
-          <a:p>
-            <a:r>
-              <a:t>Then gridMET reference evapotranspiration and the FAO-56 method give the water the lawn needs,</a:t>
-            </a:r>
-          </a:p>
-          <a:p>
-            <a:r>
-              <a:t>tied to the state's weekly watering guide, which becomes a schedule.</a:t>
-            </a:r>
-          </a:p>
-          <a:p>
-            <a:r>
-              <a:t>And we close the loop: an open API and a calendar that a sprinkler controller follows, OpenSprinkler</a:t>
-            </a:r>
-          </a:p>
-          <a:p>
-            <a:r>
-              <a:t>today and Rachio next. Claude reads water bills so we can measure the before and after, and every</a:t>
-            </a:r>
-          </a:p>
-          <a:p>
-            <a:r>
-              <a:t>correction someone makes becomes a training label for a real segmentation model.</a:t>
+              <a:t>Under the hood: 60-centimeter aerial imagery, haze-corrected NDVI to find what's growing, Meta's</a:t>
+            </a:r>
+          </a:p>
+          <a:p>
+            <a:r>
+              <a:t>LiDAR tree heights to pull out trees, and building footprints, all computed in the browser and</a:t>
+            </a:r>
+          </a:p>
+          <a:p>
+            <a:r>
+              <a:t>on Cloudflare's edge. Then local weather and the FAO-56 method give what the lawn needs, tied to</a:t>
+            </a:r>
+          </a:p>
+          <a:p>
+            <a:r>
+              <a:t>the state's weekly guide. And we close the loop: a calendar and API the sprinkler controller</a:t>
+            </a:r>
+          </a:p>
+          <a:p>
+            <a:r>
+              <a:t>follows. Claude reads bills to measure the result, and every correction trains our model.</a:t>
             </a:r>
           </a:p>
         </p:txBody>
@@ -2672,27 +2577,17 @@
           <a:lstStyle/>
           <a:p>
             <a:r>
-              <a:t>[3:40–3:55]</a:t>
-            </a:r>
-          </a:p>
-          <a:p>
-            <a:r>
-              <a:t>Water is energy: about 650 kilowatt-hours to treat and deliver every acre-foot. Per home that's</a:t>
-            </a:r>
-          </a:p>
-          <a:p>
-            <a:r>
-              <a:t>small, so we pitch it at scale: two tenths of one percent of Utah's residential outdoor water is</a:t>
-            </a:r>
-          </a:p>
-          <a:p>
-            <a:r>
-              <a:t>one entire data-center campus. Verified yard savings are how Utah grows AI without draining</a:t>
-            </a:r>
-          </a:p>
-          <a:p>
-            <a:r>
-              <a:t>the lake.</a:t>
+              <a:t>[3:40–3:52]</a:t>
+            </a:r>
+          </a:p>
+          <a:p>
+            <a:r>
+              <a:t>Water is energy: about 650 kilowatt-hours per acre-foot. And two tenths of a percent of Utah's</a:t>
+            </a:r>
+          </a:p>
+          <a:p>
+            <a:r>
+              <a:t>yard water equals one entire data-center campus.</a:t>
             </a:r>
           </a:p>
         </p:txBody>

</xml_diff>

<commit_message>
Pitch deck: real calendar, OpenSprinkler, /impact and live-lot slides; demo path for the shipped features
- Bill step now shows the 119,272 gal/yr gap (new sample bill)
- Controller slide: OpenSprinkler demo firmware switched off this week, on for July
- Slide 9 uses the /impact numbers (372 AF in our neighborhoods, ~100x a data center statewide)
- demo.md: terminal commands for the controller, USDA DNSSEC caveat for live lots

Co-Authored-By: Claude Opus 5.5 (1M context) <noreply@anthropic.com>
</commit_message>
<xml_diff>
--- a/docs/pitch/overwatering.pptx
+++ b/docs/pitch/overwatering.pptx
@@ -31,6 +31,7 @@
     <p:sldId id="279" r:id="rId31"/>
     <p:sldId id="280" r:id="rId32"/>
     <p:sldId id="281" r:id="rId33"/>
+    <p:sldId id="282" r:id="rId34"/>
   </p:sldIdLst>
   <p:sldSz cx="12191695" cy="6858000" type="screen4x3"/>
   <p:notesSz cx="6858000" cy="9144000"/>
@@ -1097,7 +1098,7 @@
           </a:p>
           <a:p>
             <a:r>
-              <a:t>Upload scripts/fixtures/sample_slc_bill.png. Claude reads twelve months; the page compares outdoor use to the lawn's need.</a:t>
+              <a:t>Upload the sample bill. Claude reads twelve months; the page shows the overwatering gap and the one change to make.</a:t>
             </a:r>
           </a:p>
         </p:txBody>
@@ -1317,12 +1318,12 @@
           <a:lstStyle/>
           <a:p>
             <a:r>
-              <a:t>[demo 2:15]</a:t>
-            </a:r>
-          </a:p>
-          <a:p>
-            <a:r>
-              <a:t>PLACEHOLDER until the calendar ships: subscribe from the watering plan; the calendar follows the state's Weekly Lawn Watering Guide.</a:t>
+              <a:t>[demo 2:10]</a:t>
+            </a:r>
+          </a:p>
+          <a:p>
+            <a:r>
+              <a:t>Subscribe once; each watering day shows up at 5 a.m. with run times, and skip weeks clear themselves.</a:t>
             </a:r>
           </a:p>
         </p:txBody>
@@ -1482,12 +1483,17 @@
           <a:lstStyle/>
           <a:p>
             <a:r>
-              <a:t>[demo 2:25]</a:t>
-            </a:r>
-          </a:p>
-          <a:p>
-            <a:r>
-              <a:t>PLACEHOLDER until the OpenSprinkler connector ships: the guide says No Watering this week, so the controller pauses itself; switch to a July week and the minutes change.</a:t>
+              <a:t>[demo 2:20]</a:t>
+            </a:r>
+          </a:p>
+          <a:p>
+            <a:r>
+              <a:t>OpenSprinkler firmware in demo mode, set by our connector. This week the guide says no watering, so the program</a:t>
+            </a:r>
+          </a:p>
+          <a:p>
+            <a:r>
+              <a:t>is switched off. Preview a July week and it's Monday, Wednesday, Friday at 5 a.m., four 7-minute cycles per zone.</a:t>
             </a:r>
           </a:p>
         </p:txBody>
@@ -1557,12 +1563,12 @@
           <a:lstStyle/>
           <a:p>
             <a:r>
-              <a:t>[demo 2:35]</a:t>
-            </a:r>
-          </a:p>
-          <a:p>
-            <a:r>
-              <a:t>About 145,000 gallons a year saved if this lawn becomes water-wise landscape.</a:t>
+              <a:t>[demo 2:30]</a:t>
+            </a:r>
+          </a:p>
+          <a:p>
+            <a:r>
+              <a:t>Same schedule as plain JSON, no key, no address in the URL.</a:t>
             </a:r>
           </a:p>
         </p:txBody>
@@ -1632,12 +1638,12 @@
           <a:lstStyle/>
           <a:p>
             <a:r>
-              <a:t>[demo 2:45]</a:t>
-            </a:r>
-          </a:p>
-          <a:p>
-            <a:r>
-              <a:t>Up to $33,423 from Central Utah Water Conservancy District, Salt Lake City, plus the $100 smart controller rebate.</a:t>
+              <a:t>[demo 2:40]</a:t>
+            </a:r>
+          </a:p>
+          <a:p>
+            <a:r>
+              <a:t>About 145,000 gallons a year saved if this lawn becomes water-wise landscape.</a:t>
             </a:r>
           </a:p>
         </p:txBody>
@@ -1707,12 +1713,12 @@
           <a:lstStyle/>
           <a:p>
             <a:r>
-              <a:t>[demo 2:55]</a:t>
-            </a:r>
-          </a:p>
-          <a:p>
-            <a:r>
-              <a:t>Any Utah address is measured live in the browser in seconds.</a:t>
+              <a:t>[demo 2:48]</a:t>
+            </a:r>
+          </a:p>
+          <a:p>
+            <a:r>
+              <a:t>Up to $33,423 from Central Utah Water Conservancy District, Salt Lake City, plus the $100 smart controller rebate.</a:t>
             </a:r>
           </a:p>
         </p:txBody>
@@ -1782,12 +1788,12 @@
           <a:lstStyle/>
           <a:p>
             <a:r>
-              <a:t>[backup]</a:t>
-            </a:r>
-          </a:p>
-          <a:p>
-            <a:r>
-              <a:t>What a district sees: lawn, need, likely overwatering and savings for a whole neighborhood.</a:t>
+              <a:t>[demo 2:55]</a:t>
+            </a:r>
+          </a:p>
+          <a:p>
+            <a:r>
+              <a:t>Any Utah address is measured live in the browser in seconds.</a:t>
             </a:r>
           </a:p>
         </p:txBody>
@@ -1862,7 +1868,7 @@
           </a:p>
           <a:p>
             <a:r>
-              <a:t>PLACEHOLDER until /impact ships.</a:t>
+              <a:t>What a district sees: lawn, need, likely overwatering and savings for a whole neighborhood.</a:t>
             </a:r>
           </a:p>
         </p:txBody>
@@ -1932,6 +1938,81 @@
           <a:lstStyle/>
           <a:p>
             <a:r>
+              <a:t>[backup]</a:t>
+            </a:r>
+          </a:p>
+          <a:p>
+            <a:r>
+              <a:t>The same numbers as slide 9, live on the site.</a:t>
+            </a:r>
+          </a:p>
+        </p:txBody>
+      </p:sp>
+      <p:sp>
+        <p:nvSpPr>
+          <p:cNvPr id="4" name="Slide Number Placeholder 3"/>
+          <p:cNvSpPr>
+            <a:spLocks noGrp="1"/>
+          </p:cNvSpPr>
+          <p:nvPr>
+            <p:ph type="sldNum" idx="5" sz="quarter"/>
+          </p:nvPr>
+        </p:nvSpPr>
+        <p:spPr/>
+      </p:sp>
+    </p:spTree>
+  </p:cSld>
+  <p:clrMapOvr>
+    <a:masterClrMapping/>
+  </p:clrMapOvr>
+</p:notes>
+</file>
+
+<file path=ppt/notesSlides/notesSlide27.xml><?xml version="1.0" encoding="utf-8"?>
+<p:notes xmlns:a="http://schemas.openxmlformats.org/drawingml/2006/main" xmlns:p="http://schemas.openxmlformats.org/presentationml/2006/main" xmlns:r="http://schemas.openxmlformats.org/officeDocument/2006/relationships">
+  <p:cSld>
+    <p:spTree>
+      <p:nvGrpSpPr>
+        <p:cNvPr id="1" name=""/>
+        <p:cNvGrpSpPr/>
+        <p:nvPr/>
+      </p:nvGrpSpPr>
+      <p:grpSpPr>
+        <a:xfrm>
+          <a:off x="0" y="0"/>
+          <a:ext cx="0" cy="0"/>
+          <a:chOff x="0" y="0"/>
+          <a:chExt cx="0" cy="0"/>
+        </a:xfrm>
+      </p:grpSpPr>
+      <p:sp>
+        <p:nvSpPr>
+          <p:cNvPr id="2" name="Slide Image Placeholder 1"/>
+          <p:cNvSpPr>
+            <a:spLocks noGrp="1"/>
+          </p:cNvSpPr>
+          <p:nvPr>
+            <p:ph type="sldImg" idx="2"/>
+          </p:nvPr>
+        </p:nvSpPr>
+        <p:spPr/>
+      </p:sp>
+      <p:sp>
+        <p:nvSpPr>
+          <p:cNvPr id="3" name="Notes Placeholder 2"/>
+          <p:cNvSpPr>
+            <a:spLocks noGrp="1"/>
+          </p:cNvSpPr>
+          <p:nvPr>
+            <p:ph type="body" idx="3" sz="quarter"/>
+          </p:nvPr>
+        </p:nvSpPr>
+        <p:spPr/>
+        <p:txBody>
+          <a:bodyPr/>
+          <a:lstStyle/>
+          <a:p>
+            <a:r>
               <a:t>[reference]</a:t>
             </a:r>
           </a:p>
@@ -2287,12 +2368,12 @@
           </a:p>
           <a:p>
             <a:r>
-              <a:t>1:45 Add the bill: upload the photo. Claude reads twelve months of usage in a few seconds and</a:t>
-            </a:r>
-          </a:p>
-          <a:p>
-            <a:r>
-              <a:t>we compare outdoor use to what the lawn needs.</a:t>
+              <a:t>1:45 Add the bill: upload the photo. Claude reads twelve months in about five seconds:</a:t>
+            </a:r>
+          </a:p>
+          <a:p>
+            <a:r>
+              <a:t>119,000 gallons a year more than this lawn needs.</a:t>
             </a:r>
           </a:p>
           <a:p>
@@ -2307,22 +2388,27 @@
           </a:p>
           <a:p>
             <a:r>
-              <a:t>2:15 Subscribe to the watering calendar, and the controller picks it up. This week the state</a:t>
-            </a:r>
-          </a:p>
-          <a:p>
-            <a:r>
-              <a:t>guide says no watering, so the controller pauses itself.</a:t>
-            </a:r>
-          </a:p>
-          <a:p>
-            <a:r>
-              <a:t>2:35 Go native: the before and after, the plants, the designers to call.</a:t>
-            </a:r>
-          </a:p>
-          <a:p>
-            <a:r>
-              <a:t>2:45 The rebate: up to $33,000 here, from Central Utah Water Conservancy District, with the city</a:t>
+              <a:t>2:10 Subscribe to the calendar, or let the controller follow it. This week the state guide says</a:t>
+            </a:r>
+          </a:p>
+          <a:p>
+            <a:r>
+              <a:t>no watering, so our connector switched the OpenSprinkler program off. In July, it's Monday,</a:t>
+            </a:r>
+          </a:p>
+          <a:p>
+            <a:r>
+              <a:t>Wednesday, Friday at 5 a.m., four short cycles per zone.</a:t>
+            </a:r>
+          </a:p>
+          <a:p>
+            <a:r>
+              <a:t>2:40 Go native: the before and after, the plants, the designers to call.</a:t>
+            </a:r>
+          </a:p>
+          <a:p>
+            <a:r>
+              <a:t>2:48 The rebate: up to $33,000 here, from Central Utah Water Conservancy District, with the city</a:t>
             </a:r>
           </a:p>
           <a:p>
@@ -2332,7 +2418,12 @@
           </a:p>
           <a:p>
             <a:r>
-              <a:t>2:55 And it isn't just these neighborhoods: any address in Utah gets measured live.</a:t>
+              <a:t>2:55 (Only if the warm-up worked.) And any address in Utah gets measured live, like this one in</a:t>
+            </a:r>
+          </a:p>
+          <a:p>
+            <a:r>
+              <a:t>St. George.</a:t>
             </a:r>
           </a:p>
         </p:txBody>
@@ -2582,12 +2673,12 @@
           </a:p>
           <a:p>
             <a:r>
-              <a:t>Water is energy: about 650 kilowatt-hours per acre-foot. And two tenths of a percent of Utah's</a:t>
-            </a:r>
-          </a:p>
-          <a:p>
-            <a:r>
-              <a:t>yard water equals one entire data-center campus.</a:t>
+              <a:t>Water is energy: 650 kilowatt-hours an acre-foot. Just the neighborhoods we've measured waste</a:t>
+            </a:r>
+          </a:p>
+          <a:p>
+            <a:r>
+              <a:t>about a third of a data-center campus's water. Statewide, it's about a hundred of them.</a:t>
             </a:r>
           </a:p>
         </p:txBody>
@@ -8112,7 +8203,7 @@
                 </a:solidFill>
                 <a:latin typeface="Fredoka"/>
               </a:rPr>
-              <a:t>3 · Claude reads the bill</a:t>
+              <a:t>3 · Claude reads the bill: 119,272 gallons over</a:t>
             </a:r>
           </a:p>
         </p:txBody>
@@ -8165,7 +8256,7 @@
       </p:sp>
       <p:pic>
         <p:nvPicPr>
-          <p:cNvPr id="4" name="Picture 3" descr="04-bill-read.jpg"/>
+          <p:cNvPr id="4" name="Picture 3" descr="04-bill.jpg"/>
           <p:cNvPicPr>
             <a:picLocks noChangeAspect="1"/>
           </p:cNvPicPr>
@@ -8221,7 +8312,7 @@
                 </a:solidFill>
                 <a:latin typeface="Nunito"/>
               </a:rPr>
-              <a:t>Twelve months of usage from a photo of the bill, in a few seconds.</a:t>
+              <a:t>320,914 gallons a year outdoors against the 201,642 this lawn needs. Read from a photo of the bill in about 5 seconds.</a:t>
             </a:r>
           </a:p>
         </p:txBody>
@@ -8647,22 +8738,21 @@
         </p:nvSpPr>
         <p:spPr>
           <a:xfrm>
-            <a:off x="2328519" y="1188720"/>
-            <a:ext cx="7534656" cy="4709160"/>
+            <a:off x="2264511" y="1124712"/>
+            <a:ext cx="7662672" cy="4837176"/>
           </a:xfrm>
           <a:prstGeom prst="roundRect">
             <a:avLst>
-              <a:gd name="adj" fmla="val 5000"/>
+              <a:gd name="adj" fmla="val 3000"/>
             </a:avLst>
           </a:prstGeom>
           <a:solidFill>
-            <a:srgbClr val="FFF6E0"/>
+            <a:srgbClr val="FFFFFF"/>
           </a:solidFill>
           <a:ln w="25400">
             <a:solidFill>
-              <a:srgbClr val="E5533F"/>
+              <a:srgbClr val="CFE6F5"/>
             </a:solidFill>
-            <a:prstDash val="dash"/>
           </a:ln>
           <a:effectLst/>
         </p:spPr>
@@ -8686,16 +8776,40 @@
           <a:p/>
         </p:txBody>
       </p:sp>
-      <p:sp>
-        <p:nvSpPr>
-          <p:cNvPr id="4" name="TextBox 3"/>
+      <p:pic>
+        <p:nvPicPr>
+          <p:cNvPr id="4" name="Picture 3" descr="06-calendar.jpg"/>
+          <p:cNvPicPr>
+            <a:picLocks noChangeAspect="1"/>
+          </p:cNvPicPr>
+          <p:nvPr/>
+        </p:nvPicPr>
+        <p:blipFill>
+          <a:blip r:embed="rId2"/>
+          <a:stretch>
+            <a:fillRect/>
+          </a:stretch>
+        </p:blipFill>
+        <p:spPr>
+          <a:xfrm>
+            <a:off x="2328519" y="1188720"/>
+            <a:ext cx="7534656" cy="4709160"/>
+          </a:xfrm>
+          <a:prstGeom prst="rect">
+            <a:avLst/>
+          </a:prstGeom>
+        </p:spPr>
+      </p:pic>
+      <p:sp>
+        <p:nvSpPr>
+          <p:cNvPr id="5" name="TextBox 4"/>
           <p:cNvSpPr txBox="1"/>
           <p:nvPr/>
         </p:nvSpPr>
         <p:spPr>
           <a:xfrm>
-            <a:off x="2602839" y="1463040"/>
-            <a:ext cx="6986016" cy="4160520"/>
+            <a:off x="685800" y="6080760"/>
+            <a:ext cx="10789920" cy="548640"/>
           </a:xfrm>
           <a:prstGeom prst="rect">
             <a:avLst/>
@@ -8703,56 +8817,24 @@
           <a:noFill/>
         </p:spPr>
         <p:txBody>
-          <a:bodyPr wrap="square" anchor="ctr" lIns="18288" rIns="18288" tIns="18288" bIns="18288">
+          <a:bodyPr wrap="square" anchor="t" lIns="18288" rIns="18288" tIns="18288" bIns="18288">
             <a:noAutofit/>
           </a:bodyPr>
           <a:lstStyle/>
           <a:p>
             <a:pPr algn="ctr">
               <a:spcAft>
-                <a:spcPts val="600"/>
-              </a:spcAft>
-            </a:pPr>
-            <a:r>
-              <a:rPr sz="1300" b="1" i="0">
-                <a:solidFill>
-                  <a:srgbClr val="E5533F"/>
+                <a:spcPts val="0"/>
+              </a:spcAft>
+            </a:pPr>
+            <a:r>
+              <a:rPr sz="1500" b="0" i="0">
+                <a:solidFill>
+                  <a:srgbClr val="4F6B80"/>
                 </a:solidFill>
                 <a:latin typeface="Nunito"/>
               </a:rPr>
-              <a:t>PLACEHOLDER</a:t>
-            </a:r>
-          </a:p>
-          <a:p>
-            <a:pPr algn="ctr">
-              <a:spcAft>
-                <a:spcPts val="600"/>
-              </a:spcAft>
-            </a:pPr>
-            <a:r>
-              <a:rPr sz="2400" b="1" i="0">
-                <a:solidFill>
-                  <a:srgbClr val="12324A"/>
-                </a:solidFill>
-                <a:latin typeface="Fredoka"/>
-              </a:rPr>
-              <a:t>Watering calendar</a:t>
-            </a:r>
-          </a:p>
-          <a:p>
-            <a:pPr algn="ctr">
-              <a:spcAft>
-                <a:spcPts val="600"/>
-              </a:spcAft>
-            </a:pPr>
-            <a:r>
-              <a:rPr sz="1500" b="0" i="0">
-                <a:solidFill>
-                  <a:srgbClr val="4F6B80"/>
-                </a:solidFill>
-                <a:latin typeface="Nunito"/>
-              </a:rPr>
-              <a:t>Screenshot of the subscribe button and a week in Google Calendar, once the calendar feature lands.</a:t>
+              <a:t>Follows Utah's Weekly Lawn Watering Guide. This week: no watering in Salt Lake County.</a:t>
             </a:r>
           </a:p>
         </p:txBody>
@@ -9537,28 +9619,105 @@
       </p:sp>
       <p:sp>
         <p:nvSpPr>
-          <p:cNvPr id="3" name="Rounded Rectangle 2"/>
+          <p:cNvPr id="3" name="TextBox 2"/>
+          <p:cNvSpPr txBox="1"/>
+          <p:nvPr/>
+        </p:nvSpPr>
+        <p:spPr>
+          <a:xfrm>
+            <a:off x="685800" y="1143000"/>
+            <a:ext cx="5212080" cy="548640"/>
+          </a:xfrm>
+          <a:prstGeom prst="rect">
+            <a:avLst/>
+          </a:prstGeom>
+          <a:noFill/>
+        </p:spPr>
+        <p:txBody>
+          <a:bodyPr wrap="square" anchor="t" lIns="18288" rIns="18288" tIns="18288" bIns="18288">
+            <a:noAutofit/>
+          </a:bodyPr>
+          <a:lstStyle/>
+          <a:p>
+            <a:pPr algn="l">
+              <a:spcAft>
+                <a:spcPts val="0"/>
+              </a:spcAft>
+            </a:pPr>
+            <a:r>
+              <a:rPr sz="2600" b="1" i="0">
+                <a:solidFill>
+                  <a:srgbClr val="E5533F"/>
+                </a:solidFill>
+                <a:latin typeface="Fredoka"/>
+              </a:rPr>
+              <a:t>This week: off</a:t>
+            </a:r>
+          </a:p>
+        </p:txBody>
+      </p:sp>
+      <p:sp>
+        <p:nvSpPr>
+          <p:cNvPr id="4" name="TextBox 3"/>
+          <p:cNvSpPr txBox="1"/>
+          <p:nvPr/>
+        </p:nvSpPr>
+        <p:spPr>
+          <a:xfrm>
+            <a:off x="6309360" y="1143000"/>
+            <a:ext cx="5212080" cy="548640"/>
+          </a:xfrm>
+          <a:prstGeom prst="rect">
+            <a:avLst/>
+          </a:prstGeom>
+          <a:noFill/>
+        </p:spPr>
+        <p:txBody>
+          <a:bodyPr wrap="square" anchor="t" lIns="18288" rIns="18288" tIns="18288" bIns="18288">
+            <a:noAutofit/>
+          </a:bodyPr>
+          <a:lstStyle/>
+          <a:p>
+            <a:pPr algn="l">
+              <a:spcAft>
+                <a:spcPts val="0"/>
+              </a:spcAft>
+            </a:pPr>
+            <a:r>
+              <a:rPr sz="2600" b="1" i="0">
+                <a:solidFill>
+                  <a:srgbClr val="2C9A4B"/>
+                </a:solidFill>
+                <a:latin typeface="Fredoka"/>
+              </a:rPr>
+              <a:t>A July week: on</a:t>
+            </a:r>
+          </a:p>
+        </p:txBody>
+      </p:sp>
+      <p:sp>
+        <p:nvSpPr>
+          <p:cNvPr id="5" name="Rounded Rectangle 4"/>
           <p:cNvSpPr/>
           <p:nvPr/>
         </p:nvSpPr>
         <p:spPr>
           <a:xfrm>
-            <a:off x="2328519" y="1188720"/>
-            <a:ext cx="7534656" cy="4709160"/>
+            <a:off x="621792" y="1719072"/>
+            <a:ext cx="5248655" cy="1792224"/>
           </a:xfrm>
           <a:prstGeom prst="roundRect">
             <a:avLst>
-              <a:gd name="adj" fmla="val 5000"/>
+              <a:gd name="adj" fmla="val 3000"/>
             </a:avLst>
           </a:prstGeom>
           <a:solidFill>
-            <a:srgbClr val="FFF6E0"/>
+            <a:srgbClr val="FFFFFF"/>
           </a:solidFill>
           <a:ln w="25400">
             <a:solidFill>
-              <a:srgbClr val="E5533F"/>
+              <a:srgbClr val="CFE6F5"/>
             </a:solidFill>
-            <a:prstDash val="dash"/>
           </a:ln>
           <a:effectLst/>
         </p:spPr>
@@ -9582,16 +9741,110 @@
           <a:p/>
         </p:txBody>
       </p:sp>
-      <p:sp>
-        <p:nvSpPr>
-          <p:cNvPr id="4" name="TextBox 3"/>
+      <p:pic>
+        <p:nvPicPr>
+          <p:cNvPr id="6" name="Picture 5" descr="06-os-paused-full-enabled.jpg"/>
+          <p:cNvPicPr>
+            <a:picLocks noChangeAspect="1"/>
+          </p:cNvPicPr>
+          <p:nvPr/>
+        </p:nvPicPr>
+        <p:blipFill>
+          <a:blip r:embed="rId2"/>
+          <a:stretch>
+            <a:fillRect/>
+          </a:stretch>
+        </p:blipFill>
+        <p:spPr>
+          <a:xfrm>
+            <a:off x="685800" y="1783080"/>
+            <a:ext cx="5120640" cy="1664207"/>
+          </a:xfrm>
+          <a:prstGeom prst="rect">
+            <a:avLst/>
+          </a:prstGeom>
+        </p:spPr>
+      </p:pic>
+      <p:sp>
+        <p:nvSpPr>
+          <p:cNvPr id="7" name="Rounded Rectangle 6"/>
+          <p:cNvSpPr/>
+          <p:nvPr/>
+        </p:nvSpPr>
+        <p:spPr>
+          <a:xfrm>
+            <a:off x="6245352" y="1719072"/>
+            <a:ext cx="5248655" cy="1792224"/>
+          </a:xfrm>
+          <a:prstGeom prst="roundRect">
+            <a:avLst>
+              <a:gd name="adj" fmla="val 3000"/>
+            </a:avLst>
+          </a:prstGeom>
+          <a:solidFill>
+            <a:srgbClr val="FFFFFF"/>
+          </a:solidFill>
+          <a:ln w="25400">
+            <a:solidFill>
+              <a:srgbClr val="CFE6F5"/>
+            </a:solidFill>
+          </a:ln>
+          <a:effectLst/>
+        </p:spPr>
+        <p:style>
+          <a:lnRef idx="1">
+            <a:schemeClr val="accent1"/>
+          </a:lnRef>
+          <a:fillRef idx="3">
+            <a:schemeClr val="accent1"/>
+          </a:fillRef>
+          <a:effectRef idx="2">
+            <a:schemeClr val="accent1"/>
+          </a:effectRef>
+          <a:fontRef idx="minor">
+            <a:schemeClr val="lt1"/>
+          </a:fontRef>
+        </p:style>
+        <p:txBody>
+          <a:bodyPr rtlCol="0" anchor="ctr"/>
+          <a:lstStyle/>
+          <a:p/>
+        </p:txBody>
+      </p:sp>
+      <p:pic>
+        <p:nvPicPr>
+          <p:cNvPr id="8" name="Picture 7" descr="06-os-july-full-enabled.jpg"/>
+          <p:cNvPicPr>
+            <a:picLocks noChangeAspect="1"/>
+          </p:cNvPicPr>
+          <p:nvPr/>
+        </p:nvPicPr>
+        <p:blipFill>
+          <a:blip r:embed="rId3"/>
+          <a:stretch>
+            <a:fillRect/>
+          </a:stretch>
+        </p:blipFill>
+        <p:spPr>
+          <a:xfrm>
+            <a:off x="6309360" y="1783080"/>
+            <a:ext cx="5120640" cy="1664207"/>
+          </a:xfrm>
+          <a:prstGeom prst="rect">
+            <a:avLst/>
+          </a:prstGeom>
+        </p:spPr>
+      </p:pic>
+      <p:sp>
+        <p:nvSpPr>
+          <p:cNvPr id="9" name="TextBox 8"/>
           <p:cNvSpPr txBox="1"/>
           <p:nvPr/>
         </p:nvSpPr>
         <p:spPr>
           <a:xfrm>
-            <a:off x="2602839" y="1463040"/>
-            <a:ext cx="6986016" cy="4160520"/>
+            <a:off x="685800" y="3703320"/>
+            <a:ext cx="5120640" cy="1371600"/>
           </a:xfrm>
           <a:prstGeom prst="rect">
             <a:avLst/>
@@ -9599,56 +9852,181 @@
           <a:noFill/>
         </p:spPr>
         <p:txBody>
-          <a:bodyPr wrap="square" anchor="ctr" lIns="18288" rIns="18288" tIns="18288" bIns="18288">
+          <a:bodyPr wrap="square" anchor="t" lIns="18288" rIns="18288" tIns="18288" bIns="18288">
             <a:noAutofit/>
           </a:bodyPr>
           <a:lstStyle/>
           <a:p>
-            <a:pPr algn="ctr">
-              <a:spcAft>
-                <a:spcPts val="600"/>
-              </a:spcAft>
-            </a:pPr>
-            <a:r>
-              <a:rPr sz="1300" b="1" i="0">
-                <a:solidFill>
-                  <a:srgbClr val="E5533F"/>
+            <a:pPr algn="l">
+              <a:lnSpc>
+                <a:spcPct val="115000"/>
+              </a:lnSpc>
+              <a:spcAft>
+                <a:spcPts val="0"/>
+              </a:spcAft>
+            </a:pPr>
+            <a:r>
+              <a:rPr sz="1700" b="0" i="0">
+                <a:solidFill>
+                  <a:srgbClr val="12324A"/>
                 </a:solidFill>
                 <a:latin typeface="Nunito"/>
               </a:rPr>
-              <a:t>PLACEHOLDER</a:t>
-            </a:r>
-          </a:p>
-          <a:p>
-            <a:pPr algn="ctr">
-              <a:spcAft>
-                <a:spcPts val="600"/>
-              </a:spcAft>
-            </a:pPr>
-            <a:r>
-              <a:rPr sz="2400" b="1" i="0">
+              <a:t>Utah's Weekly Lawn Watering Guide says no watering in Salt Lake County, so the connector switched the program off. Other programs are untouched.</a:t>
+            </a:r>
+          </a:p>
+        </p:txBody>
+      </p:sp>
+      <p:sp>
+        <p:nvSpPr>
+          <p:cNvPr id="10" name="Rounded Rectangle 9"/>
+          <p:cNvSpPr/>
+          <p:nvPr/>
+        </p:nvSpPr>
+        <p:spPr>
+          <a:xfrm>
+            <a:off x="6245352" y="3639312"/>
+            <a:ext cx="3328416" cy="2608326"/>
+          </a:xfrm>
+          <a:prstGeom prst="roundRect">
+            <a:avLst>
+              <a:gd name="adj" fmla="val 3000"/>
+            </a:avLst>
+          </a:prstGeom>
+          <a:solidFill>
+            <a:srgbClr val="FFFFFF"/>
+          </a:solidFill>
+          <a:ln w="25400">
+            <a:solidFill>
+              <a:srgbClr val="CFE6F5"/>
+            </a:solidFill>
+          </a:ln>
+          <a:effectLst/>
+        </p:spPr>
+        <p:style>
+          <a:lnRef idx="1">
+            <a:schemeClr val="accent1"/>
+          </a:lnRef>
+          <a:fillRef idx="3">
+            <a:schemeClr val="accent1"/>
+          </a:fillRef>
+          <a:effectRef idx="2">
+            <a:schemeClr val="accent1"/>
+          </a:effectRef>
+          <a:fontRef idx="minor">
+            <a:schemeClr val="lt1"/>
+          </a:fontRef>
+        </p:style>
+        <p:txBody>
+          <a:bodyPr rtlCol="0" anchor="ctr"/>
+          <a:lstStyle/>
+          <a:p/>
+        </p:txBody>
+      </p:sp>
+      <p:pic>
+        <p:nvPicPr>
+          <p:cNvPr id="11" name="Picture 10" descr="06-os-july-full-stations.jpg"/>
+          <p:cNvPicPr>
+            <a:picLocks noChangeAspect="1"/>
+          </p:cNvPicPr>
+          <p:nvPr/>
+        </p:nvPicPr>
+        <p:blipFill>
+          <a:blip r:embed="rId4"/>
+          <a:stretch>
+            <a:fillRect/>
+          </a:stretch>
+        </p:blipFill>
+        <p:spPr>
+          <a:xfrm>
+            <a:off x="6309360" y="3703320"/>
+            <a:ext cx="3200400" cy="2480310"/>
+          </a:xfrm>
+          <a:prstGeom prst="rect">
+            <a:avLst/>
+          </a:prstGeom>
+        </p:spPr>
+      </p:pic>
+      <p:sp>
+        <p:nvSpPr>
+          <p:cNvPr id="12" name="TextBox 11"/>
+          <p:cNvSpPr txBox="1"/>
+          <p:nvPr/>
+        </p:nvSpPr>
+        <p:spPr>
+          <a:xfrm>
+            <a:off x="9692640" y="3703320"/>
+            <a:ext cx="1920240" cy="2468880"/>
+          </a:xfrm>
+          <a:prstGeom prst="rect">
+            <a:avLst/>
+          </a:prstGeom>
+          <a:noFill/>
+        </p:spPr>
+        <p:txBody>
+          <a:bodyPr wrap="square" anchor="t" lIns="18288" rIns="18288" tIns="18288" bIns="18288">
+            <a:noAutofit/>
+          </a:bodyPr>
+          <a:lstStyle/>
+          <a:p>
+            <a:pPr algn="l">
+              <a:lnSpc>
+                <a:spcPct val="115000"/>
+              </a:lnSpc>
+              <a:spcAft>
+                <a:spcPts val="0"/>
+              </a:spcAft>
+            </a:pPr>
+            <a:r>
+              <a:rPr sz="1500" b="0" i="0">
                 <a:solidFill>
                   <a:srgbClr val="12324A"/>
                 </a:solidFill>
-                <a:latin typeface="Fredoka"/>
-              </a:rPr>
-              <a:t>OpenSprinkler, demo firmware</a:t>
-            </a:r>
-          </a:p>
-          <a:p>
-            <a:pPr algn="ctr">
-              <a:spcAft>
-                <a:spcPts val="600"/>
-              </a:spcAft>
-            </a:pPr>
-            <a:r>
-              <a:rPr sz="1500" b="0" i="0">
+                <a:latin typeface="Nunito"/>
+              </a:rPr>
+              <a:t>Mon, Wed, Fri at 5:00 AM. 4 × 7 min per zone, an hour apart, so it soaks in.</a:t>
+            </a:r>
+          </a:p>
+        </p:txBody>
+      </p:sp>
+      <p:sp>
+        <p:nvSpPr>
+          <p:cNvPr id="13" name="TextBox 12"/>
+          <p:cNvSpPr txBox="1"/>
+          <p:nvPr/>
+        </p:nvSpPr>
+        <p:spPr>
+          <a:xfrm>
+            <a:off x="685800" y="5669280"/>
+            <a:ext cx="5120640" cy="731520"/>
+          </a:xfrm>
+          <a:prstGeom prst="rect">
+            <a:avLst/>
+          </a:prstGeom>
+          <a:noFill/>
+        </p:spPr>
+        <p:txBody>
+          <a:bodyPr wrap="square" anchor="t" lIns="18288" rIns="18288" tIns="18288" bIns="18288">
+            <a:noAutofit/>
+          </a:bodyPr>
+          <a:lstStyle/>
+          <a:p>
+            <a:pPr algn="l">
+              <a:lnSpc>
+                <a:spcPct val="110000"/>
+              </a:lnSpc>
+              <a:spcAft>
+                <a:spcPts val="0"/>
+              </a:spcAft>
+            </a:pPr>
+            <a:r>
+              <a:rPr sz="1300" b="0" i="0">
                 <a:solidFill>
                   <a:srgbClr val="4F6B80"/>
                 </a:solidFill>
                 <a:latin typeface="Nunito"/>
               </a:rPr>
-              <a:t>Before/after: 'No Watering' week paused, July week with minutes per zone. Lands with connect/.</a:t>
+              <a:t>OpenSprinkler's own firmware, in demo mode, set by overwater.ing/connect. One program, rewritten each morning.</a:t>
             </a:r>
           </a:p>
         </p:txBody>
@@ -9713,7 +10091,7 @@
                 </a:solidFill>
                 <a:latin typeface="Fredoka"/>
               </a:rPr>
-              <a:t>7 · Go native</a:t>
+              <a:t>6 · Any controller: the open schedule API</a:t>
             </a:r>
           </a:p>
         </p:txBody>
@@ -9766,7 +10144,7 @@
       </p:sp>
       <p:pic>
         <p:nvPicPr>
-          <p:cNvPr id="4" name="Picture 3" descr="07-native.jpg"/>
+          <p:cNvPr id="4" name="Picture 3" descr="06-connect.jpg"/>
           <p:cNvPicPr>
             <a:picLocks noChangeAspect="1"/>
           </p:cNvPicPr>
@@ -9822,7 +10200,7 @@
                 </a:solidFill>
                 <a:latin typeface="Nunito"/>
               </a:rPr>
-              <a:t>Before and after for this lot, then the plants and designers.</a:t>
+              <a:t>/connect: the OpenSprinkler connector is one file. Rachio and Hydrawise are next.</a:t>
             </a:r>
           </a:p>
         </p:txBody>
@@ -9887,7 +10265,7 @@
                 </a:solidFill>
                 <a:latin typeface="Fredoka"/>
               </a:rPr>
-              <a:t>8 · The rebate, and who's in charge here</a:t>
+              <a:t>7 · Go native</a:t>
             </a:r>
           </a:p>
         </p:txBody>
@@ -9940,7 +10318,7 @@
       </p:sp>
       <p:pic>
         <p:nvPicPr>
-          <p:cNvPr id="4" name="Picture 3" descr="08-rebate.jpg"/>
+          <p:cNvPr id="4" name="Picture 3" descr="07-native.jpg"/>
           <p:cNvPicPr>
             <a:picLocks noChangeAspect="1"/>
           </p:cNvPicPr>
@@ -9996,7 +10374,7 @@
                 </a:solidFill>
                 <a:latin typeface="Nunito"/>
               </a:rPr>
-              <a:t>City, water provider, wholesale districts and program for this exact lot.</a:t>
+              <a:t>Before and after for this lot, then the plants and designers.</a:t>
             </a:r>
           </a:p>
         </p:txBody>
@@ -10061,7 +10439,7 @@
                 </a:solidFill>
                 <a:latin typeface="Fredoka"/>
               </a:rPr>
-              <a:t>9 · Any address, measured live</a:t>
+              <a:t>8 · The rebate, and who's in charge here</a:t>
             </a:r>
           </a:p>
         </p:txBody>
@@ -10074,22 +10452,21 @@
         </p:nvSpPr>
         <p:spPr>
           <a:xfrm>
-            <a:off x="2328519" y="1188720"/>
-            <a:ext cx="7534656" cy="4709160"/>
+            <a:off x="2264511" y="1124712"/>
+            <a:ext cx="7662672" cy="4837176"/>
           </a:xfrm>
           <a:prstGeom prst="roundRect">
             <a:avLst>
-              <a:gd name="adj" fmla="val 5000"/>
+              <a:gd name="adj" fmla="val 3000"/>
             </a:avLst>
           </a:prstGeom>
           <a:solidFill>
-            <a:srgbClr val="FFF6E0"/>
+            <a:srgbClr val="FFFFFF"/>
           </a:solidFill>
           <a:ln w="25400">
             <a:solidFill>
-              <a:srgbClr val="E5533F"/>
+              <a:srgbClr val="CFE6F5"/>
             </a:solidFill>
-            <a:prstDash val="dash"/>
           </a:ln>
           <a:effectLst/>
         </p:spPr>
@@ -10113,77 +10490,30 @@
           <a:p/>
         </p:txBody>
       </p:sp>
-      <p:sp>
-        <p:nvSpPr>
-          <p:cNvPr id="4" name="TextBox 3"/>
-          <p:cNvSpPr txBox="1"/>
-          <p:nvPr/>
-        </p:nvSpPr>
-        <p:spPr>
-          <a:xfrm>
-            <a:off x="2602839" y="1463040"/>
-            <a:ext cx="6986016" cy="4160520"/>
-          </a:xfrm>
-          <a:prstGeom prst="rect">
-            <a:avLst/>
-          </a:prstGeom>
-          <a:noFill/>
-        </p:spPr>
-        <p:txBody>
-          <a:bodyPr wrap="square" anchor="ctr" lIns="18288" rIns="18288" tIns="18288" bIns="18288">
-            <a:noAutofit/>
-          </a:bodyPr>
-          <a:lstStyle/>
-          <a:p>
-            <a:pPr algn="ctr">
-              <a:spcAft>
-                <a:spcPts val="600"/>
-              </a:spcAft>
-            </a:pPr>
-            <a:r>
-              <a:rPr sz="1300" b="1" i="0">
-                <a:solidFill>
-                  <a:srgbClr val="E5533F"/>
-                </a:solidFill>
-                <a:latin typeface="Nunito"/>
-              </a:rPr>
-              <a:t>PLACEHOLDER</a:t>
-            </a:r>
-          </a:p>
-          <a:p>
-            <a:pPr algn="ctr">
-              <a:spcAft>
-                <a:spcPts val="600"/>
-              </a:spcAft>
-            </a:pPr>
-            <a:r>
-              <a:rPr sz="2400" b="1" i="0">
-                <a:solidFill>
-                  <a:srgbClr val="12324A"/>
-                </a:solidFill>
-                <a:latin typeface="Fredoka"/>
-              </a:rPr>
-              <a:t>Live lot outside Salt Lake County</a:t>
-            </a:r>
-          </a:p>
-          <a:p>
-            <a:pPr algn="ctr">
-              <a:spcAft>
-                <a:spcPts val="600"/>
-              </a:spcAft>
-            </a:pPr>
-            <a:r>
-              <a:rPr sz="1500" b="0" i="0">
-                <a:solidFill>
-                  <a:srgbClr val="4F6B80"/>
-                </a:solidFill>
-                <a:latin typeface="Nunito"/>
-              </a:rPr>
-              <a:t>Screenshot pending: the statewide imagery proxy was failing when this deck was built.</a:t>
-            </a:r>
-          </a:p>
-        </p:txBody>
-      </p:sp>
+      <p:pic>
+        <p:nvPicPr>
+          <p:cNvPr id="4" name="Picture 3" descr="08-rebate.jpg"/>
+          <p:cNvPicPr>
+            <a:picLocks noChangeAspect="1"/>
+          </p:cNvPicPr>
+          <p:nvPr/>
+        </p:nvPicPr>
+        <p:blipFill>
+          <a:blip r:embed="rId2"/>
+          <a:stretch>
+            <a:fillRect/>
+          </a:stretch>
+        </p:blipFill>
+        <p:spPr>
+          <a:xfrm>
+            <a:off x="2328519" y="1188720"/>
+            <a:ext cx="7534656" cy="4709160"/>
+          </a:xfrm>
+          <a:prstGeom prst="rect">
+            <a:avLst/>
+          </a:prstGeom>
+        </p:spPr>
+      </p:pic>
       <p:sp>
         <p:nvSpPr>
           <p:cNvPr id="5" name="TextBox 4"/>
@@ -10218,7 +10548,7 @@
                 </a:solidFill>
                 <a:latin typeface="Nunito"/>
               </a:rPr>
-              <a:t>Outside Salt Lake County, computed in the browser.</a:t>
+              <a:t>City, water provider, wholesale districts and program for this exact lot.</a:t>
             </a:r>
           </a:p>
         </p:txBody>
@@ -10283,7 +10613,7 @@
                 </a:solidFill>
                 <a:latin typeface="Fredoka"/>
               </a:rPr>
-              <a:t>Neighborhood view for districts</a:t>
+              <a:t>9 · Any address, measured live</a:t>
             </a:r>
           </a:p>
         </p:txBody>
@@ -10336,7 +10666,7 @@
       </p:sp>
       <p:pic>
         <p:nvPicPr>
-          <p:cNvPr id="4" name="Picture 3" descr="11-district-avenues.jpg"/>
+          <p:cNvPr id="4" name="Picture 3" descr="09-live.jpg"/>
           <p:cNvPicPr>
             <a:picLocks noChangeAspect="1"/>
           </p:cNvPicPr>
@@ -10392,7 +10722,7 @@
                 </a:solidFill>
                 <a:latin typeface="Nunito"/>
               </a:rPr>
-              <a:t>Totals only, never household rankings.</a:t>
+              <a:t>67 W 200 N, St. George: 10,834 sq ft of lawn needing 42 inches a season. Measured in the browser, nothing precomputed.</a:t>
             </a:r>
           </a:p>
         </p:txBody>
@@ -10457,7 +10787,7 @@
                 </a:solidFill>
                 <a:latin typeface="Fredoka"/>
               </a:rPr>
-              <a:t>/impact: statewide, energy and data centers</a:t>
+              <a:t>Neighborhood view for districts</a:t>
             </a:r>
           </a:p>
         </p:txBody>
@@ -10470,22 +10800,21 @@
         </p:nvSpPr>
         <p:spPr>
           <a:xfrm>
-            <a:off x="2328519" y="1188720"/>
-            <a:ext cx="7534656" cy="4709160"/>
+            <a:off x="2264511" y="1124712"/>
+            <a:ext cx="7662672" cy="4837176"/>
           </a:xfrm>
           <a:prstGeom prst="roundRect">
             <a:avLst>
-              <a:gd name="adj" fmla="val 5000"/>
+              <a:gd name="adj" fmla="val 3000"/>
             </a:avLst>
           </a:prstGeom>
           <a:solidFill>
-            <a:srgbClr val="FFF6E0"/>
+            <a:srgbClr val="FFFFFF"/>
           </a:solidFill>
           <a:ln w="25400">
             <a:solidFill>
-              <a:srgbClr val="E5533F"/>
+              <a:srgbClr val="CFE6F5"/>
             </a:solidFill>
-            <a:prstDash val="dash"/>
           </a:ln>
           <a:effectLst/>
         </p:spPr>
@@ -10509,16 +10838,40 @@
           <a:p/>
         </p:txBody>
       </p:sp>
-      <p:sp>
-        <p:nvSpPr>
-          <p:cNvPr id="4" name="TextBox 3"/>
+      <p:pic>
+        <p:nvPicPr>
+          <p:cNvPr id="4" name="Picture 3" descr="11-district-avenues.jpg"/>
+          <p:cNvPicPr>
+            <a:picLocks noChangeAspect="1"/>
+          </p:cNvPicPr>
+          <p:nvPr/>
+        </p:nvPicPr>
+        <p:blipFill>
+          <a:blip r:embed="rId2"/>
+          <a:stretch>
+            <a:fillRect/>
+          </a:stretch>
+        </p:blipFill>
+        <p:spPr>
+          <a:xfrm>
+            <a:off x="2328519" y="1188720"/>
+            <a:ext cx="7534656" cy="4709160"/>
+          </a:xfrm>
+          <a:prstGeom prst="rect">
+            <a:avLst/>
+          </a:prstGeom>
+        </p:spPr>
+      </p:pic>
+      <p:sp>
+        <p:nvSpPr>
+          <p:cNvPr id="5" name="TextBox 4"/>
           <p:cNvSpPr txBox="1"/>
           <p:nvPr/>
         </p:nvSpPr>
         <p:spPr>
           <a:xfrm>
-            <a:off x="2602839" y="1463040"/>
-            <a:ext cx="6986016" cy="4160520"/>
+            <a:off x="685800" y="6080760"/>
+            <a:ext cx="10789920" cy="548640"/>
           </a:xfrm>
           <a:prstGeom prst="rect">
             <a:avLst/>
@@ -10526,56 +10879,24 @@
           <a:noFill/>
         </p:spPr>
         <p:txBody>
-          <a:bodyPr wrap="square" anchor="ctr" lIns="18288" rIns="18288" tIns="18288" bIns="18288">
+          <a:bodyPr wrap="square" anchor="t" lIns="18288" rIns="18288" tIns="18288" bIns="18288">
             <a:noAutofit/>
           </a:bodyPr>
           <a:lstStyle/>
           <a:p>
             <a:pPr algn="ctr">
               <a:spcAft>
-                <a:spcPts val="600"/>
-              </a:spcAft>
-            </a:pPr>
-            <a:r>
-              <a:rPr sz="1300" b="1" i="0">
-                <a:solidFill>
-                  <a:srgbClr val="E5533F"/>
+                <a:spcPts val="0"/>
+              </a:spcAft>
+            </a:pPr>
+            <a:r>
+              <a:rPr sz="1500" b="0" i="0">
+                <a:solidFill>
+                  <a:srgbClr val="4F6B80"/>
                 </a:solidFill>
                 <a:latin typeface="Nunito"/>
               </a:rPr>
-              <a:t>PLACEHOLDER</a:t>
-            </a:r>
-          </a:p>
-          <a:p>
-            <a:pPr algn="ctr">
-              <a:spcAft>
-                <a:spcPts val="600"/>
-              </a:spcAft>
-            </a:pPr>
-            <a:r>
-              <a:rPr sz="2400" b="1" i="0">
-                <a:solidFill>
-                  <a:srgbClr val="12324A"/>
-                </a:solidFill>
-                <a:latin typeface="Fredoka"/>
-              </a:rPr>
-              <a:t>/impact page</a:t>
-            </a:r>
-          </a:p>
-          <a:p>
-            <a:pPr algn="ctr">
-              <a:spcAft>
-                <a:spcPts val="600"/>
-              </a:spcAft>
-            </a:pPr>
-            <a:r>
-              <a:rPr sz="1500" b="0" i="0">
-                <a:solidFill>
-                  <a:srgbClr val="4F6B80"/>
-                </a:solidFill>
-                <a:latin typeface="Nunito"/>
-              </a:rPr>
-              <a:t>Statewide totals, energy and data-center framing. Lands with /impact.</a:t>
+              <a:t>Totals only, never household rankings.</a:t>
             </a:r>
           </a:p>
         </p:txBody>
@@ -10640,6 +10961,180 @@
                 </a:solidFill>
                 <a:latin typeface="Fredoka"/>
               </a:rPr>
+              <a:t>Why it matters: overwater.ing/impact</a:t>
+            </a:r>
+          </a:p>
+        </p:txBody>
+      </p:sp>
+      <p:sp>
+        <p:nvSpPr>
+          <p:cNvPr id="3" name="Rounded Rectangle 2"/>
+          <p:cNvSpPr/>
+          <p:nvPr/>
+        </p:nvSpPr>
+        <p:spPr>
+          <a:xfrm>
+            <a:off x="2264511" y="1124712"/>
+            <a:ext cx="7662672" cy="4837176"/>
+          </a:xfrm>
+          <a:prstGeom prst="roundRect">
+            <a:avLst>
+              <a:gd name="adj" fmla="val 3000"/>
+            </a:avLst>
+          </a:prstGeom>
+          <a:solidFill>
+            <a:srgbClr val="FFFFFF"/>
+          </a:solidFill>
+          <a:ln w="25400">
+            <a:solidFill>
+              <a:srgbClr val="CFE6F5"/>
+            </a:solidFill>
+          </a:ln>
+          <a:effectLst/>
+        </p:spPr>
+        <p:style>
+          <a:lnRef idx="1">
+            <a:schemeClr val="accent1"/>
+          </a:lnRef>
+          <a:fillRef idx="3">
+            <a:schemeClr val="accent1"/>
+          </a:fillRef>
+          <a:effectRef idx="2">
+            <a:schemeClr val="accent1"/>
+          </a:effectRef>
+          <a:fontRef idx="minor">
+            <a:schemeClr val="lt1"/>
+          </a:fontRef>
+        </p:style>
+        <p:txBody>
+          <a:bodyPr rtlCol="0" anchor="ctr"/>
+          <a:lstStyle/>
+          <a:p/>
+        </p:txBody>
+      </p:sp>
+      <p:pic>
+        <p:nvPicPr>
+          <p:cNvPr id="4" name="Picture 3" descr="12-impact.jpg"/>
+          <p:cNvPicPr>
+            <a:picLocks noChangeAspect="1"/>
+          </p:cNvPicPr>
+          <p:nvPr/>
+        </p:nvPicPr>
+        <p:blipFill>
+          <a:blip r:embed="rId2"/>
+          <a:stretch>
+            <a:fillRect/>
+          </a:stretch>
+        </p:blipFill>
+        <p:spPr>
+          <a:xfrm>
+            <a:off x="2328519" y="1188720"/>
+            <a:ext cx="7534656" cy="4709160"/>
+          </a:xfrm>
+          <a:prstGeom prst="rect">
+            <a:avLst/>
+          </a:prstGeom>
+        </p:spPr>
+      </p:pic>
+      <p:sp>
+        <p:nvSpPr>
+          <p:cNvPr id="5" name="TextBox 4"/>
+          <p:cNvSpPr txBox="1"/>
+          <p:nvPr/>
+        </p:nvSpPr>
+        <p:spPr>
+          <a:xfrm>
+            <a:off x="685800" y="6080760"/>
+            <a:ext cx="10789920" cy="548640"/>
+          </a:xfrm>
+          <a:prstGeom prst="rect">
+            <a:avLst/>
+          </a:prstGeom>
+          <a:noFill/>
+        </p:spPr>
+        <p:txBody>
+          <a:bodyPr wrap="square" anchor="t" lIns="18288" rIns="18288" tIns="18288" bIns="18288">
+            <a:noAutofit/>
+          </a:bodyPr>
+          <a:lstStyle/>
+          <a:p>
+            <a:pPr algn="ctr">
+              <a:spcAft>
+                <a:spcPts val="0"/>
+              </a:spcAft>
+            </a:pPr>
+            <a:r>
+              <a:rPr sz="1500" b="0" i="0">
+                <a:solidFill>
+                  <a:srgbClr val="4F6B80"/>
+                </a:solidFill>
+                <a:latin typeface="Nunito"/>
+              </a:rPr>
+              <a:t>Our measured neighborhoods, the state-scale scenario, and the data-center framing.</a:t>
+            </a:r>
+          </a:p>
+        </p:txBody>
+      </p:sp>
+    </p:spTree>
+  </p:cSld>
+  <p:clrMapOvr>
+    <a:masterClrMapping/>
+  </p:clrMapOvr>
+</p:sld>
+</file>
+
+<file path=ppt/slides/slide27.xml><?xml version="1.0" encoding="utf-8"?>
+<p:sld xmlns:a="http://schemas.openxmlformats.org/drawingml/2006/main" xmlns:p="http://schemas.openxmlformats.org/presentationml/2006/main" xmlns:r="http://schemas.openxmlformats.org/officeDocument/2006/relationships">
+  <p:cSld>
+    <p:bg>
+      <p:bgPr>
+        <a:solidFill>
+          <a:srgbClr val="EEF8FE"/>
+        </a:solidFill>
+        <a:effectLst/>
+      </p:bgPr>
+    </p:bg>
+    <p:spTree>
+      <p:nvGrpSpPr>
+        <p:cNvPr id="1" name=""/>
+        <p:cNvGrpSpPr/>
+        <p:nvPr/>
+      </p:nvGrpSpPr>
+      <p:grpSpPr/>
+      <p:sp>
+        <p:nvSpPr>
+          <p:cNvPr id="2" name="TextBox 1"/>
+          <p:cNvSpPr txBox="1"/>
+          <p:nvPr/>
+        </p:nvSpPr>
+        <p:spPr>
+          <a:xfrm>
+            <a:off x="685800" y="365760"/>
+            <a:ext cx="10789920" cy="640080"/>
+          </a:xfrm>
+          <a:prstGeom prst="rect">
+            <a:avLst/>
+          </a:prstGeom>
+          <a:noFill/>
+        </p:spPr>
+        <p:txBody>
+          <a:bodyPr wrap="square" anchor="t" lIns="18288" rIns="18288" tIns="18288" bIns="18288">
+            <a:noAutofit/>
+          </a:bodyPr>
+          <a:lstStyle/>
+          <a:p>
+            <a:pPr algn="l">
+              <a:spcAft>
+                <a:spcPts val="0"/>
+              </a:spcAft>
+            </a:pPr>
+            <a:r>
+              <a:rPr sz="3000" b="1" i="0">
+                <a:solidFill>
+                  <a:srgbClr val="12324A"/>
+                </a:solidFill>
+                <a:latin typeface="Fredoka"/>
+              </a:rPr>
               <a:t>Sources</a:t>
             </a:r>
           </a:p>
@@ -15490,7 +15985,7 @@
         <p:spPr>
           <a:xfrm>
             <a:off x="685800" y="2103120"/>
-            <a:ext cx="3429000" cy="2651760"/>
+            <a:ext cx="3429000" cy="2926080"/>
           </a:xfrm>
           <a:prstGeom prst="roundRect">
             <a:avLst>
@@ -15606,7 +16101,7 @@
                 </a:solidFill>
                 <a:latin typeface="Nunito"/>
               </a:rPr>
-              <a:t>to treat and deliver one acre-foot of water.</a:t>
+              <a:t>to pump and treat every acre-foot. Small per home, big at state scale.</a:t>
             </a:r>
           </a:p>
         </p:txBody>
@@ -15620,7 +16115,7 @@
         <p:spPr>
           <a:xfrm>
             <a:off x="4389120" y="2103120"/>
-            <a:ext cx="3429000" cy="2651760"/>
+            <a:ext cx="3429000" cy="2926080"/>
           </a:xfrm>
           <a:prstGeom prst="roundRect">
             <a:avLst>
@@ -15694,7 +16189,7 @@
                 </a:solidFill>
                 <a:latin typeface="Fredoka"/>
               </a:rPr>
-              <a:t>~390 kg</a:t>
+              <a:t>~372 AF</a:t>
             </a:r>
           </a:p>
         </p:txBody>
@@ -15736,7 +16231,7 @@
                 </a:solidFill>
                 <a:latin typeface="Nunito"/>
               </a:rPr>
-              <a:t>of CO₂ per acre-foot on Utah's grid (0.60 kg/kWh).</a:t>
+              <a:t>a year the grass in our measured neighborhoods never needed: 242 MWh, ~38% of one data-center campus.</a:t>
             </a:r>
           </a:p>
         </p:txBody>
@@ -15750,7 +16245,7 @@
         <p:spPr>
           <a:xfrm>
             <a:off x="8092440" y="2103120"/>
-            <a:ext cx="3429000" cy="2651760"/>
+            <a:ext cx="3429000" cy="2926080"/>
           </a:xfrm>
           <a:prstGeom prst="roundRect">
             <a:avLst>
@@ -15824,7 +16319,7 @@
                 </a:solidFill>
                 <a:latin typeface="Fredoka"/>
               </a:rPr>
-              <a:t>0.2%</a:t>
+              <a:t>~100×</a:t>
             </a:r>
           </a:p>
         </p:txBody>
@@ -15866,7 +16361,7 @@
                 </a:solidFill>
                 <a:latin typeface="Nunito"/>
               </a:rPr>
-              <a:t>of Utah's residential outdoor water equals one ~987 AF/yr data-center campus.</a:t>
+              <a:t>a large AI data center's water, if a fifth of Utah's yard water is waste: ~100,000 AF and 65 GWh a year.</a:t>
             </a:r>
           </a:p>
         </p:txBody>
@@ -15879,7 +16374,7 @@
         </p:nvSpPr>
         <p:spPr>
           <a:xfrm>
-            <a:off x="685800" y="5029200"/>
+            <a:off x="685800" y="5303520"/>
             <a:ext cx="10789920" cy="822960"/>
           </a:xfrm>
           <a:prstGeom prst="rect">
@@ -15908,7 +16403,7 @@
                 </a:solidFill>
                 <a:latin typeface="Nunito"/>
               </a:rPr>
-              <a:t>Per home it's small (~30 kWh a year). </a:t>
+              <a:t>Verified yard savings are how Utah grows AI without draining the lake. </a:t>
             </a:r>
             <a:r>
               <a:rPr sz="1800" b="0" i="0">
@@ -15917,7 +16412,7 @@
                 </a:solidFill>
                 <a:latin typeface="Nunito"/>
               </a:rPr>
-              <a:t>At district and state scale, verified yard savings are how Utah grows AI without draining the lake.</a:t>
+              <a:t>Live at overwater.ing/impact.</a:t>
             </a:r>
           </a:p>
         </p:txBody>
@@ -15956,7 +16451,7 @@
                 </a:solidFill>
                 <a:latin typeface="Nunito"/>
               </a:rPr>
-              <a:t>Sources: EPRI via ACEEE 2009 (650 kWh/AF, range 260–880); EIA Utah profile 2024 (1,322 lb CO₂/MWh); USU Extension citing DWR (500,993 AF/yr); SL Tribune Oct 20 2026 (Stratos estimate). Saved water can increase potential flows to the lake; it may be reused upstream.</a:t>
+              <a:t>Our neighborhoods: 12,791 lots, grass needs ~775 AF/yr; assumes half of homes overwater (BYU) on a July schedule all season. State: a fifth of 500,993 AF/yr (USU/DWR). EPRI via ACEEE (650 kWh/AF); EIA 2024 (0.60 kg CO₂/kWh); SL Tribune Oct 20 2026 (Stratos ~987 AF/yr estimate). Saved water can increase potential flows to the lake; it may be reused upstream.</a:t>
             </a:r>
           </a:p>
         </p:txBody>

</xml_diff>

<commit_message>
Pitch deck: story slide names the Utah Water Savers rebate as what Adam learned at the talk
Co-Authored-By: Claude Opus 5.5 (1M context) <noreply@anthropic.com>
</commit_message>
<xml_diff>
--- a/docs/pitch/overwatering.pptx
+++ b/docs/pitch/overwatering.pptx
@@ -1392,17 +1392,17 @@
           </a:p>
           <a:p>
             <a:r>
-              <a:t>Most of Utah's water goes on grass, and the state will pay you to replace it. We booked our own</a:t>
-            </a:r>
-          </a:p>
-          <a:p>
-            <a:r>
-              <a:t>yard consult for November. But my first question was: how much lawn do I have, and what does it</a:t>
-            </a:r>
-          </a:p>
-          <a:p>
-            <a:r>
-              <a:t>really need? Nobody could tell me.</a:t>
+              <a:t>That's where I learned about Utah Water Savers: the state will pay you up to three dollars a</a:t>
+            </a:r>
+          </a:p>
+          <a:p>
+            <a:r>
+              <a:t>square foot to replace your grass. We booked our own yard consult for November. But my first</a:t>
+            </a:r>
+          </a:p>
+          <a:p>
+            <a:r>
+              <a:t>question was: how much lawn do I have, and what does it really need? Nobody could tell me.</a:t>
             </a:r>
           </a:p>
         </p:txBody>
@@ -2172,12 +2172,12 @@
           </a:p>
           <a:p>
             <a:r>
-              <a:t>The state pays up to three dollars a square foot to replace grass. But nobody knows, lot by lot,</a:t>
-            </a:r>
-          </a:p>
-          <a:p>
-            <a:r>
-              <a:t>how much lawn there is. So I built it.</a:t>
+              <a:t>That rebate program has replaced 7.3 million square feet of grass since 2022. But nobody knows,</a:t>
+            </a:r>
+          </a:p>
+          <a:p>
+            <a:r>
+              <a:t>lot by lot, how much lawn there is. So I built it.</a:t>
             </a:r>
           </a:p>
         </p:txBody>
@@ -9100,7 +9100,7 @@
                 </a:solidFill>
                 <a:latin typeface="Nunito"/>
               </a:rPr>
-              <a:t>THAT NIGHT</a:t>
+              <a:t>WHAT I LEARNED</a:t>
             </a:r>
           </a:p>
         </p:txBody>
@@ -9142,7 +9142,7 @@
                 </a:solidFill>
                 <a:latin typeface="Fredoka"/>
               </a:rPr>
-              <a:t>Most of our water goes on grass.</a:t>
+              <a:t>Utah pays you to replace your grass.</a:t>
             </a:r>
           </a:p>
         </p:txBody>
@@ -9184,7 +9184,7 @@
                 </a:solidFill>
                 <a:latin typeface="Nunito"/>
               </a:rPr>
-              <a:t>And Utah will pay you to replace it.</a:t>
+              <a:t>Utah Water Savers: $1.50–$3 per square foot.</a:t>
             </a:r>
           </a:p>
         </p:txBody>

</xml_diff>

<commit_message>
Pitch deck: drop the two-customers slide for time; drone-scan outreach line moves to phase 3
Co-Authored-By: Claude Opus 5.5 (1M context) <noreply@anthropic.com>
</commit_message>
<xml_diff>
--- a/docs/pitch/overwatering.pptx
+++ b/docs/pitch/overwatering.pptx
@@ -27,7 +27,6 @@
     <p:sldId id="275" r:id="rId27"/>
     <p:sldId id="276" r:id="rId28"/>
     <p:sldId id="277" r:id="rId29"/>
-    <p:sldId id="278" r:id="rId30"/>
   </p:sldIdLst>
   <p:sldSz cx="12191695" cy="6858000" type="screen4x3"/>
   <p:notesSz cx="6858000" cy="9144000"/>
@@ -599,12 +598,12 @@
           <a:lstStyle/>
           <a:p>
             <a:r>
-              <a:t>[demo 1:10]</a:t>
-            </a:r>
-          </a:p>
-          <a:p>
-            <a:r>
-              <a:t>Type 603 E South Temple and pick the first result.</a:t>
+              <a:t>[demo 1:20]</a:t>
+            </a:r>
+          </a:p>
+          <a:p>
+            <a:r>
+              <a:t>6,828 sq ft of lawn on the Governor's Mansion lot, about 29 inches and 124,000 gallons a year.</a:t>
             </a:r>
           </a:p>
         </p:txBody>
@@ -674,12 +673,12 @@
           <a:lstStyle/>
           <a:p>
             <a:r>
-              <a:t>[demo 1:20]</a:t>
-            </a:r>
-          </a:p>
-          <a:p>
-            <a:r>
-              <a:t>6,828 sq ft of lawn on the Governor's Mansion lot, about 29 inches and 124,000 gallons a year.</a:t>
+              <a:t>[demo 1:55]</a:t>
+            </a:r>
+          </a:p>
+          <a:p>
+            <a:r>
+              <a:t>The before and after for this lot.</a:t>
             </a:r>
           </a:p>
         </p:txBody>
@@ -749,12 +748,12 @@
           <a:lstStyle/>
           <a:p>
             <a:r>
-              <a:t>[demo 1:55]</a:t>
-            </a:r>
-          </a:p>
-          <a:p>
-            <a:r>
-              <a:t>The before and after for this lot.</a:t>
+              <a:t>[demo 1:40]</a:t>
+            </a:r>
+          </a:p>
+          <a:p>
+            <a:r>
+              <a:t>The city, the water system and the program for this lot, plus the $100 smart controller rebate.</a:t>
             </a:r>
           </a:p>
         </p:txBody>
@@ -824,12 +823,12 @@
           <a:lstStyle/>
           <a:p>
             <a:r>
-              <a:t>[demo 1:40]</a:t>
-            </a:r>
-          </a:p>
-          <a:p>
-            <a:r>
-              <a:t>The city, the water system and the program for this lot, plus the $100 smart controller rebate.</a:t>
+              <a:t>[demo 2:05]</a:t>
+            </a:r>
+          </a:p>
+          <a:p>
+            <a:r>
+              <a:t>The single change with the most gallons saved, then the month-by-month schedule.</a:t>
             </a:r>
           </a:p>
         </p:txBody>
@@ -899,12 +898,12 @@
           <a:lstStyle/>
           <a:p>
             <a:r>
-              <a:t>[demo 2:05]</a:t>
-            </a:r>
-          </a:p>
-          <a:p>
-            <a:r>
-              <a:t>The single change with the most gallons saved, then the month-by-month schedule.</a:t>
+              <a:t>[demo 2:10]</a:t>
+            </a:r>
+          </a:p>
+          <a:p>
+            <a:r>
+              <a:t>Deep and infrequent, split into short cycles so it soaks in.</a:t>
             </a:r>
           </a:p>
         </p:txBody>
@@ -974,12 +973,12 @@
           <a:lstStyle/>
           <a:p>
             <a:r>
-              <a:t>[demo 2:10]</a:t>
-            </a:r>
-          </a:p>
-          <a:p>
-            <a:r>
-              <a:t>Deep and infrequent, split into short cycles so it soaks in.</a:t>
+              <a:t>[demo 2:20]</a:t>
+            </a:r>
+          </a:p>
+          <a:p>
+            <a:r>
+              <a:t>Subscribe once; each watering day shows up at 5 a.m. with run times.</a:t>
             </a:r>
           </a:p>
         </p:txBody>
@@ -1049,12 +1048,17 @@
           <a:lstStyle/>
           <a:p>
             <a:r>
-              <a:t>[demo 2:20]</a:t>
-            </a:r>
-          </a:p>
-          <a:p>
-            <a:r>
-              <a:t>Subscribe once; each watering day shows up at 5 a.m. with run times.</a:t>
+              <a:t>[demo 2:25]</a:t>
+            </a:r>
+          </a:p>
+          <a:p>
+            <a:r>
+              <a:t>OpenSprinkler firmware in demo mode, set by our connector. When the guide says no watering, the program is switched</a:t>
+            </a:r>
+          </a:p>
+          <a:p>
+            <a:r>
+              <a:t>off. Preview a July week and it's Monday, Wednesday, Friday at 5 a.m., four 7-minute cycles per zone.</a:t>
             </a:r>
           </a:p>
         </p:txBody>
@@ -1124,17 +1128,12 @@
           <a:lstStyle/>
           <a:p>
             <a:r>
-              <a:t>[demo 2:25]</a:t>
-            </a:r>
-          </a:p>
-          <a:p>
-            <a:r>
-              <a:t>OpenSprinkler firmware in demo mode, set by our connector. When the guide says no watering, the program is switched</a:t>
-            </a:r>
-          </a:p>
-          <a:p>
-            <a:r>
-              <a:t>off. Preview a July week and it's Monday, Wednesday, Friday at 5 a.m., four 7-minute cycles per zone.</a:t>
+              <a:t>[demo 2:30]</a:t>
+            </a:r>
+          </a:p>
+          <a:p>
+            <a:r>
+              <a:t>Rachio and Home Assistant cover most smart controllers sold in Utah; OpenSprinkler is the open-hardware path.</a:t>
             </a:r>
           </a:p>
         </p:txBody>
@@ -1204,12 +1203,12 @@
           <a:lstStyle/>
           <a:p>
             <a:r>
-              <a:t>[demo 2:30]</a:t>
-            </a:r>
-          </a:p>
-          <a:p>
-            <a:r>
-              <a:t>Rachio and Home Assistant cover most smart controllers sold in Utah; OpenSprinkler is the open-hardware path.</a:t>
+              <a:t>[optional]</a:t>
+            </a:r>
+          </a:p>
+          <a:p>
+            <a:r>
+              <a:t>Upload the sample bill. Claude reads twelve months; the page shows the overwatering gap.</a:t>
             </a:r>
           </a:p>
         </p:txBody>
@@ -1279,12 +1278,12 @@
           <a:lstStyle/>
           <a:p>
             <a:r>
-              <a:t>[optional]</a:t>
-            </a:r>
-          </a:p>
-          <a:p>
-            <a:r>
-              <a:t>Upload the sample bill. Claude reads twelve months; the page shows the overwatering gap.</a:t>
+              <a:t>[demo 2:50]</a:t>
+            </a:r>
+          </a:p>
+          <a:p>
+            <a:r>
+              <a:t>Any Utah address is measured live in the browser in seconds.</a:t>
             </a:r>
           </a:p>
         </p:txBody>
@@ -1444,12 +1443,12 @@
           <a:lstStyle/>
           <a:p>
             <a:r>
-              <a:t>[demo 2:50]</a:t>
-            </a:r>
-          </a:p>
-          <a:p>
-            <a:r>
-              <a:t>Any Utah address is measured live in the browser in seconds.</a:t>
+              <a:t>[backup]</a:t>
+            </a:r>
+          </a:p>
+          <a:p>
+            <a:r>
+              <a:t>What a district sees: lawn, need, likely overwatering and savings for a whole neighborhood.</a:t>
             </a:r>
           </a:p>
         </p:txBody>
@@ -1524,7 +1523,7 @@
           </a:p>
           <a:p>
             <a:r>
-              <a:t>What a district sees: lawn, need, likely overwatering and savings for a whole neighborhood.</a:t>
+              <a:t>Utah-scale numbers, live on the site.</a:t>
             </a:r>
           </a:p>
         </p:txBody>
@@ -1594,81 +1593,6 @@
           <a:lstStyle/>
           <a:p>
             <a:r>
-              <a:t>[backup]</a:t>
-            </a:r>
-          </a:p>
-          <a:p>
-            <a:r>
-              <a:t>Utah-scale numbers, live on the site.</a:t>
-            </a:r>
-          </a:p>
-        </p:txBody>
-      </p:sp>
-      <p:sp>
-        <p:nvSpPr>
-          <p:cNvPr id="4" name="Slide Number Placeholder 3"/>
-          <p:cNvSpPr>
-            <a:spLocks noGrp="1"/>
-          </p:cNvSpPr>
-          <p:nvPr>
-            <p:ph type="sldNum" idx="5" sz="quarter"/>
-          </p:nvPr>
-        </p:nvSpPr>
-        <p:spPr/>
-      </p:sp>
-    </p:spTree>
-  </p:cSld>
-  <p:clrMapOvr>
-    <a:masterClrMapping/>
-  </p:clrMapOvr>
-</p:notes>
-</file>
-
-<file path=ppt/notesSlides/notesSlide23.xml><?xml version="1.0" encoding="utf-8"?>
-<p:notes xmlns:a="http://schemas.openxmlformats.org/drawingml/2006/main" xmlns:p="http://schemas.openxmlformats.org/presentationml/2006/main" xmlns:r="http://schemas.openxmlformats.org/officeDocument/2006/relationships">
-  <p:cSld>
-    <p:spTree>
-      <p:nvGrpSpPr>
-        <p:cNvPr id="1" name=""/>
-        <p:cNvGrpSpPr/>
-        <p:nvPr/>
-      </p:nvGrpSpPr>
-      <p:grpSpPr>
-        <a:xfrm>
-          <a:off x="0" y="0"/>
-          <a:ext cx="0" cy="0"/>
-          <a:chOff x="0" y="0"/>
-          <a:chExt cx="0" cy="0"/>
-        </a:xfrm>
-      </p:grpSpPr>
-      <p:sp>
-        <p:nvSpPr>
-          <p:cNvPr id="2" name="Slide Image Placeholder 1"/>
-          <p:cNvSpPr>
-            <a:spLocks noGrp="1"/>
-          </p:cNvSpPr>
-          <p:nvPr>
-            <p:ph type="sldImg" idx="2"/>
-          </p:nvPr>
-        </p:nvSpPr>
-        <p:spPr/>
-      </p:sp>
-      <p:sp>
-        <p:nvSpPr>
-          <p:cNvPr id="3" name="Notes Placeholder 2"/>
-          <p:cNvSpPr>
-            <a:spLocks noGrp="1"/>
-          </p:cNvSpPr>
-          <p:nvPr>
-            <p:ph type="body" idx="3" sz="quarter"/>
-          </p:nvPr>
-        </p:nvSpPr>
-        <p:spPr/>
-        <p:txBody>
-          <a:bodyPr/>
-          <a:lstStyle/>
-          <a:p>
-            <a:r>
               <a:t>[reference]</a:t>
             </a:r>
           </a:p>
@@ -2089,7 +2013,12 @@
           </a:p>
           <a:p>
             <a:r>
-              <a:t>sprinkler head waters only the patch that needs it.</a:t>
+              <a:t>sprinkler head waters only the patch that needs it, and the state can spot overwatering from</a:t>
+            </a:r>
+          </a:p>
+          <a:p>
+            <a:r>
+              <a:t>the air before a bill ever shows it.</a:t>
             </a:r>
           </a:p>
         </p:txBody>
@@ -2159,27 +2088,27 @@
           <a:lstStyle/>
           <a:p>
             <a:r>
-              <a:t>[3:45–4:15]</a:t>
-            </a:r>
-          </a:p>
-          <a:p>
-            <a:r>
-              <a:t>Two customers. Cities, districts and the state already pay for rebate outreach; we show them</a:t>
-            </a:r>
-          </a:p>
-          <a:p>
-            <a:r>
-              <a:t>every lot's lawn and need, so that money goes where the savings are. With drone scans, they</a:t>
-            </a:r>
-          </a:p>
-          <a:p>
-            <a:r>
-              <a:t>could spot overwatering from the air, before a bill ever shows it. Homeowners get their lawn,</a:t>
-            </a:r>
-          </a:p>
-          <a:p>
-            <a:r>
-              <a:t>their rebate, and a schedule that runs itself, down to each sprinkler head.</a:t>
+              <a:t>[3:45–4:05]</a:t>
+            </a:r>
+          </a:p>
+          <a:p>
+            <a:r>
+              <a:t>So here's the ask: ten thousand dollars for phase two, a pilot that runs real sprinklers. And</a:t>
+            </a:r>
+          </a:p>
+          <a:p>
+            <a:r>
+              <a:t>introductions: to Utah's water-wise partners, to a district's conservation team, and to drone</a:t>
+            </a:r>
+          </a:p>
+          <a:p>
+            <a:r>
+              <a:t>training academies that could fly LiDAR scans with us. And right now, take out your phone and</a:t>
+            </a:r>
+          </a:p>
+          <a:p>
+            <a:r>
+              <a:t>type your address at overwater.ing. Thank you.</a:t>
             </a:r>
           </a:p>
         </p:txBody>
@@ -2249,27 +2178,12 @@
           <a:lstStyle/>
           <a:p>
             <a:r>
-              <a:t>[4:15–4:35]</a:t>
-            </a:r>
-          </a:p>
-          <a:p>
-            <a:r>
-              <a:t>So here's the ask: ten thousand dollars for phase two, a pilot that runs real sprinklers. And</a:t>
-            </a:r>
-          </a:p>
-          <a:p>
-            <a:r>
-              <a:t>introductions: to Utah's water-wise partners, to a district's conservation team, and to drone</a:t>
-            </a:r>
-          </a:p>
-          <a:p>
-            <a:r>
-              <a:t>training academies that could fly LiDAR scans with us. And right now, take out your phone and</a:t>
-            </a:r>
-          </a:p>
-          <a:p>
-            <a:r>
-              <a:t>type your address at overwater.ing. Thank you.</a:t>
+              <a:t>[backup]</a:t>
+            </a:r>
+          </a:p>
+          <a:p>
+            <a:r>
+              <a:t>Only if the live demo fails. Each following slide matches one demo step in demo.md.</a:t>
             </a:r>
           </a:p>
         </p:txBody>
@@ -2339,12 +2253,12 @@
           <a:lstStyle/>
           <a:p>
             <a:r>
-              <a:t>[backup]</a:t>
-            </a:r>
-          </a:p>
-          <a:p>
-            <a:r>
-              <a:t>Only if the live demo fails. Each following slide matches one demo step in demo.md.</a:t>
+              <a:t>[demo 1:10]</a:t>
+            </a:r>
+          </a:p>
+          <a:p>
+            <a:r>
+              <a:t>Type 603 E South Temple and pick the first result.</a:t>
             </a:r>
           </a:p>
         </p:txBody>
@@ -5655,7 +5569,7 @@
                 </a:solidFill>
                 <a:latin typeface="Fredoka"/>
               </a:rPr>
-              <a:t>1 · Enter any Utah address</a:t>
+              <a:t>2 · Confirm what's grass</a:t>
             </a:r>
           </a:p>
         </p:txBody>
@@ -5708,7 +5622,7 @@
       </p:sp>
       <p:pic>
         <p:nvPicPr>
-          <p:cNvPr id="4" name="Picture 3" descr="02-search.jpg"/>
+          <p:cNvPr id="4" name="Picture 3" descr="03-lot.jpg"/>
           <p:cNvPicPr>
             <a:picLocks noChangeAspect="1"/>
           </p:cNvPicPr>
@@ -5739,7 +5653,7 @@
         <p:spPr>
           <a:xfrm>
             <a:off x="8531352" y="1124712"/>
-            <a:ext cx="3054096" cy="996836"/>
+            <a:ext cx="3054096" cy="1785408"/>
           </a:xfrm>
           <a:prstGeom prst="roundRect">
             <a:avLst>
@@ -5778,7 +5692,7 @@
       </p:sp>
       <p:pic>
         <p:nvPicPr>
-          <p:cNvPr id="6" name="Picture 5" descr="flow-1-search.jpg"/>
+          <p:cNvPr id="6" name="Picture 5" descr="flow-2-lawn-zoom.jpg"/>
           <p:cNvPicPr>
             <a:picLocks noChangeAspect="1"/>
           </p:cNvPicPr>
@@ -5793,7 +5707,7 @@
         <p:spPr>
           <a:xfrm>
             <a:off x="8595360" y="1188720"/>
-            <a:ext cx="2926080" cy="868820"/>
+            <a:ext cx="2926080" cy="1657392"/>
           </a:xfrm>
           <a:prstGeom prst="rect">
             <a:avLst/>
@@ -5808,8 +5722,8 @@
         </p:nvSpPr>
         <p:spPr>
           <a:xfrm>
-            <a:off x="8595360" y="2331860"/>
-            <a:ext cx="2926080" cy="3566019"/>
+            <a:off x="8595360" y="3120432"/>
+            <a:ext cx="2926080" cy="2777447"/>
           </a:xfrm>
           <a:prstGeom prst="rect">
             <a:avLst/>
@@ -5837,7 +5751,7 @@
                 </a:solidFill>
                 <a:latin typeface="Nunito"/>
               </a:rPr>
-              <a:t>Search covers parcels in all 29 counties.</a:t>
+              <a:t>2024 USDA imagery at 0.6 m. Green = lawn, dark green = trees, red = buildings. Tap a shape to fix it. 6,828 sq ft of lawn here.</a:t>
             </a:r>
           </a:p>
         </p:txBody>
@@ -5902,7 +5816,7 @@
                 </a:solidFill>
                 <a:latin typeface="Fredoka"/>
               </a:rPr>
-              <a:t>2 · Confirm what's grass</a:t>
+              <a:t>3 · What going native saves</a:t>
             </a:r>
           </a:p>
         </p:txBody>
@@ -5955,7 +5869,7 @@
       </p:sp>
       <p:pic>
         <p:nvPicPr>
-          <p:cNvPr id="4" name="Picture 3" descr="03-lot.jpg"/>
+          <p:cNvPr id="4" name="Picture 3" descr="07-native.jpg"/>
           <p:cNvPicPr>
             <a:picLocks noChangeAspect="1"/>
           </p:cNvPicPr>
@@ -5986,7 +5900,7 @@
         <p:spPr>
           <a:xfrm>
             <a:off x="8531352" y="1124712"/>
-            <a:ext cx="3054096" cy="1785408"/>
+            <a:ext cx="3054096" cy="1763813"/>
           </a:xfrm>
           <a:prstGeom prst="roundRect">
             <a:avLst>
@@ -6025,7 +5939,7 @@
       </p:sp>
       <p:pic>
         <p:nvPicPr>
-          <p:cNvPr id="6" name="Picture 5" descr="flow-2-lawn-zoom.jpg"/>
+          <p:cNvPr id="6" name="Picture 5" descr="flow-3-native.jpg"/>
           <p:cNvPicPr>
             <a:picLocks noChangeAspect="1"/>
           </p:cNvPicPr>
@@ -6040,7 +5954,7 @@
         <p:spPr>
           <a:xfrm>
             <a:off x="8595360" y="1188720"/>
-            <a:ext cx="2926080" cy="1657392"/>
+            <a:ext cx="2926080" cy="1635797"/>
           </a:xfrm>
           <a:prstGeom prst="rect">
             <a:avLst/>
@@ -6055,8 +5969,8 @@
         </p:nvSpPr>
         <p:spPr>
           <a:xfrm>
-            <a:off x="8595360" y="3120432"/>
-            <a:ext cx="2926080" cy="2777447"/>
+            <a:off x="8595360" y="3098837"/>
+            <a:ext cx="2926080" cy="2799042"/>
           </a:xfrm>
           <a:prstGeom prst="rect">
             <a:avLst/>
@@ -6084,7 +5998,7 @@
                 </a:solidFill>
                 <a:latin typeface="Nunito"/>
               </a:rPr>
-              <a:t>2024 USDA imagery at 0.6 m. Green = lawn, dark green = trees, red = buildings. Tap a shape to fix it. 6,828 sq ft of lawn here.</a:t>
+              <a:t>About 89,236 gallons a year for this lot, then the plants and the designers to call.</a:t>
             </a:r>
           </a:p>
         </p:txBody>
@@ -6149,7 +6063,7 @@
                 </a:solidFill>
                 <a:latin typeface="Fredoka"/>
               </a:rPr>
-              <a:t>3 · What going native saves</a:t>
+              <a:t>3 · The rebate, and who's in charge here</a:t>
             </a:r>
           </a:p>
         </p:txBody>
@@ -6202,7 +6116,7 @@
       </p:sp>
       <p:pic>
         <p:nvPicPr>
-          <p:cNvPr id="4" name="Picture 3" descr="07-native.jpg"/>
+          <p:cNvPr id="4" name="Picture 3" descr="08-rebate.jpg"/>
           <p:cNvPicPr>
             <a:picLocks noChangeAspect="1"/>
           </p:cNvPicPr>
@@ -6233,7 +6147,7 @@
         <p:spPr>
           <a:xfrm>
             <a:off x="8531352" y="1124712"/>
-            <a:ext cx="3054096" cy="1763813"/>
+            <a:ext cx="3054096" cy="3469793"/>
           </a:xfrm>
           <a:prstGeom prst="roundRect">
             <a:avLst>
@@ -6272,7 +6186,7 @@
       </p:sp>
       <p:pic>
         <p:nvPicPr>
-          <p:cNvPr id="6" name="Picture 5" descr="flow-3-native.jpg"/>
+          <p:cNvPr id="6" name="Picture 5" descr="flow-3-rebate-zoom.jpg"/>
           <p:cNvPicPr>
             <a:picLocks noChangeAspect="1"/>
           </p:cNvPicPr>
@@ -6287,7 +6201,7 @@
         <p:spPr>
           <a:xfrm>
             <a:off x="8595360" y="1188720"/>
-            <a:ext cx="2926080" cy="1635797"/>
+            <a:ext cx="2926080" cy="3341777"/>
           </a:xfrm>
           <a:prstGeom prst="rect">
             <a:avLst/>
@@ -6302,8 +6216,8 @@
         </p:nvSpPr>
         <p:spPr>
           <a:xfrm>
-            <a:off x="8595360" y="3098837"/>
-            <a:ext cx="2926080" cy="2799042"/>
+            <a:off x="8595360" y="4804817"/>
+            <a:ext cx="2926080" cy="1093062"/>
           </a:xfrm>
           <a:prstGeom prst="rect">
             <a:avLst/>
@@ -6331,7 +6245,7 @@
                 </a:solidFill>
                 <a:latin typeface="Nunito"/>
               </a:rPr>
-              <a:t>About 89,236 gallons a year for this lot, then the plants and the designers to call.</a:t>
+              <a:t>Up to $20,484 from Central Utah Water Conservancy District. City, water provider and program for this exact lot.</a:t>
             </a:r>
           </a:p>
         </p:txBody>
@@ -6396,7 +6310,7 @@
                 </a:solidFill>
                 <a:latin typeface="Fredoka"/>
               </a:rPr>
-              <a:t>3 · The rebate, and who's in charge here</a:t>
+              <a:t>4 · Lower your water use today</a:t>
             </a:r>
           </a:p>
         </p:txBody>
@@ -6449,7 +6363,7 @@
       </p:sp>
       <p:pic>
         <p:nvPicPr>
-          <p:cNvPr id="4" name="Picture 3" descr="08-rebate.jpg"/>
+          <p:cNvPr id="4" name="Picture 3" descr="05-watering-plan.jpg"/>
           <p:cNvPicPr>
             <a:picLocks noChangeAspect="1"/>
           </p:cNvPicPr>
@@ -6480,7 +6394,7 @@
         <p:spPr>
           <a:xfrm>
             <a:off x="8531352" y="1124712"/>
-            <a:ext cx="3054096" cy="3469793"/>
+            <a:ext cx="3054096" cy="684014"/>
           </a:xfrm>
           <a:prstGeom prst="roundRect">
             <a:avLst>
@@ -6519,7 +6433,7 @@
       </p:sp>
       <p:pic>
         <p:nvPicPr>
-          <p:cNvPr id="6" name="Picture 5" descr="flow-3-rebate-zoom.jpg"/>
+          <p:cNvPr id="6" name="Picture 5" descr="flow-4-plan-zoom.jpg"/>
           <p:cNvPicPr>
             <a:picLocks noChangeAspect="1"/>
           </p:cNvPicPr>
@@ -6534,7 +6448,7 @@
         <p:spPr>
           <a:xfrm>
             <a:off x="8595360" y="1188720"/>
-            <a:ext cx="2926080" cy="3341777"/>
+            <a:ext cx="2926080" cy="555998"/>
           </a:xfrm>
           <a:prstGeom prst="rect">
             <a:avLst/>
@@ -6549,8 +6463,8 @@
         </p:nvSpPr>
         <p:spPr>
           <a:xfrm>
-            <a:off x="8595360" y="4804817"/>
-            <a:ext cx="2926080" cy="1093062"/>
+            <a:off x="8595360" y="2019038"/>
+            <a:ext cx="2926080" cy="3878841"/>
           </a:xfrm>
           <a:prstGeom prst="rect">
             <a:avLst/>
@@ -6578,7 +6492,7 @@
                 </a:solidFill>
                 <a:latin typeface="Nunito"/>
               </a:rPr>
-              <a:t>Up to $20,484 from Central Utah Water Conservancy District. City, water provider and program for this exact lot.</a:t>
+              <a:t>Spray heads and a basic timer, in this county's weather: one thing to change.</a:t>
             </a:r>
           </a:p>
         </p:txBody>
@@ -6643,7 +6557,7 @@
                 </a:solidFill>
                 <a:latin typeface="Fredoka"/>
               </a:rPr>
-              <a:t>4 · Lower your water use today</a:t>
+              <a:t>4 · The schedule</a:t>
             </a:r>
           </a:p>
         </p:txBody>
@@ -6656,7 +6570,7 @@
         </p:nvSpPr>
         <p:spPr>
           <a:xfrm>
-            <a:off x="621792" y="1124712"/>
+            <a:off x="2264511" y="1124712"/>
             <a:ext cx="7662672" cy="4837176"/>
           </a:xfrm>
           <a:prstGeom prst="roundRect">
@@ -6696,7 +6610,7 @@
       </p:sp>
       <p:pic>
         <p:nvPicPr>
-          <p:cNvPr id="4" name="Picture 3" descr="05-watering-plan.jpg"/>
+          <p:cNvPr id="4" name="Picture 3" descr="05-watering-schedule.jpg"/>
           <p:cNvPicPr>
             <a:picLocks noChangeAspect="1"/>
           </p:cNvPicPr>
@@ -6710,7 +6624,7 @@
         </p:blipFill>
         <p:spPr>
           <a:xfrm>
-            <a:off x="685800" y="1188720"/>
+            <a:off x="2328519" y="1188720"/>
             <a:ext cx="7534656" cy="4709160"/>
           </a:xfrm>
           <a:prstGeom prst="rect">
@@ -6720,84 +6634,14 @@
       </p:pic>
       <p:sp>
         <p:nvSpPr>
-          <p:cNvPr id="5" name="Rounded Rectangle 4"/>
-          <p:cNvSpPr/>
-          <p:nvPr/>
-        </p:nvSpPr>
-        <p:spPr>
-          <a:xfrm>
-            <a:off x="8531352" y="1124712"/>
-            <a:ext cx="3054096" cy="684014"/>
-          </a:xfrm>
-          <a:prstGeom prst="roundRect">
-            <a:avLst>
-              <a:gd name="adj" fmla="val 3000"/>
-            </a:avLst>
-          </a:prstGeom>
-          <a:solidFill>
-            <a:srgbClr val="FFFFFF"/>
-          </a:solidFill>
-          <a:ln w="25400">
-            <a:solidFill>
-              <a:srgbClr val="CFE6F5"/>
-            </a:solidFill>
-          </a:ln>
-          <a:effectLst/>
-        </p:spPr>
-        <p:style>
-          <a:lnRef idx="1">
-            <a:schemeClr val="accent1"/>
-          </a:lnRef>
-          <a:fillRef idx="3">
-            <a:schemeClr val="accent1"/>
-          </a:fillRef>
-          <a:effectRef idx="2">
-            <a:schemeClr val="accent1"/>
-          </a:effectRef>
-          <a:fontRef idx="minor">
-            <a:schemeClr val="lt1"/>
-          </a:fontRef>
-        </p:style>
-        <p:txBody>
-          <a:bodyPr rtlCol="0" anchor="ctr"/>
-          <a:lstStyle/>
-          <a:p/>
-        </p:txBody>
-      </p:sp>
-      <p:pic>
-        <p:nvPicPr>
-          <p:cNvPr id="6" name="Picture 5" descr="flow-4-plan-zoom.jpg"/>
-          <p:cNvPicPr>
-            <a:picLocks noChangeAspect="1"/>
-          </p:cNvPicPr>
-          <p:nvPr/>
-        </p:nvPicPr>
-        <p:blipFill>
-          <a:blip r:embed="rId3"/>
-          <a:stretch>
-            <a:fillRect/>
-          </a:stretch>
-        </p:blipFill>
-        <p:spPr>
-          <a:xfrm>
-            <a:off x="8595360" y="1188720"/>
-            <a:ext cx="2926080" cy="555998"/>
-          </a:xfrm>
-          <a:prstGeom prst="rect">
-            <a:avLst/>
-          </a:prstGeom>
-        </p:spPr>
-      </p:pic>
-      <p:sp>
-        <p:nvSpPr>
-          <p:cNvPr id="7" name="TextBox 6"/>
+          <p:cNvPr id="5" name="TextBox 4"/>
           <p:cNvSpPr txBox="1"/>
           <p:nvPr/>
         </p:nvSpPr>
         <p:spPr>
           <a:xfrm>
-            <a:off x="8595360" y="2019038"/>
-            <a:ext cx="2926080" cy="3878841"/>
+            <a:off x="685800" y="6080760"/>
+            <a:ext cx="10789920" cy="548640"/>
           </a:xfrm>
           <a:prstGeom prst="rect">
             <a:avLst/>
@@ -6810,22 +6654,19 @@
           </a:bodyPr>
           <a:lstStyle/>
           <a:p>
-            <a:pPr algn="l">
-              <a:lnSpc>
-                <a:spcPct val="115000"/>
-              </a:lnSpc>
+            <a:pPr algn="ctr">
               <a:spcAft>
                 <a:spcPts val="0"/>
               </a:spcAft>
             </a:pPr>
             <a:r>
-              <a:rPr sz="1400" b="0" i="0">
-                <a:solidFill>
-                  <a:srgbClr val="12324A"/>
+              <a:rPr sz="1500" b="0" i="0">
+                <a:solidFill>
+                  <a:srgbClr val="4F6B80"/>
                 </a:solidFill>
                 <a:latin typeface="Nunito"/>
               </a:rPr>
-              <a:t>Spray heads and a basic timer, in this county's weather: one thing to change.</a:t>
+              <a:t>Days a week and cycle-and-soak minutes per zone, from local weather.</a:t>
             </a:r>
           </a:p>
         </p:txBody>
@@ -6890,7 +6731,7 @@
                 </a:solidFill>
                 <a:latin typeface="Fredoka"/>
               </a:rPr>
-              <a:t>4 · The schedule</a:t>
+              <a:t>4 · Subscribe to the watering calendar</a:t>
             </a:r>
           </a:p>
         </p:txBody>
@@ -6943,7 +6784,7 @@
       </p:sp>
       <p:pic>
         <p:nvPicPr>
-          <p:cNvPr id="4" name="Picture 3" descr="05-watering-schedule.jpg"/>
+          <p:cNvPr id="4" name="Picture 3" descr="06-calendar.jpg"/>
           <p:cNvPicPr>
             <a:picLocks noChangeAspect="1"/>
           </p:cNvPicPr>
@@ -6999,7 +6840,7 @@
                 </a:solidFill>
                 <a:latin typeface="Nunito"/>
               </a:rPr>
-              <a:t>Days a week and cycle-and-soak minutes per zone, from local weather.</a:t>
+              <a:t>It follows Utah's Weekly Lawn Watering Guide; skip weeks clear themselves.</a:t>
             </a:r>
           </a:p>
         </p:txBody>
@@ -7064,21 +6905,99 @@
                 </a:solidFill>
                 <a:latin typeface="Fredoka"/>
               </a:rPr>
-              <a:t>4 · Subscribe to the watering calendar</a:t>
-            </a:r>
-          </a:p>
-        </p:txBody>
-      </p:sp>
-      <p:sp>
-        <p:nvSpPr>
-          <p:cNvPr id="3" name="Rounded Rectangle 2"/>
+              <a:t>4 · The controller follows the schedule</a:t>
+            </a:r>
+          </a:p>
+        </p:txBody>
+      </p:sp>
+      <p:sp>
+        <p:nvSpPr>
+          <p:cNvPr id="3" name="TextBox 2"/>
+          <p:cNvSpPr txBox="1"/>
+          <p:nvPr/>
+        </p:nvSpPr>
+        <p:spPr>
+          <a:xfrm>
+            <a:off x="685800" y="1143000"/>
+            <a:ext cx="5212080" cy="548640"/>
+          </a:xfrm>
+          <a:prstGeom prst="rect">
+            <a:avLst/>
+          </a:prstGeom>
+          <a:noFill/>
+        </p:spPr>
+        <p:txBody>
+          <a:bodyPr wrap="square" anchor="t" lIns="18288" rIns="18288" tIns="18288" bIns="18288">
+            <a:noAutofit/>
+          </a:bodyPr>
+          <a:lstStyle/>
+          <a:p>
+            <a:pPr algn="l">
+              <a:spcAft>
+                <a:spcPts val="0"/>
+              </a:spcAft>
+            </a:pPr>
+            <a:r>
+              <a:rPr sz="2600" b="1" i="0">
+                <a:solidFill>
+                  <a:srgbClr val="E5533F"/>
+                </a:solidFill>
+                <a:latin typeface="Fredoka"/>
+              </a:rPr>
+              <a:t>When the state says skip: off</a:t>
+            </a:r>
+          </a:p>
+        </p:txBody>
+      </p:sp>
+      <p:sp>
+        <p:nvSpPr>
+          <p:cNvPr id="4" name="TextBox 3"/>
+          <p:cNvSpPr txBox="1"/>
+          <p:nvPr/>
+        </p:nvSpPr>
+        <p:spPr>
+          <a:xfrm>
+            <a:off x="6309360" y="1143000"/>
+            <a:ext cx="5212080" cy="548640"/>
+          </a:xfrm>
+          <a:prstGeom prst="rect">
+            <a:avLst/>
+          </a:prstGeom>
+          <a:noFill/>
+        </p:spPr>
+        <p:txBody>
+          <a:bodyPr wrap="square" anchor="t" lIns="18288" rIns="18288" tIns="18288" bIns="18288">
+            <a:noAutofit/>
+          </a:bodyPr>
+          <a:lstStyle/>
+          <a:p>
+            <a:pPr algn="l">
+              <a:spcAft>
+                <a:spcPts val="0"/>
+              </a:spcAft>
+            </a:pPr>
+            <a:r>
+              <a:rPr sz="2600" b="1" i="0">
+                <a:solidFill>
+                  <a:srgbClr val="2C9A4B"/>
+                </a:solidFill>
+                <a:latin typeface="Fredoka"/>
+              </a:rPr>
+              <a:t>A July week: on</a:t>
+            </a:r>
+          </a:p>
+        </p:txBody>
+      </p:sp>
+      <p:sp>
+        <p:nvSpPr>
+          <p:cNvPr id="5" name="Rounded Rectangle 4"/>
           <p:cNvSpPr/>
           <p:nvPr/>
         </p:nvSpPr>
         <p:spPr>
           <a:xfrm>
-            <a:off x="2264511" y="1124712"/>
-            <a:ext cx="7662672" cy="4837176"/>
+            <a:off x="621792" y="1719072"/>
+            <a:ext cx="5248655" cy="1792224"/>
           </a:xfrm>
           <a:prstGeom prst="roundRect">
             <a:avLst>
@@ -7117,7 +7036,7 @@
       </p:sp>
       <p:pic>
         <p:nvPicPr>
-          <p:cNvPr id="4" name="Picture 3" descr="06-calendar.jpg"/>
+          <p:cNvPr id="6" name="Picture 5" descr="06-os-paused-full-enabled.jpg"/>
           <p:cNvPicPr>
             <a:picLocks noChangeAspect="1"/>
           </p:cNvPicPr>
@@ -7131,8 +7050,8 @@
         </p:blipFill>
         <p:spPr>
           <a:xfrm>
-            <a:off x="2328519" y="1188720"/>
-            <a:ext cx="7534656" cy="4709160"/>
+            <a:off x="685800" y="1783080"/>
+            <a:ext cx="5120640" cy="1664207"/>
           </a:xfrm>
           <a:prstGeom prst="rect">
             <a:avLst/>
@@ -7141,14 +7060,84 @@
       </p:pic>
       <p:sp>
         <p:nvSpPr>
-          <p:cNvPr id="5" name="TextBox 4"/>
+          <p:cNvPr id="7" name="Rounded Rectangle 6"/>
+          <p:cNvSpPr/>
+          <p:nvPr/>
+        </p:nvSpPr>
+        <p:spPr>
+          <a:xfrm>
+            <a:off x="6245352" y="1719072"/>
+            <a:ext cx="5248655" cy="1792224"/>
+          </a:xfrm>
+          <a:prstGeom prst="roundRect">
+            <a:avLst>
+              <a:gd name="adj" fmla="val 3000"/>
+            </a:avLst>
+          </a:prstGeom>
+          <a:solidFill>
+            <a:srgbClr val="FFFFFF"/>
+          </a:solidFill>
+          <a:ln w="25400">
+            <a:solidFill>
+              <a:srgbClr val="CFE6F5"/>
+            </a:solidFill>
+          </a:ln>
+          <a:effectLst/>
+        </p:spPr>
+        <p:style>
+          <a:lnRef idx="1">
+            <a:schemeClr val="accent1"/>
+          </a:lnRef>
+          <a:fillRef idx="3">
+            <a:schemeClr val="accent1"/>
+          </a:fillRef>
+          <a:effectRef idx="2">
+            <a:schemeClr val="accent1"/>
+          </a:effectRef>
+          <a:fontRef idx="minor">
+            <a:schemeClr val="lt1"/>
+          </a:fontRef>
+        </p:style>
+        <p:txBody>
+          <a:bodyPr rtlCol="0" anchor="ctr"/>
+          <a:lstStyle/>
+          <a:p/>
+        </p:txBody>
+      </p:sp>
+      <p:pic>
+        <p:nvPicPr>
+          <p:cNvPr id="8" name="Picture 7" descr="06-os-july-full-enabled.jpg"/>
+          <p:cNvPicPr>
+            <a:picLocks noChangeAspect="1"/>
+          </p:cNvPicPr>
+          <p:nvPr/>
+        </p:nvPicPr>
+        <p:blipFill>
+          <a:blip r:embed="rId3"/>
+          <a:stretch>
+            <a:fillRect/>
+          </a:stretch>
+        </p:blipFill>
+        <p:spPr>
+          <a:xfrm>
+            <a:off x="6309360" y="1783080"/>
+            <a:ext cx="5120640" cy="1664207"/>
+          </a:xfrm>
+          <a:prstGeom prst="rect">
+            <a:avLst/>
+          </a:prstGeom>
+        </p:spPr>
+      </p:pic>
+      <p:sp>
+        <p:nvSpPr>
+          <p:cNvPr id="9" name="TextBox 8"/>
           <p:cNvSpPr txBox="1"/>
           <p:nvPr/>
         </p:nvSpPr>
         <p:spPr>
           <a:xfrm>
-            <a:off x="685800" y="6080760"/>
-            <a:ext cx="10789920" cy="548640"/>
+            <a:off x="685800" y="3703320"/>
+            <a:ext cx="5120640" cy="1371600"/>
           </a:xfrm>
           <a:prstGeom prst="rect">
             <a:avLst/>
@@ -7161,19 +7150,176 @@
           </a:bodyPr>
           <a:lstStyle/>
           <a:p>
-            <a:pPr algn="ctr">
+            <a:pPr algn="l">
+              <a:lnSpc>
+                <a:spcPct val="115000"/>
+              </a:lnSpc>
               <a:spcAft>
                 <a:spcPts val="0"/>
               </a:spcAft>
             </a:pPr>
             <a:r>
-              <a:rPr sz="1500" b="0" i="0">
-                <a:solidFill>
-                  <a:srgbClr val="4F6B80"/>
+              <a:rPr sz="1700" b="0" i="0">
+                <a:solidFill>
+                  <a:srgbClr val="12324A"/>
                 </a:solidFill>
                 <a:latin typeface="Nunito"/>
               </a:rPr>
-              <a:t>It follows Utah's Weekly Lawn Watering Guide; skip weeks clear themselves.</a:t>
+              <a:t>Utah's Weekly Lawn Watering Guide said no watering in Salt Lake County, so the connector switched the program off. Other programs are untouched.</a:t>
+            </a:r>
+          </a:p>
+        </p:txBody>
+      </p:sp>
+      <p:sp>
+        <p:nvSpPr>
+          <p:cNvPr id="10" name="Rounded Rectangle 9"/>
+          <p:cNvSpPr/>
+          <p:nvPr/>
+        </p:nvSpPr>
+        <p:spPr>
+          <a:xfrm>
+            <a:off x="6245352" y="3639312"/>
+            <a:ext cx="3328416" cy="2608326"/>
+          </a:xfrm>
+          <a:prstGeom prst="roundRect">
+            <a:avLst>
+              <a:gd name="adj" fmla="val 3000"/>
+            </a:avLst>
+          </a:prstGeom>
+          <a:solidFill>
+            <a:srgbClr val="FFFFFF"/>
+          </a:solidFill>
+          <a:ln w="25400">
+            <a:solidFill>
+              <a:srgbClr val="CFE6F5"/>
+            </a:solidFill>
+          </a:ln>
+          <a:effectLst/>
+        </p:spPr>
+        <p:style>
+          <a:lnRef idx="1">
+            <a:schemeClr val="accent1"/>
+          </a:lnRef>
+          <a:fillRef idx="3">
+            <a:schemeClr val="accent1"/>
+          </a:fillRef>
+          <a:effectRef idx="2">
+            <a:schemeClr val="accent1"/>
+          </a:effectRef>
+          <a:fontRef idx="minor">
+            <a:schemeClr val="lt1"/>
+          </a:fontRef>
+        </p:style>
+        <p:txBody>
+          <a:bodyPr rtlCol="0" anchor="ctr"/>
+          <a:lstStyle/>
+          <a:p/>
+        </p:txBody>
+      </p:sp>
+      <p:pic>
+        <p:nvPicPr>
+          <p:cNvPr id="11" name="Picture 10" descr="06-os-july-full-stations.jpg"/>
+          <p:cNvPicPr>
+            <a:picLocks noChangeAspect="1"/>
+          </p:cNvPicPr>
+          <p:nvPr/>
+        </p:nvPicPr>
+        <p:blipFill>
+          <a:blip r:embed="rId4"/>
+          <a:stretch>
+            <a:fillRect/>
+          </a:stretch>
+        </p:blipFill>
+        <p:spPr>
+          <a:xfrm>
+            <a:off x="6309360" y="3703320"/>
+            <a:ext cx="3200400" cy="2480310"/>
+          </a:xfrm>
+          <a:prstGeom prst="rect">
+            <a:avLst/>
+          </a:prstGeom>
+        </p:spPr>
+      </p:pic>
+      <p:sp>
+        <p:nvSpPr>
+          <p:cNvPr id="12" name="TextBox 11"/>
+          <p:cNvSpPr txBox="1"/>
+          <p:nvPr/>
+        </p:nvSpPr>
+        <p:spPr>
+          <a:xfrm>
+            <a:off x="9692640" y="3703320"/>
+            <a:ext cx="1920240" cy="2468880"/>
+          </a:xfrm>
+          <a:prstGeom prst="rect">
+            <a:avLst/>
+          </a:prstGeom>
+          <a:noFill/>
+        </p:spPr>
+        <p:txBody>
+          <a:bodyPr wrap="square" anchor="t" lIns="18288" rIns="18288" tIns="18288" bIns="18288">
+            <a:noAutofit/>
+          </a:bodyPr>
+          <a:lstStyle/>
+          <a:p>
+            <a:pPr algn="l">
+              <a:lnSpc>
+                <a:spcPct val="115000"/>
+              </a:lnSpc>
+              <a:spcAft>
+                <a:spcPts val="0"/>
+              </a:spcAft>
+            </a:pPr>
+            <a:r>
+              <a:rPr sz="1500" b="0" i="0">
+                <a:solidFill>
+                  <a:srgbClr val="12324A"/>
+                </a:solidFill>
+                <a:latin typeface="Nunito"/>
+              </a:rPr>
+              <a:t>Mon, Wed, Fri at 5:00 AM. 4 × 7 min per zone, an hour apart, so it soaks in.</a:t>
+            </a:r>
+          </a:p>
+        </p:txBody>
+      </p:sp>
+      <p:sp>
+        <p:nvSpPr>
+          <p:cNvPr id="13" name="TextBox 12"/>
+          <p:cNvSpPr txBox="1"/>
+          <p:nvPr/>
+        </p:nvSpPr>
+        <p:spPr>
+          <a:xfrm>
+            <a:off x="685800" y="5669280"/>
+            <a:ext cx="5120640" cy="731520"/>
+          </a:xfrm>
+          <a:prstGeom prst="rect">
+            <a:avLst/>
+          </a:prstGeom>
+          <a:noFill/>
+        </p:spPr>
+        <p:txBody>
+          <a:bodyPr wrap="square" anchor="t" lIns="18288" rIns="18288" tIns="18288" bIns="18288">
+            <a:noAutofit/>
+          </a:bodyPr>
+          <a:lstStyle/>
+          <a:p>
+            <a:pPr algn="l">
+              <a:lnSpc>
+                <a:spcPct val="110000"/>
+              </a:lnSpc>
+              <a:spcAft>
+                <a:spcPts val="0"/>
+              </a:spcAft>
+            </a:pPr>
+            <a:r>
+              <a:rPr sz="1300" b="0" i="0">
+                <a:solidFill>
+                  <a:srgbClr val="4F6B80"/>
+                </a:solidFill>
+                <a:latin typeface="Nunito"/>
+              </a:rPr>
+              <a:t>OpenSprinkler's own firmware, in demo mode, set by overwater.ing/connect. One program, rewritten each morning.</a:t>
             </a:r>
           </a:p>
         </p:txBody>
@@ -7238,99 +7384,21 @@
                 </a:solidFill>
                 <a:latin typeface="Fredoka"/>
               </a:rPr>
-              <a:t>4 · The controller follows the schedule</a:t>
-            </a:r>
-          </a:p>
-        </p:txBody>
-      </p:sp>
-      <p:sp>
-        <p:nvSpPr>
-          <p:cNvPr id="3" name="TextBox 2"/>
-          <p:cNvSpPr txBox="1"/>
-          <p:nvPr/>
-        </p:nvSpPr>
-        <p:spPr>
-          <a:xfrm>
-            <a:off x="685800" y="1143000"/>
-            <a:ext cx="5212080" cy="548640"/>
-          </a:xfrm>
-          <a:prstGeom prst="rect">
-            <a:avLst/>
-          </a:prstGeom>
-          <a:noFill/>
-        </p:spPr>
-        <p:txBody>
-          <a:bodyPr wrap="square" anchor="t" lIns="18288" rIns="18288" tIns="18288" bIns="18288">
-            <a:noAutofit/>
-          </a:bodyPr>
-          <a:lstStyle/>
-          <a:p>
-            <a:pPr algn="l">
-              <a:spcAft>
-                <a:spcPts val="0"/>
-              </a:spcAft>
-            </a:pPr>
-            <a:r>
-              <a:rPr sz="2600" b="1" i="0">
-                <a:solidFill>
-                  <a:srgbClr val="E5533F"/>
-                </a:solidFill>
-                <a:latin typeface="Fredoka"/>
-              </a:rPr>
-              <a:t>When the state says skip: off</a:t>
-            </a:r>
-          </a:p>
-        </p:txBody>
-      </p:sp>
-      <p:sp>
-        <p:nvSpPr>
-          <p:cNvPr id="4" name="TextBox 3"/>
-          <p:cNvSpPr txBox="1"/>
-          <p:nvPr/>
-        </p:nvSpPr>
-        <p:spPr>
-          <a:xfrm>
-            <a:off x="6309360" y="1143000"/>
-            <a:ext cx="5212080" cy="548640"/>
-          </a:xfrm>
-          <a:prstGeom prst="rect">
-            <a:avLst/>
-          </a:prstGeom>
-          <a:noFill/>
-        </p:spPr>
-        <p:txBody>
-          <a:bodyPr wrap="square" anchor="t" lIns="18288" rIns="18288" tIns="18288" bIns="18288">
-            <a:noAutofit/>
-          </a:bodyPr>
-          <a:lstStyle/>
-          <a:p>
-            <a:pPr algn="l">
-              <a:spcAft>
-                <a:spcPts val="0"/>
-              </a:spcAft>
-            </a:pPr>
-            <a:r>
-              <a:rPr sz="2600" b="1" i="0">
-                <a:solidFill>
-                  <a:srgbClr val="2C9A4B"/>
-                </a:solidFill>
-                <a:latin typeface="Fredoka"/>
-              </a:rPr>
-              <a:t>A July week: on</a:t>
-            </a:r>
-          </a:p>
-        </p:txBody>
-      </p:sp>
-      <p:sp>
-        <p:nvSpPr>
-          <p:cNvPr id="5" name="Rounded Rectangle 4"/>
+              <a:t>4 · Any controller: /connect</a:t>
+            </a:r>
+          </a:p>
+        </p:txBody>
+      </p:sp>
+      <p:sp>
+        <p:nvSpPr>
+          <p:cNvPr id="3" name="Rounded Rectangle 2"/>
           <p:cNvSpPr/>
           <p:nvPr/>
         </p:nvSpPr>
         <p:spPr>
           <a:xfrm>
-            <a:off x="621792" y="1719072"/>
-            <a:ext cx="5248655" cy="1792224"/>
+            <a:off x="2264511" y="1124712"/>
+            <a:ext cx="7662672" cy="4837176"/>
           </a:xfrm>
           <a:prstGeom prst="roundRect">
             <a:avLst>
@@ -7369,7 +7437,7 @@
       </p:sp>
       <p:pic>
         <p:nvPicPr>
-          <p:cNvPr id="6" name="Picture 5" descr="06-os-paused-full-enabled.jpg"/>
+          <p:cNvPr id="4" name="Picture 3" descr="06-connect.jpg"/>
           <p:cNvPicPr>
             <a:picLocks noChangeAspect="1"/>
           </p:cNvPicPr>
@@ -7383,8 +7451,8 @@
         </p:blipFill>
         <p:spPr>
           <a:xfrm>
-            <a:off x="685800" y="1783080"/>
-            <a:ext cx="5120640" cy="1664207"/>
+            <a:off x="2328519" y="1188720"/>
+            <a:ext cx="7534656" cy="4709160"/>
           </a:xfrm>
           <a:prstGeom prst="rect">
             <a:avLst/>
@@ -7393,84 +7461,14 @@
       </p:pic>
       <p:sp>
         <p:nvSpPr>
-          <p:cNvPr id="7" name="Rounded Rectangle 6"/>
-          <p:cNvSpPr/>
-          <p:nvPr/>
-        </p:nvSpPr>
-        <p:spPr>
-          <a:xfrm>
-            <a:off x="6245352" y="1719072"/>
-            <a:ext cx="5248655" cy="1792224"/>
-          </a:xfrm>
-          <a:prstGeom prst="roundRect">
-            <a:avLst>
-              <a:gd name="adj" fmla="val 3000"/>
-            </a:avLst>
-          </a:prstGeom>
-          <a:solidFill>
-            <a:srgbClr val="FFFFFF"/>
-          </a:solidFill>
-          <a:ln w="25400">
-            <a:solidFill>
-              <a:srgbClr val="CFE6F5"/>
-            </a:solidFill>
-          </a:ln>
-          <a:effectLst/>
-        </p:spPr>
-        <p:style>
-          <a:lnRef idx="1">
-            <a:schemeClr val="accent1"/>
-          </a:lnRef>
-          <a:fillRef idx="3">
-            <a:schemeClr val="accent1"/>
-          </a:fillRef>
-          <a:effectRef idx="2">
-            <a:schemeClr val="accent1"/>
-          </a:effectRef>
-          <a:fontRef idx="minor">
-            <a:schemeClr val="lt1"/>
-          </a:fontRef>
-        </p:style>
-        <p:txBody>
-          <a:bodyPr rtlCol="0" anchor="ctr"/>
-          <a:lstStyle/>
-          <a:p/>
-        </p:txBody>
-      </p:sp>
-      <p:pic>
-        <p:nvPicPr>
-          <p:cNvPr id="8" name="Picture 7" descr="06-os-july-full-enabled.jpg"/>
-          <p:cNvPicPr>
-            <a:picLocks noChangeAspect="1"/>
-          </p:cNvPicPr>
-          <p:nvPr/>
-        </p:nvPicPr>
-        <p:blipFill>
-          <a:blip r:embed="rId3"/>
-          <a:stretch>
-            <a:fillRect/>
-          </a:stretch>
-        </p:blipFill>
-        <p:spPr>
-          <a:xfrm>
-            <a:off x="6309360" y="1783080"/>
-            <a:ext cx="5120640" cy="1664207"/>
-          </a:xfrm>
-          <a:prstGeom prst="rect">
-            <a:avLst/>
-          </a:prstGeom>
-        </p:spPr>
-      </p:pic>
-      <p:sp>
-        <p:nvSpPr>
-          <p:cNvPr id="9" name="TextBox 8"/>
+          <p:cNvPr id="5" name="TextBox 4"/>
           <p:cNvSpPr txBox="1"/>
           <p:nvPr/>
         </p:nvSpPr>
         <p:spPr>
           <a:xfrm>
-            <a:off x="685800" y="3703320"/>
-            <a:ext cx="5120640" cy="1371600"/>
+            <a:off x="685800" y="6080760"/>
+            <a:ext cx="10789920" cy="548640"/>
           </a:xfrm>
           <a:prstGeom prst="rect">
             <a:avLst/>
@@ -7483,176 +7481,19 @@
           </a:bodyPr>
           <a:lstStyle/>
           <a:p>
-            <a:pPr algn="l">
-              <a:lnSpc>
-                <a:spcPct val="115000"/>
-              </a:lnSpc>
+            <a:pPr algn="ctr">
               <a:spcAft>
                 <a:spcPts val="0"/>
               </a:spcAft>
             </a:pPr>
             <a:r>
-              <a:rPr sz="1700" b="0" i="0">
-                <a:solidFill>
-                  <a:srgbClr val="12324A"/>
+              <a:rPr sz="1500" b="0" i="0">
+                <a:solidFill>
+                  <a:srgbClr val="4F6B80"/>
                 </a:solidFill>
                 <a:latin typeface="Nunito"/>
               </a:rPr>
-              <a:t>Utah's Weekly Lawn Watering Guide said no watering in Salt Lake County, so the connector switched the program off. Other programs are untouched.</a:t>
-            </a:r>
-          </a:p>
-        </p:txBody>
-      </p:sp>
-      <p:sp>
-        <p:nvSpPr>
-          <p:cNvPr id="10" name="Rounded Rectangle 9"/>
-          <p:cNvSpPr/>
-          <p:nvPr/>
-        </p:nvSpPr>
-        <p:spPr>
-          <a:xfrm>
-            <a:off x="6245352" y="3639312"/>
-            <a:ext cx="3328416" cy="2608326"/>
-          </a:xfrm>
-          <a:prstGeom prst="roundRect">
-            <a:avLst>
-              <a:gd name="adj" fmla="val 3000"/>
-            </a:avLst>
-          </a:prstGeom>
-          <a:solidFill>
-            <a:srgbClr val="FFFFFF"/>
-          </a:solidFill>
-          <a:ln w="25400">
-            <a:solidFill>
-              <a:srgbClr val="CFE6F5"/>
-            </a:solidFill>
-          </a:ln>
-          <a:effectLst/>
-        </p:spPr>
-        <p:style>
-          <a:lnRef idx="1">
-            <a:schemeClr val="accent1"/>
-          </a:lnRef>
-          <a:fillRef idx="3">
-            <a:schemeClr val="accent1"/>
-          </a:fillRef>
-          <a:effectRef idx="2">
-            <a:schemeClr val="accent1"/>
-          </a:effectRef>
-          <a:fontRef idx="minor">
-            <a:schemeClr val="lt1"/>
-          </a:fontRef>
-        </p:style>
-        <p:txBody>
-          <a:bodyPr rtlCol="0" anchor="ctr"/>
-          <a:lstStyle/>
-          <a:p/>
-        </p:txBody>
-      </p:sp>
-      <p:pic>
-        <p:nvPicPr>
-          <p:cNvPr id="11" name="Picture 10" descr="06-os-july-full-stations.jpg"/>
-          <p:cNvPicPr>
-            <a:picLocks noChangeAspect="1"/>
-          </p:cNvPicPr>
-          <p:nvPr/>
-        </p:nvPicPr>
-        <p:blipFill>
-          <a:blip r:embed="rId4"/>
-          <a:stretch>
-            <a:fillRect/>
-          </a:stretch>
-        </p:blipFill>
-        <p:spPr>
-          <a:xfrm>
-            <a:off x="6309360" y="3703320"/>
-            <a:ext cx="3200400" cy="2480310"/>
-          </a:xfrm>
-          <a:prstGeom prst="rect">
-            <a:avLst/>
-          </a:prstGeom>
-        </p:spPr>
-      </p:pic>
-      <p:sp>
-        <p:nvSpPr>
-          <p:cNvPr id="12" name="TextBox 11"/>
-          <p:cNvSpPr txBox="1"/>
-          <p:nvPr/>
-        </p:nvSpPr>
-        <p:spPr>
-          <a:xfrm>
-            <a:off x="9692640" y="3703320"/>
-            <a:ext cx="1920240" cy="2468880"/>
-          </a:xfrm>
-          <a:prstGeom prst="rect">
-            <a:avLst/>
-          </a:prstGeom>
-          <a:noFill/>
-        </p:spPr>
-        <p:txBody>
-          <a:bodyPr wrap="square" anchor="t" lIns="18288" rIns="18288" tIns="18288" bIns="18288">
-            <a:noAutofit/>
-          </a:bodyPr>
-          <a:lstStyle/>
-          <a:p>
-            <a:pPr algn="l">
-              <a:lnSpc>
-                <a:spcPct val="115000"/>
-              </a:lnSpc>
-              <a:spcAft>
-                <a:spcPts val="0"/>
-              </a:spcAft>
-            </a:pPr>
-            <a:r>
-              <a:rPr sz="1500" b="0" i="0">
-                <a:solidFill>
-                  <a:srgbClr val="12324A"/>
-                </a:solidFill>
-                <a:latin typeface="Nunito"/>
-              </a:rPr>
-              <a:t>Mon, Wed, Fri at 5:00 AM. 4 × 7 min per zone, an hour apart, so it soaks in.</a:t>
-            </a:r>
-          </a:p>
-        </p:txBody>
-      </p:sp>
-      <p:sp>
-        <p:nvSpPr>
-          <p:cNvPr id="13" name="TextBox 12"/>
-          <p:cNvSpPr txBox="1"/>
-          <p:nvPr/>
-        </p:nvSpPr>
-        <p:spPr>
-          <a:xfrm>
-            <a:off x="685800" y="5669280"/>
-            <a:ext cx="5120640" cy="731520"/>
-          </a:xfrm>
-          <a:prstGeom prst="rect">
-            <a:avLst/>
-          </a:prstGeom>
-          <a:noFill/>
-        </p:spPr>
-        <p:txBody>
-          <a:bodyPr wrap="square" anchor="t" lIns="18288" rIns="18288" tIns="18288" bIns="18288">
-            <a:noAutofit/>
-          </a:bodyPr>
-          <a:lstStyle/>
-          <a:p>
-            <a:pPr algn="l">
-              <a:lnSpc>
-                <a:spcPct val="110000"/>
-              </a:lnSpc>
-              <a:spcAft>
-                <a:spcPts val="0"/>
-              </a:spcAft>
-            </a:pPr>
-            <a:r>
-              <a:rPr sz="1300" b="0" i="0">
-                <a:solidFill>
-                  <a:srgbClr val="4F6B80"/>
-                </a:solidFill>
-                <a:latin typeface="Nunito"/>
-              </a:rPr>
-              <a:t>OpenSprinkler's own firmware, in demo mode, set by overwater.ing/connect. One program, rewritten each morning.</a:t>
+              <a:t>Pick a county and sprinkler type, then OpenSprinkler, Rachio or Home Assistant. The same schedule is open JSON.</a:t>
             </a:r>
           </a:p>
         </p:txBody>
@@ -7717,7 +7558,7 @@
                 </a:solidFill>
                 <a:latin typeface="Fredoka"/>
               </a:rPr>
-              <a:t>4 · Any controller: /connect</a:t>
+              <a:t>Optional · Claude reads the bill: 197,334 gallons over</a:t>
             </a:r>
           </a:p>
         </p:txBody>
@@ -7730,7 +7571,7 @@
         </p:nvSpPr>
         <p:spPr>
           <a:xfrm>
-            <a:off x="2264511" y="1124712"/>
+            <a:off x="621792" y="1124712"/>
             <a:ext cx="7662672" cy="4837176"/>
           </a:xfrm>
           <a:prstGeom prst="roundRect">
@@ -7770,7 +7611,7 @@
       </p:sp>
       <p:pic>
         <p:nvPicPr>
-          <p:cNvPr id="4" name="Picture 3" descr="06-connect.jpg"/>
+          <p:cNvPr id="4" name="Picture 3" descr="04-bill.jpg"/>
           <p:cNvPicPr>
             <a:picLocks noChangeAspect="1"/>
           </p:cNvPicPr>
@@ -7784,7 +7625,7 @@
         </p:blipFill>
         <p:spPr>
           <a:xfrm>
-            <a:off x="2328519" y="1188720"/>
+            <a:off x="685800" y="1188720"/>
             <a:ext cx="7534656" cy="4709160"/>
           </a:xfrm>
           <a:prstGeom prst="rect">
@@ -7794,14 +7635,84 @@
       </p:pic>
       <p:sp>
         <p:nvSpPr>
-          <p:cNvPr id="5" name="TextBox 4"/>
+          <p:cNvPr id="5" name="Rounded Rectangle 4"/>
+          <p:cNvSpPr/>
+          <p:nvPr/>
+        </p:nvSpPr>
+        <p:spPr>
+          <a:xfrm>
+            <a:off x="8531352" y="1124712"/>
+            <a:ext cx="3054096" cy="2692385"/>
+          </a:xfrm>
+          <a:prstGeom prst="roundRect">
+            <a:avLst>
+              <a:gd name="adj" fmla="val 3000"/>
+            </a:avLst>
+          </a:prstGeom>
+          <a:solidFill>
+            <a:srgbClr val="FFFFFF"/>
+          </a:solidFill>
+          <a:ln w="25400">
+            <a:solidFill>
+              <a:srgbClr val="CFE6F5"/>
+            </a:solidFill>
+          </a:ln>
+          <a:effectLst/>
+        </p:spPr>
+        <p:style>
+          <a:lnRef idx="1">
+            <a:schemeClr val="accent1"/>
+          </a:lnRef>
+          <a:fillRef idx="3">
+            <a:schemeClr val="accent1"/>
+          </a:fillRef>
+          <a:effectRef idx="2">
+            <a:schemeClr val="accent1"/>
+          </a:effectRef>
+          <a:fontRef idx="minor">
+            <a:schemeClr val="lt1"/>
+          </a:fontRef>
+        </p:style>
+        <p:txBody>
+          <a:bodyPr rtlCol="0" anchor="ctr"/>
+          <a:lstStyle/>
+          <a:p/>
+        </p:txBody>
+      </p:sp>
+      <p:pic>
+        <p:nvPicPr>
+          <p:cNvPr id="6" name="Picture 5" descr="zoom-bill-zoom.jpg"/>
+          <p:cNvPicPr>
+            <a:picLocks noChangeAspect="1"/>
+          </p:cNvPicPr>
+          <p:nvPr/>
+        </p:nvPicPr>
+        <p:blipFill>
+          <a:blip r:embed="rId3"/>
+          <a:stretch>
+            <a:fillRect/>
+          </a:stretch>
+        </p:blipFill>
+        <p:spPr>
+          <a:xfrm>
+            <a:off x="8595360" y="1188720"/>
+            <a:ext cx="2926080" cy="2564369"/>
+          </a:xfrm>
+          <a:prstGeom prst="rect">
+            <a:avLst/>
+          </a:prstGeom>
+        </p:spPr>
+      </p:pic>
+      <p:sp>
+        <p:nvSpPr>
+          <p:cNvPr id="7" name="TextBox 6"/>
           <p:cNvSpPr txBox="1"/>
           <p:nvPr/>
         </p:nvSpPr>
         <p:spPr>
           <a:xfrm>
-            <a:off x="685800" y="6080760"/>
-            <a:ext cx="10789920" cy="548640"/>
+            <a:off x="8595360" y="4027409"/>
+            <a:ext cx="2926080" cy="1870470"/>
           </a:xfrm>
           <a:prstGeom prst="rect">
             <a:avLst/>
@@ -7814,19 +7725,22 @@
           </a:bodyPr>
           <a:lstStyle/>
           <a:p>
-            <a:pPr algn="ctr">
+            <a:pPr algn="l">
+              <a:lnSpc>
+                <a:spcPct val="115000"/>
+              </a:lnSpc>
               <a:spcAft>
                 <a:spcPts val="0"/>
               </a:spcAft>
             </a:pPr>
             <a:r>
-              <a:rPr sz="1500" b="0" i="0">
-                <a:solidFill>
-                  <a:srgbClr val="4F6B80"/>
+              <a:rPr sz="1400" b="0" i="0">
+                <a:solidFill>
+                  <a:srgbClr val="12324A"/>
                 </a:solidFill>
                 <a:latin typeface="Nunito"/>
               </a:rPr>
-              <a:t>Pick a county and sprinkler type, then OpenSprinkler, Rachio or Home Assistant. The same schedule is open JSON.</a:t>
+              <a:t>320,914 gallons a year outdoors against the 123,581 this lawn needs, read from a photo of the bill.</a:t>
             </a:r>
           </a:p>
         </p:txBody>
@@ -7891,7 +7805,7 @@
                 </a:solidFill>
                 <a:latin typeface="Fredoka"/>
               </a:rPr>
-              <a:t>Optional · Claude reads the bill: 197,334 gallons over</a:t>
+              <a:t>Optional · Any address, measured live</a:t>
             </a:r>
           </a:p>
         </p:txBody>
@@ -7944,7 +7858,7 @@
       </p:sp>
       <p:pic>
         <p:nvPicPr>
-          <p:cNvPr id="4" name="Picture 3" descr="04-bill.jpg"/>
+          <p:cNvPr id="4" name="Picture 3" descr="09-live.jpg"/>
           <p:cNvPicPr>
             <a:picLocks noChangeAspect="1"/>
           </p:cNvPicPr>
@@ -7975,7 +7889,7 @@
         <p:spPr>
           <a:xfrm>
             <a:off x="8531352" y="1124712"/>
-            <a:ext cx="3054096" cy="2692385"/>
+            <a:ext cx="3054096" cy="1645042"/>
           </a:xfrm>
           <a:prstGeom prst="roundRect">
             <a:avLst>
@@ -8014,7 +7928,7 @@
       </p:sp>
       <p:pic>
         <p:nvPicPr>
-          <p:cNvPr id="6" name="Picture 5" descr="zoom-bill-zoom.jpg"/>
+          <p:cNvPr id="6" name="Picture 5" descr="zoom-live-zoom.jpg"/>
           <p:cNvPicPr>
             <a:picLocks noChangeAspect="1"/>
           </p:cNvPicPr>
@@ -8029,7 +7943,7 @@
         <p:spPr>
           <a:xfrm>
             <a:off x="8595360" y="1188720"/>
-            <a:ext cx="2926080" cy="2564369"/>
+            <a:ext cx="2926080" cy="1517026"/>
           </a:xfrm>
           <a:prstGeom prst="rect">
             <a:avLst/>
@@ -8044,8 +7958,8 @@
         </p:nvSpPr>
         <p:spPr>
           <a:xfrm>
-            <a:off x="8595360" y="4027409"/>
-            <a:ext cx="2926080" cy="1870470"/>
+            <a:off x="8595360" y="2980066"/>
+            <a:ext cx="2926080" cy="2917813"/>
           </a:xfrm>
           <a:prstGeom prst="rect">
             <a:avLst/>
@@ -8073,7 +7987,7 @@
                 </a:solidFill>
                 <a:latin typeface="Nunito"/>
               </a:rPr>
-              <a:t>320,914 gallons a year outdoors against the 123,581 this lawn needs, read from a photo of the bill.</a:t>
+              <a:t>67 W 200 N, St. George: 10,834 sq ft of lawn needing 42 inches a season. Measured in the browser, nothing precomputed.</a:t>
             </a:r>
           </a:p>
         </p:txBody>
@@ -8851,7 +8765,7 @@
                 </a:solidFill>
                 <a:latin typeface="Fredoka"/>
               </a:rPr>
-              <a:t>Optional · Any address, measured live</a:t>
+              <a:t>Neighborhood view for districts</a:t>
             </a:r>
           </a:p>
         </p:txBody>
@@ -8864,7 +8778,7 @@
         </p:nvSpPr>
         <p:spPr>
           <a:xfrm>
-            <a:off x="621792" y="1124712"/>
+            <a:off x="2264511" y="1124712"/>
             <a:ext cx="7662672" cy="4837176"/>
           </a:xfrm>
           <a:prstGeom prst="roundRect">
@@ -8904,7 +8818,7 @@
       </p:sp>
       <p:pic>
         <p:nvPicPr>
-          <p:cNvPr id="4" name="Picture 3" descr="09-live.jpg"/>
+          <p:cNvPr id="4" name="Picture 3" descr="11-district-avenues.jpg"/>
           <p:cNvPicPr>
             <a:picLocks noChangeAspect="1"/>
           </p:cNvPicPr>
@@ -8918,7 +8832,7 @@
         </p:blipFill>
         <p:spPr>
           <a:xfrm>
-            <a:off x="685800" y="1188720"/>
+            <a:off x="2328519" y="1188720"/>
             <a:ext cx="7534656" cy="4709160"/>
           </a:xfrm>
           <a:prstGeom prst="rect">
@@ -8928,84 +8842,14 @@
       </p:pic>
       <p:sp>
         <p:nvSpPr>
-          <p:cNvPr id="5" name="Rounded Rectangle 4"/>
-          <p:cNvSpPr/>
-          <p:nvPr/>
-        </p:nvSpPr>
-        <p:spPr>
-          <a:xfrm>
-            <a:off x="8531352" y="1124712"/>
-            <a:ext cx="3054096" cy="1645042"/>
-          </a:xfrm>
-          <a:prstGeom prst="roundRect">
-            <a:avLst>
-              <a:gd name="adj" fmla="val 3000"/>
-            </a:avLst>
-          </a:prstGeom>
-          <a:solidFill>
-            <a:srgbClr val="FFFFFF"/>
-          </a:solidFill>
-          <a:ln w="25400">
-            <a:solidFill>
-              <a:srgbClr val="CFE6F5"/>
-            </a:solidFill>
-          </a:ln>
-          <a:effectLst/>
-        </p:spPr>
-        <p:style>
-          <a:lnRef idx="1">
-            <a:schemeClr val="accent1"/>
-          </a:lnRef>
-          <a:fillRef idx="3">
-            <a:schemeClr val="accent1"/>
-          </a:fillRef>
-          <a:effectRef idx="2">
-            <a:schemeClr val="accent1"/>
-          </a:effectRef>
-          <a:fontRef idx="minor">
-            <a:schemeClr val="lt1"/>
-          </a:fontRef>
-        </p:style>
-        <p:txBody>
-          <a:bodyPr rtlCol="0" anchor="ctr"/>
-          <a:lstStyle/>
-          <a:p/>
-        </p:txBody>
-      </p:sp>
-      <p:pic>
-        <p:nvPicPr>
-          <p:cNvPr id="6" name="Picture 5" descr="zoom-live-zoom.jpg"/>
-          <p:cNvPicPr>
-            <a:picLocks noChangeAspect="1"/>
-          </p:cNvPicPr>
-          <p:nvPr/>
-        </p:nvPicPr>
-        <p:blipFill>
-          <a:blip r:embed="rId3"/>
-          <a:stretch>
-            <a:fillRect/>
-          </a:stretch>
-        </p:blipFill>
-        <p:spPr>
-          <a:xfrm>
-            <a:off x="8595360" y="1188720"/>
-            <a:ext cx="2926080" cy="1517026"/>
-          </a:xfrm>
-          <a:prstGeom prst="rect">
-            <a:avLst/>
-          </a:prstGeom>
-        </p:spPr>
-      </p:pic>
-      <p:sp>
-        <p:nvSpPr>
-          <p:cNvPr id="7" name="TextBox 6"/>
+          <p:cNvPr id="5" name="TextBox 4"/>
           <p:cNvSpPr txBox="1"/>
           <p:nvPr/>
         </p:nvSpPr>
         <p:spPr>
           <a:xfrm>
-            <a:off x="8595360" y="2980066"/>
-            <a:ext cx="2926080" cy="2917813"/>
+            <a:off x="685800" y="6080760"/>
+            <a:ext cx="10789920" cy="548640"/>
           </a:xfrm>
           <a:prstGeom prst="rect">
             <a:avLst/>
@@ -9018,22 +8862,19 @@
           </a:bodyPr>
           <a:lstStyle/>
           <a:p>
-            <a:pPr algn="l">
-              <a:lnSpc>
-                <a:spcPct val="115000"/>
-              </a:lnSpc>
+            <a:pPr algn="ctr">
               <a:spcAft>
                 <a:spcPts val="0"/>
               </a:spcAft>
             </a:pPr>
             <a:r>
-              <a:rPr sz="1400" b="0" i="0">
-                <a:solidFill>
-                  <a:srgbClr val="12324A"/>
+              <a:rPr sz="1500" b="0" i="0">
+                <a:solidFill>
+                  <a:srgbClr val="4F6B80"/>
                 </a:solidFill>
                 <a:latin typeface="Nunito"/>
               </a:rPr>
-              <a:t>67 W 200 N, St. George: 10,834 sq ft of lawn needing 42 inches a season. Measured in the browser, nothing precomputed.</a:t>
+              <a:t>Totals only, never household rankings.</a:t>
             </a:r>
           </a:p>
         </p:txBody>
@@ -9098,7 +8939,7 @@
                 </a:solidFill>
                 <a:latin typeface="Fredoka"/>
               </a:rPr>
-              <a:t>Neighborhood view for districts</a:t>
+              <a:t>Utah-scale numbers: overwater.ing/impact</a:t>
             </a:r>
           </a:p>
         </p:txBody>
@@ -9151,7 +8992,7 @@
       </p:sp>
       <p:pic>
         <p:nvPicPr>
-          <p:cNvPr id="4" name="Picture 3" descr="11-district-avenues.jpg"/>
+          <p:cNvPr id="4" name="Picture 3" descr="12-impact.jpg"/>
           <p:cNvPicPr>
             <a:picLocks noChangeAspect="1"/>
           </p:cNvPicPr>
@@ -9207,7 +9048,7 @@
                 </a:solidFill>
                 <a:latin typeface="Nunito"/>
               </a:rPr>
-              <a:t>Totals only, never household rankings.</a:t>
+              <a:t>Our measured neighborhoods and the state-scale scenario.</a:t>
             </a:r>
           </a:p>
         </p:txBody>
@@ -9221,180 +9062,6 @@
 </file>
 
 <file path=ppt/slides/slide22.xml><?xml version="1.0" encoding="utf-8"?>
-<p:sld xmlns:a="http://schemas.openxmlformats.org/drawingml/2006/main" xmlns:p="http://schemas.openxmlformats.org/presentationml/2006/main" xmlns:r="http://schemas.openxmlformats.org/officeDocument/2006/relationships">
-  <p:cSld>
-    <p:bg>
-      <p:bgPr>
-        <a:solidFill>
-          <a:srgbClr val="EEF8FE"/>
-        </a:solidFill>
-        <a:effectLst/>
-      </p:bgPr>
-    </p:bg>
-    <p:spTree>
-      <p:nvGrpSpPr>
-        <p:cNvPr id="1" name=""/>
-        <p:cNvGrpSpPr/>
-        <p:nvPr/>
-      </p:nvGrpSpPr>
-      <p:grpSpPr/>
-      <p:sp>
-        <p:nvSpPr>
-          <p:cNvPr id="2" name="TextBox 1"/>
-          <p:cNvSpPr txBox="1"/>
-          <p:nvPr/>
-        </p:nvSpPr>
-        <p:spPr>
-          <a:xfrm>
-            <a:off x="685800" y="365760"/>
-            <a:ext cx="10789920" cy="640080"/>
-          </a:xfrm>
-          <a:prstGeom prst="rect">
-            <a:avLst/>
-          </a:prstGeom>
-          <a:noFill/>
-        </p:spPr>
-        <p:txBody>
-          <a:bodyPr wrap="square" anchor="t" lIns="18288" rIns="18288" tIns="18288" bIns="18288">
-            <a:noAutofit/>
-          </a:bodyPr>
-          <a:lstStyle/>
-          <a:p>
-            <a:pPr algn="l">
-              <a:spcAft>
-                <a:spcPts val="0"/>
-              </a:spcAft>
-            </a:pPr>
-            <a:r>
-              <a:rPr sz="3000" b="1" i="0">
-                <a:solidFill>
-                  <a:srgbClr val="12324A"/>
-                </a:solidFill>
-                <a:latin typeface="Fredoka"/>
-              </a:rPr>
-              <a:t>Utah-scale numbers: overwater.ing/impact</a:t>
-            </a:r>
-          </a:p>
-        </p:txBody>
-      </p:sp>
-      <p:sp>
-        <p:nvSpPr>
-          <p:cNvPr id="3" name="Rounded Rectangle 2"/>
-          <p:cNvSpPr/>
-          <p:nvPr/>
-        </p:nvSpPr>
-        <p:spPr>
-          <a:xfrm>
-            <a:off x="2264511" y="1124712"/>
-            <a:ext cx="7662672" cy="4837176"/>
-          </a:xfrm>
-          <a:prstGeom prst="roundRect">
-            <a:avLst>
-              <a:gd name="adj" fmla="val 3000"/>
-            </a:avLst>
-          </a:prstGeom>
-          <a:solidFill>
-            <a:srgbClr val="FFFFFF"/>
-          </a:solidFill>
-          <a:ln w="25400">
-            <a:solidFill>
-              <a:srgbClr val="CFE6F5"/>
-            </a:solidFill>
-          </a:ln>
-          <a:effectLst/>
-        </p:spPr>
-        <p:style>
-          <a:lnRef idx="1">
-            <a:schemeClr val="accent1"/>
-          </a:lnRef>
-          <a:fillRef idx="3">
-            <a:schemeClr val="accent1"/>
-          </a:fillRef>
-          <a:effectRef idx="2">
-            <a:schemeClr val="accent1"/>
-          </a:effectRef>
-          <a:fontRef idx="minor">
-            <a:schemeClr val="lt1"/>
-          </a:fontRef>
-        </p:style>
-        <p:txBody>
-          <a:bodyPr rtlCol="0" anchor="ctr"/>
-          <a:lstStyle/>
-          <a:p/>
-        </p:txBody>
-      </p:sp>
-      <p:pic>
-        <p:nvPicPr>
-          <p:cNvPr id="4" name="Picture 3" descr="12-impact.jpg"/>
-          <p:cNvPicPr>
-            <a:picLocks noChangeAspect="1"/>
-          </p:cNvPicPr>
-          <p:nvPr/>
-        </p:nvPicPr>
-        <p:blipFill>
-          <a:blip r:embed="rId2"/>
-          <a:stretch>
-            <a:fillRect/>
-          </a:stretch>
-        </p:blipFill>
-        <p:spPr>
-          <a:xfrm>
-            <a:off x="2328519" y="1188720"/>
-            <a:ext cx="7534656" cy="4709160"/>
-          </a:xfrm>
-          <a:prstGeom prst="rect">
-            <a:avLst/>
-          </a:prstGeom>
-        </p:spPr>
-      </p:pic>
-      <p:sp>
-        <p:nvSpPr>
-          <p:cNvPr id="5" name="TextBox 4"/>
-          <p:cNvSpPr txBox="1"/>
-          <p:nvPr/>
-        </p:nvSpPr>
-        <p:spPr>
-          <a:xfrm>
-            <a:off x="685800" y="6080760"/>
-            <a:ext cx="10789920" cy="548640"/>
-          </a:xfrm>
-          <a:prstGeom prst="rect">
-            <a:avLst/>
-          </a:prstGeom>
-          <a:noFill/>
-        </p:spPr>
-        <p:txBody>
-          <a:bodyPr wrap="square" anchor="t" lIns="18288" rIns="18288" tIns="18288" bIns="18288">
-            <a:noAutofit/>
-          </a:bodyPr>
-          <a:lstStyle/>
-          <a:p>
-            <a:pPr algn="ctr">
-              <a:spcAft>
-                <a:spcPts val="0"/>
-              </a:spcAft>
-            </a:pPr>
-            <a:r>
-              <a:rPr sz="1500" b="0" i="0">
-                <a:solidFill>
-                  <a:srgbClr val="4F6B80"/>
-                </a:solidFill>
-                <a:latin typeface="Nunito"/>
-              </a:rPr>
-              <a:t>Our measured neighborhoods and the state-scale scenario.</a:t>
-            </a:r>
-          </a:p>
-        </p:txBody>
-      </p:sp>
-    </p:spTree>
-  </p:cSld>
-  <p:clrMapOvr>
-    <a:masterClrMapping/>
-  </p:clrMapOvr>
-</p:sld>
-</file>
-
-<file path=ppt/slides/slide23.xml><?xml version="1.0" encoding="utf-8"?>
 <p:sld xmlns:a="http://schemas.openxmlformats.org/drawingml/2006/main" xmlns:p="http://schemas.openxmlformats.org/presentationml/2006/main" xmlns:r="http://schemas.openxmlformats.org/officeDocument/2006/relationships">
   <p:cSld>
     <p:bg>
@@ -13056,16 +12723,40 @@
         <p:nvPr/>
       </p:nvGrpSpPr>
       <p:grpSpPr/>
-      <p:sp>
-        <p:nvSpPr>
-          <p:cNvPr id="2" name="TextBox 1"/>
+      <p:pic>
+        <p:nvPicPr>
+          <p:cNvPr id="2" name="Picture 1" descr="scene-footer.png"/>
+          <p:cNvPicPr>
+            <a:picLocks noChangeAspect="1"/>
+          </p:cNvPicPr>
+          <p:nvPr/>
+        </p:nvPicPr>
+        <p:blipFill>
+          <a:blip r:embed="rId2"/>
+          <a:stretch>
+            <a:fillRect/>
+          </a:stretch>
+        </p:blipFill>
+        <p:spPr>
+          <a:xfrm>
+            <a:off x="0" y="4622855"/>
+            <a:ext cx="12191695" cy="2235144"/>
+          </a:xfrm>
+          <a:prstGeom prst="rect">
+            <a:avLst/>
+          </a:prstGeom>
+        </p:spPr>
+      </p:pic>
+      <p:sp>
+        <p:nvSpPr>
+          <p:cNvPr id="3" name="TextBox 2"/>
           <p:cNvSpPr txBox="1"/>
           <p:nvPr/>
         </p:nvSpPr>
         <p:spPr>
           <a:xfrm>
-            <a:off x="685800" y="502920"/>
-            <a:ext cx="8229600" cy="365760"/>
+            <a:off x="685800" y="685800"/>
+            <a:ext cx="7315200" cy="365760"/>
           </a:xfrm>
           <a:prstGeom prst="rect">
             <a:avLst/>
@@ -13090,21 +12781,21 @@
                 </a:solidFill>
                 <a:latin typeface="Nunito"/>
               </a:rPr>
-              <a:t>PATH TO REALITY</a:t>
-            </a:r>
-          </a:p>
-        </p:txBody>
-      </p:sp>
-      <p:sp>
-        <p:nvSpPr>
-          <p:cNvPr id="3" name="TextBox 2"/>
+              <a:t>THE ASK</a:t>
+            </a:r>
+          </a:p>
+        </p:txBody>
+      </p:sp>
+      <p:sp>
+        <p:nvSpPr>
+          <p:cNvPr id="4" name="TextBox 3"/>
           <p:cNvSpPr txBox="1"/>
           <p:nvPr/>
         </p:nvSpPr>
         <p:spPr>
           <a:xfrm>
-            <a:off x="685800" y="822960"/>
-            <a:ext cx="10789920" cy="914400"/>
+            <a:off x="685800" y="1051560"/>
+            <a:ext cx="7498079" cy="1737360"/>
           </a:xfrm>
           <a:prstGeom prst="rect">
             <a:avLst/>
@@ -13126,41 +12817,17 @@
               </a:spcAft>
             </a:pPr>
             <a:r>
-              <a:rPr sz="4000" b="1" i="0">
+              <a:rPr sz="4800" b="1" i="0">
                 <a:solidFill>
                   <a:srgbClr val="12324A"/>
                 </a:solidFill>
                 <a:latin typeface="Fredoka"/>
               </a:rPr>
-              <a:t>Two customers: the state and the homeowner.</a:t>
-            </a:r>
-          </a:p>
-        </p:txBody>
-      </p:sp>
-      <p:pic>
-        <p:nvPicPr>
-          <p:cNvPr id="4" name="Picture 3" descr="sprinkler-solo.png"/>
-          <p:cNvPicPr>
-            <a:picLocks noChangeAspect="1"/>
-          </p:cNvPicPr>
-          <p:nvPr/>
-        </p:nvPicPr>
-        <p:blipFill>
-          <a:blip r:embed="rId2"/>
-          <a:stretch>
-            <a:fillRect/>
-          </a:stretch>
-        </p:blipFill>
-        <p:spPr>
-          <a:xfrm>
-            <a:off x="2331720" y="1737360"/>
-            <a:ext cx="402145" cy="548640"/>
-          </a:xfrm>
-          <a:prstGeom prst="rect">
-            <a:avLst/>
-          </a:prstGeom>
-        </p:spPr>
-      </p:pic>
+              <a:t>Type your address at overwater.ing</a:t>
+            </a:r>
+          </a:p>
+        </p:txBody>
+      </p:sp>
       <p:sp>
         <p:nvSpPr>
           <p:cNvPr id="5" name="TextBox 4"/>
@@ -13169,8 +12836,8 @@
         </p:nvSpPr>
         <p:spPr>
           <a:xfrm>
-            <a:off x="2971800" y="1783080"/>
-            <a:ext cx="3931920" cy="457200"/>
+            <a:off x="685800" y="2788920"/>
+            <a:ext cx="7680960" cy="1737360"/>
           </a:xfrm>
           <a:prstGeom prst="rect">
             <a:avLst/>
@@ -13184,25 +12851,65 @@
           <a:lstStyle/>
           <a:p>
             <a:pPr algn="l">
+              <a:lnSpc>
+                <a:spcPct val="115000"/>
+              </a:lnSpc>
               <a:spcAft>
-                <a:spcPts val="0"/>
+                <a:spcPts val="800"/>
               </a:spcAft>
             </a:pPr>
             <a:r>
-              <a:rPr sz="2200" b="1" i="0">
+              <a:rPr sz="2000" b="1" i="0">
+                <a:solidFill>
+                  <a:srgbClr val="1F86D6"/>
+                </a:solidFill>
+                <a:latin typeface="Nunito"/>
+              </a:rPr>
+              <a:t>$10K </a:t>
+            </a:r>
+            <a:r>
+              <a:rPr sz="2000" b="0" i="0">
                 <a:solidFill>
                   <a:srgbClr val="12324A"/>
                 </a:solidFill>
-                <a:latin typeface="Fredoka"/>
+                <a:latin typeface="Nunito"/>
               </a:rPr>
-              <a:t>Cities, districts &amp; the state</a:t>
+              <a:t>for phase 2: a pilot that runs real sprinklers.</a:t>
+            </a:r>
+          </a:p>
+          <a:p>
+            <a:pPr algn="l">
+              <a:lnSpc>
+                <a:spcPct val="115000"/>
+              </a:lnSpc>
+              <a:spcAft>
+                <a:spcPts val="800"/>
+              </a:spcAft>
+            </a:pPr>
+            <a:r>
+              <a:rPr sz="2000" b="1" i="0">
+                <a:solidFill>
+                  <a:srgbClr val="1F86D6"/>
+                </a:solidFill>
+                <a:latin typeface="Nunito"/>
+              </a:rPr>
+              <a:t>Intros </a:t>
+            </a:r>
+            <a:r>
+              <a:rPr sz="2000" b="0" i="0">
+                <a:solidFill>
+                  <a:srgbClr val="12324A"/>
+                </a:solidFill>
+                <a:latin typeface="Nunito"/>
+              </a:rPr>
+              <a:t>to Utah's water-wise partners, a district conservation team, and drone training academies for LiDAR scans.</a:t>
             </a:r>
           </a:p>
         </p:txBody>
       </p:sp>
       <p:pic>
         <p:nvPicPr>
-          <p:cNvPr id="6" name="Picture 5" descr="grass.png"/>
+          <p:cNvPr id="6" name="Picture 5" descr="qr.png"/>
           <p:cNvPicPr>
             <a:picLocks noChangeAspect="1"/>
           </p:cNvPicPr>
@@ -13216,8 +12923,8 @@
         </p:blipFill>
         <p:spPr>
           <a:xfrm>
-            <a:off x="6995160" y="1737360"/>
-            <a:ext cx="480210" cy="548640"/>
+            <a:off x="8915400" y="777240"/>
+            <a:ext cx="2377440" cy="2377440"/>
           </a:xfrm>
           <a:prstGeom prst="rect">
             <a:avLst/>
@@ -13232,8 +12939,8 @@
         </p:nvSpPr>
         <p:spPr>
           <a:xfrm>
-            <a:off x="7635240" y="1783080"/>
-            <a:ext cx="3931920" cy="457200"/>
+            <a:off x="8915400" y="3200400"/>
+            <a:ext cx="2377440" cy="365760"/>
           </a:xfrm>
           <a:prstGeom prst="rect">
             <a:avLst/>
@@ -13246,703 +12953,19 @@
           </a:bodyPr>
           <a:lstStyle/>
           <a:p>
-            <a:pPr algn="l">
+            <a:pPr algn="ctr">
               <a:spcAft>
                 <a:spcPts val="0"/>
               </a:spcAft>
             </a:pPr>
             <a:r>
-              <a:rPr sz="2200" b="1" i="0">
+              <a:rPr sz="1800" b="1" i="0">
                 <a:solidFill>
                   <a:srgbClr val="12324A"/>
                 </a:solidFill>
                 <a:latin typeface="Fredoka"/>
               </a:rPr>
-              <a:t>Homeowners</a:t>
-            </a:r>
-          </a:p>
-        </p:txBody>
-      </p:sp>
-      <p:sp>
-        <p:nvSpPr>
-          <p:cNvPr id="8" name="TextBox 7"/>
-          <p:cNvSpPr txBox="1"/>
-          <p:nvPr/>
-        </p:nvSpPr>
-        <p:spPr>
-          <a:xfrm>
-            <a:off x="685800" y="2560320"/>
-            <a:ext cx="1463040" cy="457200"/>
-          </a:xfrm>
-          <a:prstGeom prst="rect">
-            <a:avLst/>
-          </a:prstGeom>
-          <a:noFill/>
-        </p:spPr>
-        <p:txBody>
-          <a:bodyPr wrap="square" anchor="t" lIns="18288" rIns="18288" tIns="18288" bIns="18288">
-            <a:noAutofit/>
-          </a:bodyPr>
-          <a:lstStyle/>
-          <a:p>
-            <a:pPr algn="l">
-              <a:spcAft>
-                <a:spcPts val="0"/>
-              </a:spcAft>
-            </a:pPr>
-            <a:r>
-              <a:rPr sz="1400" b="1" i="0">
-                <a:solidFill>
-                  <a:srgbClr val="2C9A4B"/>
-                </a:solidFill>
-                <a:latin typeface="Nunito"/>
-              </a:rPr>
-              <a:t>NOW</a:t>
-            </a:r>
-          </a:p>
-        </p:txBody>
-      </p:sp>
-      <p:sp>
-        <p:nvSpPr>
-          <p:cNvPr id="9" name="Rounded Rectangle 8"/>
-          <p:cNvSpPr/>
-          <p:nvPr/>
-        </p:nvSpPr>
-        <p:spPr>
-          <a:xfrm>
-            <a:off x="2331720" y="2514600"/>
-            <a:ext cx="4526280" cy="1051560"/>
-          </a:xfrm>
-          <a:prstGeom prst="roundRect">
-            <a:avLst>
-              <a:gd name="adj" fmla="val 10000"/>
-            </a:avLst>
-          </a:prstGeom>
-          <a:solidFill>
-            <a:srgbClr val="FFFFFF"/>
-          </a:solidFill>
-          <a:ln w="25400">
-            <a:solidFill>
-              <a:srgbClr val="CFE6F5"/>
-            </a:solidFill>
-          </a:ln>
-          <a:effectLst/>
-        </p:spPr>
-        <p:style>
-          <a:lnRef idx="1">
-            <a:schemeClr val="accent1"/>
-          </a:lnRef>
-          <a:fillRef idx="3">
-            <a:schemeClr val="accent1"/>
-          </a:fillRef>
-          <a:effectRef idx="2">
-            <a:schemeClr val="accent1"/>
-          </a:effectRef>
-          <a:fontRef idx="minor">
-            <a:schemeClr val="lt1"/>
-          </a:fontRef>
-        </p:style>
-        <p:txBody>
-          <a:bodyPr rtlCol="0" anchor="ctr"/>
-          <a:lstStyle/>
-          <a:p/>
-        </p:txBody>
-      </p:sp>
-      <p:sp>
-        <p:nvSpPr>
-          <p:cNvPr id="10" name="TextBox 9"/>
-          <p:cNvSpPr txBox="1"/>
-          <p:nvPr/>
-        </p:nvSpPr>
-        <p:spPr>
-          <a:xfrm>
-            <a:off x="2560320" y="2560320"/>
-            <a:ext cx="4114800" cy="960120"/>
-          </a:xfrm>
-          <a:prstGeom prst="rect">
-            <a:avLst/>
-          </a:prstGeom>
-          <a:noFill/>
-        </p:spPr>
-        <p:txBody>
-          <a:bodyPr wrap="square" anchor="ctr" lIns="18288" rIns="18288" tIns="18288" bIns="18288">
-            <a:noAutofit/>
-          </a:bodyPr>
-          <a:lstStyle/>
-          <a:p>
-            <a:pPr algn="l">
-              <a:lnSpc>
-                <a:spcPct val="110000"/>
-              </a:lnSpc>
-              <a:spcAft>
-                <a:spcPts val="0"/>
-              </a:spcAft>
-            </a:pPr>
-            <a:r>
-              <a:rPr sz="1600" b="0" i="0">
-                <a:solidFill>
-                  <a:srgbClr val="12324A"/>
-                </a:solidFill>
-                <a:latin typeface="Nunito"/>
-              </a:rPr>
-              <a:t>Every lot's lawn and need. Rebate outreach goes where the savings are.</a:t>
-            </a:r>
-          </a:p>
-        </p:txBody>
-      </p:sp>
-      <p:sp>
-        <p:nvSpPr>
-          <p:cNvPr id="11" name="Rounded Rectangle 10"/>
-          <p:cNvSpPr/>
-          <p:nvPr/>
-        </p:nvSpPr>
-        <p:spPr>
-          <a:xfrm>
-            <a:off x="6995160" y="2514600"/>
-            <a:ext cx="4526280" cy="1051560"/>
-          </a:xfrm>
-          <a:prstGeom prst="roundRect">
-            <a:avLst>
-              <a:gd name="adj" fmla="val 10000"/>
-            </a:avLst>
-          </a:prstGeom>
-          <a:solidFill>
-            <a:srgbClr val="FFFFFF"/>
-          </a:solidFill>
-          <a:ln w="25400">
-            <a:solidFill>
-              <a:srgbClr val="CFE6F5"/>
-            </a:solidFill>
-          </a:ln>
-          <a:effectLst/>
-        </p:spPr>
-        <p:style>
-          <a:lnRef idx="1">
-            <a:schemeClr val="accent1"/>
-          </a:lnRef>
-          <a:fillRef idx="3">
-            <a:schemeClr val="accent1"/>
-          </a:fillRef>
-          <a:effectRef idx="2">
-            <a:schemeClr val="accent1"/>
-          </a:effectRef>
-          <a:fontRef idx="minor">
-            <a:schemeClr val="lt1"/>
-          </a:fontRef>
-        </p:style>
-        <p:txBody>
-          <a:bodyPr rtlCol="0" anchor="ctr"/>
-          <a:lstStyle/>
-          <a:p/>
-        </p:txBody>
-      </p:sp>
-      <p:sp>
-        <p:nvSpPr>
-          <p:cNvPr id="12" name="TextBox 11"/>
-          <p:cNvSpPr txBox="1"/>
-          <p:nvPr/>
-        </p:nvSpPr>
-        <p:spPr>
-          <a:xfrm>
-            <a:off x="7223760" y="2560320"/>
-            <a:ext cx="4114800" cy="960120"/>
-          </a:xfrm>
-          <a:prstGeom prst="rect">
-            <a:avLst/>
-          </a:prstGeom>
-          <a:noFill/>
-        </p:spPr>
-        <p:txBody>
-          <a:bodyPr wrap="square" anchor="ctr" lIns="18288" rIns="18288" tIns="18288" bIns="18288">
-            <a:noAutofit/>
-          </a:bodyPr>
-          <a:lstStyle/>
-          <a:p>
-            <a:pPr algn="l">
-              <a:lnSpc>
-                <a:spcPct val="110000"/>
-              </a:lnSpc>
-              <a:spcAft>
-                <a:spcPts val="0"/>
-              </a:spcAft>
-            </a:pPr>
-            <a:r>
-              <a:rPr sz="1600" b="0" i="0">
-                <a:solidFill>
-                  <a:srgbClr val="12324A"/>
-                </a:solidFill>
-                <a:latin typeface="Nunito"/>
-              </a:rPr>
-              <a:t>Your lawn, your rebate, and a schedule that changes itself.</a:t>
-            </a:r>
-          </a:p>
-        </p:txBody>
-      </p:sp>
-      <p:sp>
-        <p:nvSpPr>
-          <p:cNvPr id="13" name="TextBox 12"/>
-          <p:cNvSpPr txBox="1"/>
-          <p:nvPr/>
-        </p:nvSpPr>
-        <p:spPr>
-          <a:xfrm>
-            <a:off x="685800" y="3794759"/>
-            <a:ext cx="1463040" cy="457200"/>
-          </a:xfrm>
-          <a:prstGeom prst="rect">
-            <a:avLst/>
-          </a:prstGeom>
-          <a:noFill/>
-        </p:spPr>
-        <p:txBody>
-          <a:bodyPr wrap="square" anchor="t" lIns="18288" rIns="18288" tIns="18288" bIns="18288">
-            <a:noAutofit/>
-          </a:bodyPr>
-          <a:lstStyle/>
-          <a:p>
-            <a:pPr algn="l">
-              <a:spcAft>
-                <a:spcPts val="0"/>
-              </a:spcAft>
-            </a:pPr>
-            <a:r>
-              <a:rPr sz="1400" b="1" i="0">
-                <a:solidFill>
-                  <a:srgbClr val="1F86D6"/>
-                </a:solidFill>
-                <a:latin typeface="Nunito"/>
-              </a:rPr>
-              <a:t>PHASE 2</a:t>
-            </a:r>
-          </a:p>
-        </p:txBody>
-      </p:sp>
-      <p:sp>
-        <p:nvSpPr>
-          <p:cNvPr id="14" name="Rounded Rectangle 13"/>
-          <p:cNvSpPr/>
-          <p:nvPr/>
-        </p:nvSpPr>
-        <p:spPr>
-          <a:xfrm>
-            <a:off x="2331720" y="3749039"/>
-            <a:ext cx="4526280" cy="1051560"/>
-          </a:xfrm>
-          <a:prstGeom prst="roundRect">
-            <a:avLst>
-              <a:gd name="adj" fmla="val 10000"/>
-            </a:avLst>
-          </a:prstGeom>
-          <a:solidFill>
-            <a:srgbClr val="FFFFFF"/>
-          </a:solidFill>
-          <a:ln w="25400">
-            <a:solidFill>
-              <a:srgbClr val="CFE6F5"/>
-            </a:solidFill>
-          </a:ln>
-          <a:effectLst/>
-        </p:spPr>
-        <p:style>
-          <a:lnRef idx="1">
-            <a:schemeClr val="accent1"/>
-          </a:lnRef>
-          <a:fillRef idx="3">
-            <a:schemeClr val="accent1"/>
-          </a:fillRef>
-          <a:effectRef idx="2">
-            <a:schemeClr val="accent1"/>
-          </a:effectRef>
-          <a:fontRef idx="minor">
-            <a:schemeClr val="lt1"/>
-          </a:fontRef>
-        </p:style>
-        <p:txBody>
-          <a:bodyPr rtlCol="0" anchor="ctr"/>
-          <a:lstStyle/>
-          <a:p/>
-        </p:txBody>
-      </p:sp>
-      <p:sp>
-        <p:nvSpPr>
-          <p:cNvPr id="15" name="TextBox 14"/>
-          <p:cNvSpPr txBox="1"/>
-          <p:nvPr/>
-        </p:nvSpPr>
-        <p:spPr>
-          <a:xfrm>
-            <a:off x="2560320" y="3794759"/>
-            <a:ext cx="4114800" cy="960120"/>
-          </a:xfrm>
-          <a:prstGeom prst="rect">
-            <a:avLst/>
-          </a:prstGeom>
-          <a:noFill/>
-        </p:spPr>
-        <p:txBody>
-          <a:bodyPr wrap="square" anchor="ctr" lIns="18288" rIns="18288" tIns="18288" bIns="18288">
-            <a:noAutofit/>
-          </a:bodyPr>
-          <a:lstStyle/>
-          <a:p>
-            <a:pPr algn="l">
-              <a:lnSpc>
-                <a:spcPct val="110000"/>
-              </a:lnSpc>
-              <a:spcAft>
-                <a:spcPts val="0"/>
-              </a:spcAft>
-            </a:pPr>
-            <a:r>
-              <a:rPr sz="1600" b="0" i="0">
-                <a:solidFill>
-                  <a:srgbClr val="12324A"/>
-                </a:solidFill>
-                <a:latin typeface="Nunito"/>
-              </a:rPr>
-              <a:t>Schedules that follow the state guide across a district. Savings measured on meters.</a:t>
-            </a:r>
-          </a:p>
-        </p:txBody>
-      </p:sp>
-      <p:sp>
-        <p:nvSpPr>
-          <p:cNvPr id="16" name="Rounded Rectangle 15"/>
-          <p:cNvSpPr/>
-          <p:nvPr/>
-        </p:nvSpPr>
-        <p:spPr>
-          <a:xfrm>
-            <a:off x="6995160" y="3749039"/>
-            <a:ext cx="4526280" cy="1051560"/>
-          </a:xfrm>
-          <a:prstGeom prst="roundRect">
-            <a:avLst>
-              <a:gd name="adj" fmla="val 10000"/>
-            </a:avLst>
-          </a:prstGeom>
-          <a:solidFill>
-            <a:srgbClr val="FFFFFF"/>
-          </a:solidFill>
-          <a:ln w="25400">
-            <a:solidFill>
-              <a:srgbClr val="CFE6F5"/>
-            </a:solidFill>
-          </a:ln>
-          <a:effectLst/>
-        </p:spPr>
-        <p:style>
-          <a:lnRef idx="1">
-            <a:schemeClr val="accent1"/>
-          </a:lnRef>
-          <a:fillRef idx="3">
-            <a:schemeClr val="accent1"/>
-          </a:fillRef>
-          <a:effectRef idx="2">
-            <a:schemeClr val="accent1"/>
-          </a:effectRef>
-          <a:fontRef idx="minor">
-            <a:schemeClr val="lt1"/>
-          </a:fontRef>
-        </p:style>
-        <p:txBody>
-          <a:bodyPr rtlCol="0" anchor="ctr"/>
-          <a:lstStyle/>
-          <a:p/>
-        </p:txBody>
-      </p:sp>
-      <p:sp>
-        <p:nvSpPr>
-          <p:cNvPr id="17" name="TextBox 16"/>
-          <p:cNvSpPr txBox="1"/>
-          <p:nvPr/>
-        </p:nvSpPr>
-        <p:spPr>
-          <a:xfrm>
-            <a:off x="7223760" y="3794759"/>
-            <a:ext cx="4114800" cy="960120"/>
-          </a:xfrm>
-          <a:prstGeom prst="rect">
-            <a:avLst/>
-          </a:prstGeom>
-          <a:noFill/>
-        </p:spPr>
-        <p:txBody>
-          <a:bodyPr wrap="square" anchor="ctr" lIns="18288" rIns="18288" tIns="18288" bIns="18288">
-            <a:noAutofit/>
-          </a:bodyPr>
-          <a:lstStyle/>
-          <a:p>
-            <a:pPr algn="l">
-              <a:lnSpc>
-                <a:spcPct val="110000"/>
-              </a:lnSpc>
-              <a:spcAft>
-                <a:spcPts val="0"/>
-              </a:spcAft>
-            </a:pPr>
-            <a:r>
-              <a:rPr sz="1600" b="0" i="0">
-                <a:solidFill>
-                  <a:srgbClr val="12324A"/>
-                </a:solidFill>
-                <a:latin typeface="Nunito"/>
-              </a:rPr>
-              <a:t>Sprinklers managed for you. Moisture sensors skip the wet days.</a:t>
-            </a:r>
-          </a:p>
-        </p:txBody>
-      </p:sp>
-      <p:sp>
-        <p:nvSpPr>
-          <p:cNvPr id="18" name="TextBox 17"/>
-          <p:cNvSpPr txBox="1"/>
-          <p:nvPr/>
-        </p:nvSpPr>
-        <p:spPr>
-          <a:xfrm>
-            <a:off x="685800" y="5029200"/>
-            <a:ext cx="1463040" cy="457200"/>
-          </a:xfrm>
-          <a:prstGeom prst="rect">
-            <a:avLst/>
-          </a:prstGeom>
-          <a:noFill/>
-        </p:spPr>
-        <p:txBody>
-          <a:bodyPr wrap="square" anchor="t" lIns="18288" rIns="18288" tIns="18288" bIns="18288">
-            <a:noAutofit/>
-          </a:bodyPr>
-          <a:lstStyle/>
-          <a:p>
-            <a:pPr algn="l">
-              <a:spcAft>
-                <a:spcPts val="0"/>
-              </a:spcAft>
-            </a:pPr>
-            <a:r>
-              <a:rPr sz="1400" b="1" i="0">
-                <a:solidFill>
-                  <a:srgbClr val="C27C00"/>
-                </a:solidFill>
-                <a:latin typeface="Nunito"/>
-              </a:rPr>
-              <a:t>PHASE 3</a:t>
-            </a:r>
-          </a:p>
-        </p:txBody>
-      </p:sp>
-      <p:sp>
-        <p:nvSpPr>
-          <p:cNvPr id="19" name="Rounded Rectangle 18"/>
-          <p:cNvSpPr/>
-          <p:nvPr/>
-        </p:nvSpPr>
-        <p:spPr>
-          <a:xfrm>
-            <a:off x="2331720" y="4983480"/>
-            <a:ext cx="4526280" cy="1051560"/>
-          </a:xfrm>
-          <a:prstGeom prst="roundRect">
-            <a:avLst>
-              <a:gd name="adj" fmla="val 10000"/>
-            </a:avLst>
-          </a:prstGeom>
-          <a:solidFill>
-            <a:srgbClr val="FFFFFF"/>
-          </a:solidFill>
-          <a:ln w="25400">
-            <a:solidFill>
-              <a:srgbClr val="CFE6F5"/>
-            </a:solidFill>
-          </a:ln>
-          <a:effectLst/>
-        </p:spPr>
-        <p:style>
-          <a:lnRef idx="1">
-            <a:schemeClr val="accent1"/>
-          </a:lnRef>
-          <a:fillRef idx="3">
-            <a:schemeClr val="accent1"/>
-          </a:fillRef>
-          <a:effectRef idx="2">
-            <a:schemeClr val="accent1"/>
-          </a:effectRef>
-          <a:fontRef idx="minor">
-            <a:schemeClr val="lt1"/>
-          </a:fontRef>
-        </p:style>
-        <p:txBody>
-          <a:bodyPr rtlCol="0" anchor="ctr"/>
-          <a:lstStyle/>
-          <a:p/>
-        </p:txBody>
-      </p:sp>
-      <p:sp>
-        <p:nvSpPr>
-          <p:cNvPr id="20" name="TextBox 19"/>
-          <p:cNvSpPr txBox="1"/>
-          <p:nvPr/>
-        </p:nvSpPr>
-        <p:spPr>
-          <a:xfrm>
-            <a:off x="2560320" y="5029200"/>
-            <a:ext cx="4114800" cy="960120"/>
-          </a:xfrm>
-          <a:prstGeom prst="rect">
-            <a:avLst/>
-          </a:prstGeom>
-          <a:noFill/>
-        </p:spPr>
-        <p:txBody>
-          <a:bodyPr wrap="square" anchor="ctr" lIns="18288" rIns="18288" tIns="18288" bIns="18288">
-            <a:noAutofit/>
-          </a:bodyPr>
-          <a:lstStyle/>
-          <a:p>
-            <a:pPr algn="l">
-              <a:lnSpc>
-                <a:spcPct val="110000"/>
-              </a:lnSpc>
-              <a:spcAft>
-                <a:spcPts val="0"/>
-              </a:spcAft>
-            </a:pPr>
-            <a:r>
-              <a:rPr sz="1600" b="0" i="0">
-                <a:solidFill>
-                  <a:srgbClr val="12324A"/>
-                </a:solidFill>
-                <a:latin typeface="Nunito"/>
-              </a:rPr>
-              <a:t>Drone scans spot overwatering from the air, lot by lot.</a:t>
-            </a:r>
-          </a:p>
-        </p:txBody>
-      </p:sp>
-      <p:sp>
-        <p:nvSpPr>
-          <p:cNvPr id="21" name="Rounded Rectangle 20"/>
-          <p:cNvSpPr/>
-          <p:nvPr/>
-        </p:nvSpPr>
-        <p:spPr>
-          <a:xfrm>
-            <a:off x="6995160" y="4983480"/>
-            <a:ext cx="4526280" cy="1051560"/>
-          </a:xfrm>
-          <a:prstGeom prst="roundRect">
-            <a:avLst>
-              <a:gd name="adj" fmla="val 10000"/>
-            </a:avLst>
-          </a:prstGeom>
-          <a:solidFill>
-            <a:srgbClr val="FFFFFF"/>
-          </a:solidFill>
-          <a:ln w="25400">
-            <a:solidFill>
-              <a:srgbClr val="CFE6F5"/>
-            </a:solidFill>
-          </a:ln>
-          <a:effectLst/>
-        </p:spPr>
-        <p:style>
-          <a:lnRef idx="1">
-            <a:schemeClr val="accent1"/>
-          </a:lnRef>
-          <a:fillRef idx="3">
-            <a:schemeClr val="accent1"/>
-          </a:fillRef>
-          <a:effectRef idx="2">
-            <a:schemeClr val="accent1"/>
-          </a:effectRef>
-          <a:fontRef idx="minor">
-            <a:schemeClr val="lt1"/>
-          </a:fontRef>
-        </p:style>
-        <p:txBody>
-          <a:bodyPr rtlCol="0" anchor="ctr"/>
-          <a:lstStyle/>
-          <a:p/>
-        </p:txBody>
-      </p:sp>
-      <p:sp>
-        <p:nvSpPr>
-          <p:cNvPr id="22" name="TextBox 21"/>
-          <p:cNvSpPr txBox="1"/>
-          <p:nvPr/>
-        </p:nvSpPr>
-        <p:spPr>
-          <a:xfrm>
-            <a:off x="7223760" y="5029200"/>
-            <a:ext cx="4114800" cy="960120"/>
-          </a:xfrm>
-          <a:prstGeom prst="rect">
-            <a:avLst/>
-          </a:prstGeom>
-          <a:noFill/>
-        </p:spPr>
-        <p:txBody>
-          <a:bodyPr wrap="square" anchor="ctr" lIns="18288" rIns="18288" tIns="18288" bIns="18288">
-            <a:noAutofit/>
-          </a:bodyPr>
-          <a:lstStyle/>
-          <a:p>
-            <a:pPr algn="l">
-              <a:lnSpc>
-                <a:spcPct val="110000"/>
-              </a:lnSpc>
-              <a:spcAft>
-                <a:spcPts val="0"/>
-              </a:spcAft>
-            </a:pPr>
-            <a:r>
-              <a:rPr sz="1600" b="0" i="0">
-                <a:solidFill>
-                  <a:srgbClr val="12324A"/>
-                </a:solidFill>
-                <a:latin typeface="Nunito"/>
-              </a:rPr>
-              <a:t>Each sprinkler head waters only the patch that needs it.</a:t>
-            </a:r>
-          </a:p>
-        </p:txBody>
-      </p:sp>
-      <p:sp>
-        <p:nvSpPr>
-          <p:cNvPr id="23" name="TextBox 22"/>
-          <p:cNvSpPr txBox="1"/>
-          <p:nvPr/>
-        </p:nvSpPr>
-        <p:spPr>
-          <a:xfrm>
-            <a:off x="685800" y="6355080"/>
-            <a:ext cx="10789920" cy="365760"/>
-          </a:xfrm>
-          <a:prstGeom prst="rect">
-            <a:avLst/>
-          </a:prstGeom>
-          <a:noFill/>
-        </p:spPr>
-        <p:txBody>
-          <a:bodyPr wrap="square" anchor="t" lIns="18288" rIns="18288" tIns="18288" bIns="18288">
-            <a:noAutofit/>
-          </a:bodyPr>
-          <a:lstStyle/>
-          <a:p>
-            <a:pPr algn="l">
-              <a:spcAft>
-                <a:spcPts val="0"/>
-              </a:spcAft>
-            </a:pPr>
-            <a:r>
-              <a:rPr sz="900" b="0" i="0">
-                <a:solidFill>
-                  <a:srgbClr val="4F6B80"/>
-                </a:solidFill>
-                <a:latin typeface="Nunito"/>
-              </a:rPr>
-              <a:t>Districts already named on the site: Central Utah, Jordan Valley, Weber Basin, Washington County, and the statewide Utah Water Savers program.</a:t>
+              <a:t>overwater.ing</a:t>
             </a:r>
           </a:p>
         </p:txBody>
@@ -13956,6 +12979,134 @@
 </file>
 
 <file path=ppt/slides/slide8.xml><?xml version="1.0" encoding="utf-8"?>
+<p:sld xmlns:a="http://schemas.openxmlformats.org/drawingml/2006/main" xmlns:p="http://schemas.openxmlformats.org/presentationml/2006/main" xmlns:r="http://schemas.openxmlformats.org/officeDocument/2006/relationships">
+  <p:cSld>
+    <p:bg>
+      <p:bgPr>
+        <a:solidFill>
+          <a:srgbClr val="DFF3FD"/>
+        </a:solidFill>
+        <a:effectLst/>
+      </p:bgPr>
+    </p:bg>
+    <p:spTree>
+      <p:nvGrpSpPr>
+        <p:cNvPr id="1" name=""/>
+        <p:cNvGrpSpPr/>
+        <p:nvPr/>
+      </p:nvGrpSpPr>
+      <p:grpSpPr/>
+      <p:sp>
+        <p:nvSpPr>
+          <p:cNvPr id="2" name="TextBox 1"/>
+          <p:cNvSpPr txBox="1"/>
+          <p:nvPr/>
+        </p:nvSpPr>
+        <p:spPr>
+          <a:xfrm>
+            <a:off x="685800" y="2377440"/>
+            <a:ext cx="10789920" cy="1097280"/>
+          </a:xfrm>
+          <a:prstGeom prst="rect">
+            <a:avLst/>
+          </a:prstGeom>
+          <a:noFill/>
+        </p:spPr>
+        <p:txBody>
+          <a:bodyPr wrap="square" anchor="t" lIns="18288" rIns="18288" tIns="18288" bIns="18288">
+            <a:noAutofit/>
+          </a:bodyPr>
+          <a:lstStyle/>
+          <a:p>
+            <a:pPr algn="l">
+              <a:spcAft>
+                <a:spcPts val="0"/>
+              </a:spcAft>
+            </a:pPr>
+            <a:r>
+              <a:rPr sz="4400" b="1" i="0">
+                <a:solidFill>
+                  <a:srgbClr val="12324A"/>
+                </a:solidFill>
+                <a:latin typeface="Fredoka"/>
+              </a:rPr>
+              <a:t>Backup: the demo, step by step</a:t>
+            </a:r>
+          </a:p>
+        </p:txBody>
+      </p:sp>
+      <p:sp>
+        <p:nvSpPr>
+          <p:cNvPr id="3" name="TextBox 2"/>
+          <p:cNvSpPr txBox="1"/>
+          <p:nvPr/>
+        </p:nvSpPr>
+        <p:spPr>
+          <a:xfrm>
+            <a:off x="685800" y="3429000"/>
+            <a:ext cx="10789920" cy="731520"/>
+          </a:xfrm>
+          <a:prstGeom prst="rect">
+            <a:avLst/>
+          </a:prstGeom>
+          <a:noFill/>
+        </p:spPr>
+        <p:txBody>
+          <a:bodyPr wrap="square" anchor="t" lIns="18288" rIns="18288" tIns="18288" bIns="18288">
+            <a:noAutofit/>
+          </a:bodyPr>
+          <a:lstStyle/>
+          <a:p>
+            <a:pPr algn="l">
+              <a:spcAft>
+                <a:spcPts val="0"/>
+              </a:spcAft>
+            </a:pPr>
+            <a:r>
+              <a:rPr sz="2000" b="0" i="0">
+                <a:solidFill>
+                  <a:srgbClr val="4F6B80"/>
+                </a:solidFill>
+                <a:latin typeface="Nunito"/>
+              </a:rPr>
+              <a:t>If the Wi-Fi fails, click through these instead. Same order as the live demo.</a:t>
+            </a:r>
+          </a:p>
+        </p:txBody>
+      </p:sp>
+      <p:pic>
+        <p:nvPicPr>
+          <p:cNvPr id="4" name="Picture 3" descr="sprinkler-off.png"/>
+          <p:cNvPicPr>
+            <a:picLocks noChangeAspect="1"/>
+          </p:cNvPicPr>
+          <p:nvPr/>
+        </p:nvPicPr>
+        <p:blipFill>
+          <a:blip r:embed="rId2"/>
+          <a:stretch>
+            <a:fillRect/>
+          </a:stretch>
+        </p:blipFill>
+        <p:spPr>
+          <a:xfrm>
+            <a:off x="9875520" y="4206240"/>
+            <a:ext cx="1280160" cy="1600200"/>
+          </a:xfrm>
+          <a:prstGeom prst="rect">
+            <a:avLst/>
+          </a:prstGeom>
+        </p:spPr>
+      </p:pic>
+    </p:spTree>
+  </p:cSld>
+  <p:clrMapOvr>
+    <a:masterClrMapping/>
+  </p:clrMapOvr>
+</p:sld>
+</file>
+
+<file path=ppt/slides/slide9.xml><?xml version="1.0" encoding="utf-8"?>
 <p:sld xmlns:a="http://schemas.openxmlformats.org/drawingml/2006/main" xmlns:p="http://schemas.openxmlformats.org/presentationml/2006/main" xmlns:r="http://schemas.openxmlformats.org/officeDocument/2006/relationships">
   <p:cSld>
     <p:bg>
@@ -13973,9 +13124,94 @@
         <p:nvPr/>
       </p:nvGrpSpPr>
       <p:grpSpPr/>
+      <p:sp>
+        <p:nvSpPr>
+          <p:cNvPr id="2" name="TextBox 1"/>
+          <p:cNvSpPr txBox="1"/>
+          <p:nvPr/>
+        </p:nvSpPr>
+        <p:spPr>
+          <a:xfrm>
+            <a:off x="685800" y="365760"/>
+            <a:ext cx="10789920" cy="640080"/>
+          </a:xfrm>
+          <a:prstGeom prst="rect">
+            <a:avLst/>
+          </a:prstGeom>
+          <a:noFill/>
+        </p:spPr>
+        <p:txBody>
+          <a:bodyPr wrap="square" anchor="t" lIns="18288" rIns="18288" tIns="18288" bIns="18288">
+            <a:noAutofit/>
+          </a:bodyPr>
+          <a:lstStyle/>
+          <a:p>
+            <a:pPr algn="l">
+              <a:spcAft>
+                <a:spcPts val="0"/>
+              </a:spcAft>
+            </a:pPr>
+            <a:r>
+              <a:rPr sz="3000" b="1" i="0">
+                <a:solidFill>
+                  <a:srgbClr val="12324A"/>
+                </a:solidFill>
+                <a:latin typeface="Fredoka"/>
+              </a:rPr>
+              <a:t>1 · Enter any Utah address</a:t>
+            </a:r>
+          </a:p>
+        </p:txBody>
+      </p:sp>
+      <p:sp>
+        <p:nvSpPr>
+          <p:cNvPr id="3" name="Rounded Rectangle 2"/>
+          <p:cNvSpPr/>
+          <p:nvPr/>
+        </p:nvSpPr>
+        <p:spPr>
+          <a:xfrm>
+            <a:off x="621792" y="1124712"/>
+            <a:ext cx="7662672" cy="4837176"/>
+          </a:xfrm>
+          <a:prstGeom prst="roundRect">
+            <a:avLst>
+              <a:gd name="adj" fmla="val 3000"/>
+            </a:avLst>
+          </a:prstGeom>
+          <a:solidFill>
+            <a:srgbClr val="FFFFFF"/>
+          </a:solidFill>
+          <a:ln w="25400">
+            <a:solidFill>
+              <a:srgbClr val="CFE6F5"/>
+            </a:solidFill>
+          </a:ln>
+          <a:effectLst/>
+        </p:spPr>
+        <p:style>
+          <a:lnRef idx="1">
+            <a:schemeClr val="accent1"/>
+          </a:lnRef>
+          <a:fillRef idx="3">
+            <a:schemeClr val="accent1"/>
+          </a:fillRef>
+          <a:effectRef idx="2">
+            <a:schemeClr val="accent1"/>
+          </a:effectRef>
+          <a:fontRef idx="minor">
+            <a:schemeClr val="lt1"/>
+          </a:fontRef>
+        </p:style>
+        <p:txBody>
+          <a:bodyPr rtlCol="0" anchor="ctr"/>
+          <a:lstStyle/>
+          <a:p/>
+        </p:txBody>
+      </p:sp>
       <p:pic>
         <p:nvPicPr>
-          <p:cNvPr id="2" name="Picture 1" descr="scene-footer.png"/>
+          <p:cNvPr id="4" name="Picture 3" descr="02-search.jpg"/>
           <p:cNvPicPr>
             <a:picLocks noChangeAspect="1"/>
           </p:cNvPicPr>
@@ -13989,8 +13225,8 @@
         </p:blipFill>
         <p:spPr>
           <a:xfrm>
-            <a:off x="0" y="4622855"/>
-            <a:ext cx="12191695" cy="2235144"/>
+            <a:off x="685800" y="1188720"/>
+            <a:ext cx="7534656" cy="4709160"/>
           </a:xfrm>
           <a:prstGeom prst="rect">
             <a:avLst/>
@@ -13999,167 +13235,53 @@
       </p:pic>
       <p:sp>
         <p:nvSpPr>
-          <p:cNvPr id="3" name="TextBox 2"/>
-          <p:cNvSpPr txBox="1"/>
-          <p:nvPr/>
-        </p:nvSpPr>
-        <p:spPr>
-          <a:xfrm>
-            <a:off x="685800" y="685800"/>
-            <a:ext cx="7315200" cy="365760"/>
-          </a:xfrm>
-          <a:prstGeom prst="rect">
-            <a:avLst/>
-          </a:prstGeom>
-          <a:noFill/>
-        </p:spPr>
-        <p:txBody>
-          <a:bodyPr wrap="square" anchor="t" lIns="18288" rIns="18288" tIns="18288" bIns="18288">
-            <a:noAutofit/>
-          </a:bodyPr>
-          <a:lstStyle/>
-          <a:p>
-            <a:pPr algn="l">
-              <a:spcAft>
-                <a:spcPts val="0"/>
-              </a:spcAft>
-            </a:pPr>
-            <a:r>
-              <a:rPr sz="1400" b="1" i="0">
-                <a:solidFill>
-                  <a:srgbClr val="1F86D6"/>
-                </a:solidFill>
-                <a:latin typeface="Nunito"/>
-              </a:rPr>
-              <a:t>THE ASK</a:t>
-            </a:r>
-          </a:p>
-        </p:txBody>
-      </p:sp>
-      <p:sp>
-        <p:nvSpPr>
-          <p:cNvPr id="4" name="TextBox 3"/>
-          <p:cNvSpPr txBox="1"/>
-          <p:nvPr/>
-        </p:nvSpPr>
-        <p:spPr>
-          <a:xfrm>
-            <a:off x="685800" y="1051560"/>
-            <a:ext cx="7498079" cy="1737360"/>
-          </a:xfrm>
-          <a:prstGeom prst="rect">
-            <a:avLst/>
-          </a:prstGeom>
-          <a:noFill/>
-        </p:spPr>
-        <p:txBody>
-          <a:bodyPr wrap="square" anchor="t" lIns="18288" rIns="18288" tIns="18288" bIns="18288">
-            <a:noAutofit/>
-          </a:bodyPr>
-          <a:lstStyle/>
-          <a:p>
-            <a:pPr algn="l">
-              <a:lnSpc>
-                <a:spcPct val="95000"/>
-              </a:lnSpc>
-              <a:spcAft>
-                <a:spcPts val="0"/>
-              </a:spcAft>
-            </a:pPr>
-            <a:r>
-              <a:rPr sz="4800" b="1" i="0">
-                <a:solidFill>
-                  <a:srgbClr val="12324A"/>
-                </a:solidFill>
-                <a:latin typeface="Fredoka"/>
-              </a:rPr>
-              <a:t>Type your address at overwater.ing</a:t>
-            </a:r>
-          </a:p>
-        </p:txBody>
-      </p:sp>
-      <p:sp>
-        <p:nvSpPr>
-          <p:cNvPr id="5" name="TextBox 4"/>
-          <p:cNvSpPr txBox="1"/>
-          <p:nvPr/>
-        </p:nvSpPr>
-        <p:spPr>
-          <a:xfrm>
-            <a:off x="685800" y="2788920"/>
-            <a:ext cx="7680960" cy="1737360"/>
-          </a:xfrm>
-          <a:prstGeom prst="rect">
-            <a:avLst/>
-          </a:prstGeom>
-          <a:noFill/>
-        </p:spPr>
-        <p:txBody>
-          <a:bodyPr wrap="square" anchor="t" lIns="18288" rIns="18288" tIns="18288" bIns="18288">
-            <a:noAutofit/>
-          </a:bodyPr>
-          <a:lstStyle/>
-          <a:p>
-            <a:pPr algn="l">
-              <a:lnSpc>
-                <a:spcPct val="115000"/>
-              </a:lnSpc>
-              <a:spcAft>
-                <a:spcPts val="800"/>
-              </a:spcAft>
-            </a:pPr>
-            <a:r>
-              <a:rPr sz="2000" b="1" i="0">
-                <a:solidFill>
-                  <a:srgbClr val="1F86D6"/>
-                </a:solidFill>
-                <a:latin typeface="Nunito"/>
-              </a:rPr>
-              <a:t>$10K </a:t>
-            </a:r>
-            <a:r>
-              <a:rPr sz="2000" b="0" i="0">
-                <a:solidFill>
-                  <a:srgbClr val="12324A"/>
-                </a:solidFill>
-                <a:latin typeface="Nunito"/>
-              </a:rPr>
-              <a:t>for phase 2: a pilot that runs real sprinklers.</a:t>
-            </a:r>
-          </a:p>
-          <a:p>
-            <a:pPr algn="l">
-              <a:lnSpc>
-                <a:spcPct val="115000"/>
-              </a:lnSpc>
-              <a:spcAft>
-                <a:spcPts val="800"/>
-              </a:spcAft>
-            </a:pPr>
-            <a:r>
-              <a:rPr sz="2000" b="1" i="0">
-                <a:solidFill>
-                  <a:srgbClr val="1F86D6"/>
-                </a:solidFill>
-                <a:latin typeface="Nunito"/>
-              </a:rPr>
-              <a:t>Intros </a:t>
-            </a:r>
-            <a:r>
-              <a:rPr sz="2000" b="0" i="0">
-                <a:solidFill>
-                  <a:srgbClr val="12324A"/>
-                </a:solidFill>
-                <a:latin typeface="Nunito"/>
-              </a:rPr>
-              <a:t>to Utah's water-wise partners, a district conservation team, and drone training academies for LiDAR scans.</a:t>
-            </a:r>
-          </a:p>
+          <p:cNvPr id="5" name="Rounded Rectangle 4"/>
+          <p:cNvSpPr/>
+          <p:nvPr/>
+        </p:nvSpPr>
+        <p:spPr>
+          <a:xfrm>
+            <a:off x="8531352" y="1124712"/>
+            <a:ext cx="3054096" cy="996836"/>
+          </a:xfrm>
+          <a:prstGeom prst="roundRect">
+            <a:avLst>
+              <a:gd name="adj" fmla="val 3000"/>
+            </a:avLst>
+          </a:prstGeom>
+          <a:solidFill>
+            <a:srgbClr val="FFFFFF"/>
+          </a:solidFill>
+          <a:ln w="25400">
+            <a:solidFill>
+              <a:srgbClr val="CFE6F5"/>
+            </a:solidFill>
+          </a:ln>
+          <a:effectLst/>
+        </p:spPr>
+        <p:style>
+          <a:lnRef idx="1">
+            <a:schemeClr val="accent1"/>
+          </a:lnRef>
+          <a:fillRef idx="3">
+            <a:schemeClr val="accent1"/>
+          </a:fillRef>
+          <a:effectRef idx="2">
+            <a:schemeClr val="accent1"/>
+          </a:effectRef>
+          <a:fontRef idx="minor">
+            <a:schemeClr val="lt1"/>
+          </a:fontRef>
+        </p:style>
+        <p:txBody>
+          <a:bodyPr rtlCol="0" anchor="ctr"/>
+          <a:lstStyle/>
+          <a:p/>
         </p:txBody>
       </p:sp>
       <p:pic>
         <p:nvPicPr>
-          <p:cNvPr id="6" name="Picture 5" descr="qr.png"/>
+          <p:cNvPr id="6" name="Picture 5" descr="flow-1-search.jpg"/>
           <p:cNvPicPr>
             <a:picLocks noChangeAspect="1"/>
           </p:cNvPicPr>
@@ -14173,8 +13295,8 @@
         </p:blipFill>
         <p:spPr>
           <a:xfrm>
-            <a:off x="8915400" y="777240"/>
-            <a:ext cx="2377440" cy="2377440"/>
+            <a:off x="8595360" y="1188720"/>
+            <a:ext cx="2926080" cy="868820"/>
           </a:xfrm>
           <a:prstGeom prst="rect">
             <a:avLst/>
@@ -14189,8 +13311,8 @@
         </p:nvSpPr>
         <p:spPr>
           <a:xfrm>
-            <a:off x="8915400" y="3200400"/>
-            <a:ext cx="2377440" cy="365760"/>
+            <a:off x="8595360" y="2331860"/>
+            <a:ext cx="2926080" cy="3566019"/>
           </a:xfrm>
           <a:prstGeom prst="rect">
             <a:avLst/>
@@ -14203,151 +13325,26 @@
           </a:bodyPr>
           <a:lstStyle/>
           <a:p>
-            <a:pPr algn="ctr">
+            <a:pPr algn="l">
+              <a:lnSpc>
+                <a:spcPct val="115000"/>
+              </a:lnSpc>
               <a:spcAft>
                 <a:spcPts val="0"/>
               </a:spcAft>
             </a:pPr>
             <a:r>
-              <a:rPr sz="1800" b="1" i="0">
+              <a:rPr sz="1400" b="0" i="0">
                 <a:solidFill>
                   <a:srgbClr val="12324A"/>
-                </a:solidFill>
-                <a:latin typeface="Fredoka"/>
-              </a:rPr>
-              <a:t>overwater.ing</a:t>
-            </a:r>
-          </a:p>
-        </p:txBody>
-      </p:sp>
-    </p:spTree>
-  </p:cSld>
-  <p:clrMapOvr>
-    <a:masterClrMapping/>
-  </p:clrMapOvr>
-</p:sld>
-</file>
-
-<file path=ppt/slides/slide9.xml><?xml version="1.0" encoding="utf-8"?>
-<p:sld xmlns:a="http://schemas.openxmlformats.org/drawingml/2006/main" xmlns:p="http://schemas.openxmlformats.org/presentationml/2006/main" xmlns:r="http://schemas.openxmlformats.org/officeDocument/2006/relationships">
-  <p:cSld>
-    <p:bg>
-      <p:bgPr>
-        <a:solidFill>
-          <a:srgbClr val="DFF3FD"/>
-        </a:solidFill>
-        <a:effectLst/>
-      </p:bgPr>
-    </p:bg>
-    <p:spTree>
-      <p:nvGrpSpPr>
-        <p:cNvPr id="1" name=""/>
-        <p:cNvGrpSpPr/>
-        <p:nvPr/>
-      </p:nvGrpSpPr>
-      <p:grpSpPr/>
-      <p:sp>
-        <p:nvSpPr>
-          <p:cNvPr id="2" name="TextBox 1"/>
-          <p:cNvSpPr txBox="1"/>
-          <p:nvPr/>
-        </p:nvSpPr>
-        <p:spPr>
-          <a:xfrm>
-            <a:off x="685800" y="2377440"/>
-            <a:ext cx="10789920" cy="1097280"/>
-          </a:xfrm>
-          <a:prstGeom prst="rect">
-            <a:avLst/>
-          </a:prstGeom>
-          <a:noFill/>
-        </p:spPr>
-        <p:txBody>
-          <a:bodyPr wrap="square" anchor="t" lIns="18288" rIns="18288" tIns="18288" bIns="18288">
-            <a:noAutofit/>
-          </a:bodyPr>
-          <a:lstStyle/>
-          <a:p>
-            <a:pPr algn="l">
-              <a:spcAft>
-                <a:spcPts val="0"/>
-              </a:spcAft>
-            </a:pPr>
-            <a:r>
-              <a:rPr sz="4400" b="1" i="0">
-                <a:solidFill>
-                  <a:srgbClr val="12324A"/>
-                </a:solidFill>
-                <a:latin typeface="Fredoka"/>
-              </a:rPr>
-              <a:t>Backup: the demo, step by step</a:t>
-            </a:r>
-          </a:p>
-        </p:txBody>
-      </p:sp>
-      <p:sp>
-        <p:nvSpPr>
-          <p:cNvPr id="3" name="TextBox 2"/>
-          <p:cNvSpPr txBox="1"/>
-          <p:nvPr/>
-        </p:nvSpPr>
-        <p:spPr>
-          <a:xfrm>
-            <a:off x="685800" y="3429000"/>
-            <a:ext cx="10789920" cy="731520"/>
-          </a:xfrm>
-          <a:prstGeom prst="rect">
-            <a:avLst/>
-          </a:prstGeom>
-          <a:noFill/>
-        </p:spPr>
-        <p:txBody>
-          <a:bodyPr wrap="square" anchor="t" lIns="18288" rIns="18288" tIns="18288" bIns="18288">
-            <a:noAutofit/>
-          </a:bodyPr>
-          <a:lstStyle/>
-          <a:p>
-            <a:pPr algn="l">
-              <a:spcAft>
-                <a:spcPts val="0"/>
-              </a:spcAft>
-            </a:pPr>
-            <a:r>
-              <a:rPr sz="2000" b="0" i="0">
-                <a:solidFill>
-                  <a:srgbClr val="4F6B80"/>
                 </a:solidFill>
                 <a:latin typeface="Nunito"/>
               </a:rPr>
-              <a:t>If the Wi-Fi fails, click through these instead. Same order as the live demo.</a:t>
-            </a:r>
-          </a:p>
-        </p:txBody>
-      </p:sp>
-      <p:pic>
-        <p:nvPicPr>
-          <p:cNvPr id="4" name="Picture 3" descr="sprinkler-off.png"/>
-          <p:cNvPicPr>
-            <a:picLocks noChangeAspect="1"/>
-          </p:cNvPicPr>
-          <p:nvPr/>
-        </p:nvPicPr>
-        <p:blipFill>
-          <a:blip r:embed="rId2"/>
-          <a:stretch>
-            <a:fillRect/>
-          </a:stretch>
-        </p:blipFill>
-        <p:spPr>
-          <a:xfrm>
-            <a:off x="9875520" y="4206240"/>
-            <a:ext cx="1280160" cy="1600200"/>
-          </a:xfrm>
-          <a:prstGeom prst="rect">
-            <a:avLst/>
-          </a:prstGeom>
-        </p:spPr>
-      </p:pic>
+              <a:t>Search covers parcels in all 29 counties.</a:t>
+            </a:r>
+          </a:p>
+        </p:txBody>
+      </p:sp>
     </p:spTree>
   </p:cSld>
   <p:clrMapOvr>

</xml_diff>

<commit_message>
Pitch: hard-tech talking points at the controller step (notes + demo.md)
Co-Authored-By: Claude Opus 5.5 (1M context) <noreply@anthropic.com>
</commit_message>
<xml_diff>
--- a/docs/pitch/overwatering.pptx
+++ b/docs/pitch/overwatering.pptx
@@ -1909,6 +1909,31 @@
           <a:p>
             <a:r>
               <a:t>5 a.m., four short cycles a zone.</a:t>
+            </a:r>
+          </a:p>
+          <a:p>
+            <a:r>
+              <a:t>Hard tech, here: each county's daily weather (gridMET reference evapotranspiration) runs through</a:t>
+            </a:r>
+          </a:p>
+          <a:p>
+            <a:r>
+              <a:t>the FAO-56 turf method to get minutes per zone, cycle-and-soak so it doesn't run off. Every week</a:t>
+            </a:r>
+          </a:p>
+          <a:p>
+            <a:r>
+              <a:t>it's checked against the state's watering guide, which a GitHub Action pushes to our edge</a:t>
+            </a:r>
+          </a:p>
+          <a:p>
+            <a:r>
+              <a:t>database. It's one open JSON API, and the connectors write it to OpenSprinkler's local API,</a:t>
+            </a:r>
+          </a:p>
+          <a:p>
+            <a:r>
+              <a:t>Rachio's seasonal adjustment, or Home Assistant, which reaches Rain Bird, Hydrawise and B-hyve.</a:t>
             </a:r>
           </a:p>
           <a:p>

</xml_diff>

<commit_message>
Pitch deck: link the public GitHub repo on the title and ask slides
Co-Authored-By: Claude Opus 5.5 (1M context) <noreply@anthropic.com>
</commit_message>
<xml_diff>
--- a/docs/pitch/overwatering.pptx
+++ b/docs/pitch/overwatering.pptx
@@ -528,7 +528,7 @@
           </a:p>
           <a:p>
             <a:r>
-              <a:t>Hi, I'm Adam Fortuna. This is Overwater.ing. Question mark.</a:t>
+              <a:t>Hi, I'm Adam Fortuna. This is Overwater.ing. Question mark. And it's all open source.</a:t>
             </a:r>
           </a:p>
         </p:txBody>
@@ -5534,6 +5534,55 @@
           </a:p>
         </p:txBody>
       </p:sp>
+      <p:sp>
+        <p:nvSpPr>
+          <p:cNvPr id="8" name="TextBox 7"/>
+          <p:cNvSpPr txBox="1"/>
+          <p:nvPr/>
+        </p:nvSpPr>
+        <p:spPr>
+          <a:xfrm>
+            <a:off x="685800" y="6108192"/>
+            <a:ext cx="5852160" cy="365760"/>
+          </a:xfrm>
+          <a:prstGeom prst="rect">
+            <a:avLst/>
+          </a:prstGeom>
+          <a:noFill/>
+        </p:spPr>
+        <p:txBody>
+          <a:bodyPr wrap="square" anchor="t" lIns="18288" rIns="18288" tIns="18288" bIns="18288">
+            <a:noAutofit/>
+          </a:bodyPr>
+          <a:lstStyle/>
+          <a:p>
+            <a:pPr algn="l">
+              <a:spcAft>
+                <a:spcPts val="0"/>
+              </a:spcAft>
+            </a:pPr>
+            <a:r>
+              <a:rPr sz="1500" b="1" i="0">
+                <a:solidFill>
+                  <a:srgbClr val="4F6B80"/>
+                </a:solidFill>
+                <a:latin typeface="Nunito"/>
+              </a:rPr>
+              <a:t>Open source: </a:t>
+            </a:r>
+            <a:r>
+              <a:rPr sz="1500" b="0" i="0">
+                <a:solidFill>
+                  <a:srgbClr val="1F86D6"/>
+                </a:solidFill>
+                <a:latin typeface="Nunito"/>
+                <a:hlinkClick r:id="rId4"/>
+              </a:rPr>
+              <a:t>github.com/adamfortuna/overwatering</a:t>
+            </a:r>
+          </a:p>
+        </p:txBody>
+      </p:sp>
     </p:spTree>
   </p:cSld>
   <p:clrMapOvr>
@@ -12991,6 +13040,68 @@
                 <a:latin typeface="Fredoka"/>
               </a:rPr>
               <a:t>overwater.ing</a:t>
+            </a:r>
+          </a:p>
+        </p:txBody>
+      </p:sp>
+      <p:sp>
+        <p:nvSpPr>
+          <p:cNvPr id="8" name="TextBox 7"/>
+          <p:cNvSpPr txBox="1"/>
+          <p:nvPr/>
+        </p:nvSpPr>
+        <p:spPr>
+          <a:xfrm>
+            <a:off x="8275320" y="3611880"/>
+            <a:ext cx="3657600" cy="640080"/>
+          </a:xfrm>
+          <a:prstGeom prst="rect">
+            <a:avLst/>
+          </a:prstGeom>
+          <a:noFill/>
+        </p:spPr>
+        <p:txBody>
+          <a:bodyPr wrap="square" anchor="t" lIns="18288" rIns="18288" tIns="18288" bIns="18288">
+            <a:noAutofit/>
+          </a:bodyPr>
+          <a:lstStyle/>
+          <a:p>
+            <a:pPr algn="ctr">
+              <a:lnSpc>
+                <a:spcPct val="110000"/>
+              </a:lnSpc>
+              <a:spcAft>
+                <a:spcPts val="0"/>
+              </a:spcAft>
+            </a:pPr>
+            <a:r>
+              <a:rPr sz="1300" b="1" i="0">
+                <a:solidFill>
+                  <a:srgbClr val="4F6B80"/>
+                </a:solidFill>
+                <a:latin typeface="Nunito"/>
+              </a:rPr>
+              <a:t>Open source</a:t>
+            </a:r>
+          </a:p>
+          <a:p>
+            <a:pPr algn="ctr">
+              <a:lnSpc>
+                <a:spcPct val="110000"/>
+              </a:lnSpc>
+              <a:spcAft>
+                <a:spcPts val="0"/>
+              </a:spcAft>
+            </a:pPr>
+            <a:r>
+              <a:rPr sz="1300" b="0" i="0">
+                <a:solidFill>
+                  <a:srgbClr val="1F86D6"/>
+                </a:solidFill>
+                <a:latin typeface="Nunito"/>
+                <a:hlinkClick r:id="rId4"/>
+              </a:rPr>
+              <a:t>github.com/adamfortuna/overwatering</a:t>
             </a:r>
           </a:p>
         </p:txBody>

</xml_diff>